<commit_message>
GrowOn: beldag op gemeten capaciteit van 120 pogingen in plaats van 100
De urenexport van week 41 laat zien wat een volle dag echt oplevert: 159 tot
206 contactpogingen bij 8 betaalde uur, oftewel 20 tot 27 per uur. Zes uur
bellen komt daarmee op ongeveer 120 pogingen uit, niet op 100.

- beldag: 120 pogingen, 70 gesproken, target blijft bewust op 2 afspraken
  terwijl het rendement uit de pilot op 2,4 per beldag uitkomt
- vergelijking: prijs per beldag erbij, nu ongeveer 460 euro tegen 600 in het
  voorstel en 500 bij acht beldagen
- staffel: toelichting op 120 pogingen per beldag en de marge in het target

Co-Authored-By: Claude Opus 5 <noreply@anthropic.com>
Claude-Session: https://claude.ai/code/session_0141FN3f3hHkYQHTyvTJJGrw
</commit_message>
<xml_diff>
--- a/output/LINK. voorstel GrowOn Agency.pptx
+++ b/output/LINK. voorstel GrowOn Agency.pptx
@@ -4995,7 +4995,7 @@
                 <a:ea typeface="Arial" pitchFamily="34" charset="-122"/>
                 <a:cs typeface="Arial" pitchFamily="34" charset="-120"/>
               </a:rPr>
-              <a:t>± 4</a:t>
+              <a:t>± 3,5</a:t>
             </a:r>
             <a:endParaRPr lang="en-US" sz="1150" dirty="0"/>
           </a:p>
@@ -5057,7 +5057,7 @@
                 <a:ea typeface="Arial" pitchFamily="34" charset="-122"/>
                 <a:cs typeface="Arial" pitchFamily="34" charset="-120"/>
               </a:rPr>
-              <a:t>Uur bellen</a:t>
+              <a:t>Contactpogingen</a:t>
             </a:r>
             <a:endParaRPr lang="en-US" sz="950" dirty="0"/>
           </a:p>
@@ -5096,7 +5096,7 @@
                 <a:ea typeface="Arial" pitchFamily="34" charset="-122"/>
                 <a:cs typeface="Arial" pitchFamily="34" charset="-120"/>
               </a:rPr>
-              <a:t>± 24</a:t>
+              <a:t>± 400</a:t>
             </a:r>
             <a:endParaRPr lang="en-US" sz="1150" dirty="0"/>
           </a:p>
@@ -5158,7 +5158,7 @@
                 <a:ea typeface="Arial" pitchFamily="34" charset="-122"/>
                 <a:cs typeface="Arial" pitchFamily="34" charset="-120"/>
               </a:rPr>
-              <a:t>Contactpogingen</a:t>
+              <a:t>Afspraken</a:t>
             </a:r>
             <a:endParaRPr lang="en-US" sz="950" dirty="0"/>
           </a:p>
@@ -5197,7 +5197,7 @@
                 <a:ea typeface="Arial" pitchFamily="34" charset="-122"/>
                 <a:cs typeface="Arial" pitchFamily="34" charset="-120"/>
               </a:rPr>
-              <a:t>± 400</a:t>
+              <a:t>± 8</a:t>
             </a:r>
             <a:endParaRPr lang="en-US" sz="1150" dirty="0"/>
           </a:p>
@@ -5259,7 +5259,7 @@
                 <a:ea typeface="Arial" pitchFamily="34" charset="-122"/>
                 <a:cs typeface="Arial" pitchFamily="34" charset="-120"/>
               </a:rPr>
-              <a:t>Afspraken</a:t>
+              <a:t>Prijs per beldag</a:t>
             </a:r>
             <a:endParaRPr lang="en-US" sz="950" dirty="0"/>
           </a:p>
@@ -5298,7 +5298,7 @@
                 <a:ea typeface="Arial" pitchFamily="34" charset="-122"/>
                 <a:cs typeface="Arial" pitchFamily="34" charset="-120"/>
               </a:rPr>
-              <a:t>± 8</a:t>
+              <a:t>± € 460</a:t>
             </a:r>
             <a:endParaRPr lang="en-US" sz="1150" dirty="0"/>
           </a:p>
@@ -5642,7 +5642,7 @@
                 <a:ea typeface="Arial" pitchFamily="34" charset="-122"/>
                 <a:cs typeface="Arial" pitchFamily="34" charset="-120"/>
               </a:rPr>
-              <a:t>Uur bellen</a:t>
+              <a:t>Contactpogingen</a:t>
             </a:r>
             <a:endParaRPr lang="en-US" sz="950" dirty="0"/>
           </a:p>
@@ -5681,7 +5681,7 @@
                 <a:ea typeface="Arial" pitchFamily="34" charset="-122"/>
                 <a:cs typeface="Arial" pitchFamily="34" charset="-120"/>
               </a:rPr>
-              <a:t>24</a:t>
+              <a:t>± 480</a:t>
             </a:r>
             <a:endParaRPr lang="en-US" sz="1150" dirty="0"/>
           </a:p>
@@ -5743,7 +5743,7 @@
                 <a:ea typeface="Arial" pitchFamily="34" charset="-122"/>
                 <a:cs typeface="Arial" pitchFamily="34" charset="-120"/>
               </a:rPr>
-              <a:t>Contactpogingen</a:t>
+              <a:t>Afspraken</a:t>
             </a:r>
             <a:endParaRPr lang="en-US" sz="950" dirty="0"/>
           </a:p>
@@ -5782,7 +5782,7 @@
                 <a:ea typeface="Arial" pitchFamily="34" charset="-122"/>
                 <a:cs typeface="Arial" pitchFamily="34" charset="-120"/>
               </a:rPr>
-              <a:t>± 400</a:t>
+              <a:t>± 8</a:t>
             </a:r>
             <a:endParaRPr lang="en-US" sz="1150" dirty="0"/>
           </a:p>
@@ -5844,7 +5844,7 @@
                 <a:ea typeface="Arial" pitchFamily="34" charset="-122"/>
                 <a:cs typeface="Arial" pitchFamily="34" charset="-120"/>
               </a:rPr>
-              <a:t>Afspraken</a:t>
+              <a:t>Prijs per beldag</a:t>
             </a:r>
             <a:endParaRPr lang="en-US" sz="950" dirty="0"/>
           </a:p>
@@ -5883,7 +5883,7 @@
                 <a:ea typeface="Arial" pitchFamily="34" charset="-122"/>
                 <a:cs typeface="Arial" pitchFamily="34" charset="-120"/>
               </a:rPr>
-              <a:t>± 8</a:t>
+              <a:t>€ 600</a:t>
             </a:r>
             <a:endParaRPr lang="en-US" sz="1150" dirty="0"/>
           </a:p>
@@ -6227,7 +6227,7 @@
                 <a:ea typeface="Arial" pitchFamily="34" charset="-122"/>
                 <a:cs typeface="Arial" pitchFamily="34" charset="-120"/>
               </a:rPr>
-              <a:t>Uur bellen</a:t>
+              <a:t>Contactpogingen</a:t>
             </a:r>
             <a:endParaRPr lang="en-US" sz="950" dirty="0"/>
           </a:p>
@@ -6266,7 +6266,7 @@
                 <a:ea typeface="Arial" pitchFamily="34" charset="-122"/>
                 <a:cs typeface="Arial" pitchFamily="34" charset="-120"/>
               </a:rPr>
-              <a:t>48</a:t>
+              <a:t>± 960</a:t>
             </a:r>
             <a:endParaRPr lang="en-US" sz="1150" dirty="0"/>
           </a:p>
@@ -6328,7 +6328,7 @@
                 <a:ea typeface="Arial" pitchFamily="34" charset="-122"/>
                 <a:cs typeface="Arial" pitchFamily="34" charset="-120"/>
               </a:rPr>
-              <a:t>Contactpogingen</a:t>
+              <a:t>Afspraken</a:t>
             </a:r>
             <a:endParaRPr lang="en-US" sz="950" dirty="0"/>
           </a:p>
@@ -6367,7 +6367,7 @@
                 <a:ea typeface="Arial" pitchFamily="34" charset="-122"/>
                 <a:cs typeface="Arial" pitchFamily="34" charset="-120"/>
               </a:rPr>
-              <a:t>± 800</a:t>
+              <a:t>± 16</a:t>
             </a:r>
             <a:endParaRPr lang="en-US" sz="1150" dirty="0"/>
           </a:p>
@@ -6429,7 +6429,7 @@
                 <a:ea typeface="Arial" pitchFamily="34" charset="-122"/>
                 <a:cs typeface="Arial" pitchFamily="34" charset="-120"/>
               </a:rPr>
-              <a:t>Afspraken</a:t>
+              <a:t>Prijs per beldag</a:t>
             </a:r>
             <a:endParaRPr lang="en-US" sz="950" dirty="0"/>
           </a:p>
@@ -6468,7 +6468,7 @@
                 <a:ea typeface="Arial" pitchFamily="34" charset="-122"/>
                 <a:cs typeface="Arial" pitchFamily="34" charset="-120"/>
               </a:rPr>
-              <a:t>± 16</a:t>
+              <a:t>€ 500</a:t>
             </a:r>
             <a:endParaRPr lang="en-US" sz="1150" dirty="0"/>
           </a:p>
@@ -6628,7 +6628,7 @@
                 <a:ea typeface="Arial" pitchFamily="34" charset="-122"/>
                 <a:cs typeface="Arial" pitchFamily="34" charset="-120"/>
               </a:rPr>
-              <a:t>In de pilot betaalde je het minst per afspraak, omdat de pilotprijs onder onze dagprijs lag. Bij acht beldagen zakt de prijs per afspraak terug naar ongeveer tweehonderdvijftig euro.</a:t>
+              <a:t>Je koopt nu ongeveer drieënhalve beldag per werkperiode. Vanaf vier beldagen gaat het volume met twintig procent omhoog, bij acht beldagen verdubbelt het en zakt de dagprijs naar vijfhonderd euro.</a:t>
             </a:r>
             <a:endParaRPr lang="en-US" sz="1200" dirty="0"/>
           </a:p>
@@ -15886,7 +15886,7 @@
                 <a:ea typeface="Arial" pitchFamily="34" charset="-122"/>
                 <a:cs typeface="Arial" pitchFamily="34" charset="-120"/>
               </a:rPr>
-              <a:t>± 100</a:t>
+              <a:t>± 120</a:t>
             </a:r>
             <a:endParaRPr lang="en-US" sz="3600" dirty="0"/>
           </a:p>
@@ -15967,7 +15967,7 @@
                 <a:ea typeface="Arial" pitchFamily="34" charset="-122"/>
                 <a:cs typeface="Arial" pitchFamily="34" charset="-120"/>
               </a:rPr>
-              <a:t>Ongeveer zeventien pogingen per uur bellen, gemeten over jullie hele pilot.</a:t>
+              <a:t>Onze bellers draaien twintig tot zevenentwintig pogingen per uur. Gemeten in onze eigen urenregistratie.</a:t>
             </a:r>
             <a:endParaRPr lang="en-US" sz="950" dirty="0"/>
           </a:p>
@@ -16028,7 +16028,7 @@
                 <a:ea typeface="Arial" pitchFamily="34" charset="-122"/>
                 <a:cs typeface="Arial" pitchFamily="34" charset="-120"/>
               </a:rPr>
-              <a:t>± 60</a:t>
+              <a:t>± 70</a:t>
             </a:r>
             <a:endParaRPr lang="en-US" sz="3600" dirty="0"/>
           </a:p>
@@ -16251,7 +16251,7 @@
                 <a:ea typeface="Arial" pitchFamily="34" charset="-122"/>
                 <a:cs typeface="Arial" pitchFamily="34" charset="-120"/>
               </a:rPr>
-              <a:t>Vierentwintig afspraken over ruim twaalf beldagen. Dit is het getal waar we op sturen.</a:t>
+              <a:t>Met het rendement uit jullie pilot komt een beldag op 2,4 uit. Wij rekenen bewust met twee.</a:t>
             </a:r>
             <a:endParaRPr lang="en-US" sz="950" dirty="0"/>
           </a:p>
@@ -16310,7 +16310,7 @@
                 <a:ea typeface="Arial" pitchFamily="34" charset="-122"/>
                 <a:cs typeface="Arial" pitchFamily="34" charset="-120"/>
               </a:rPr>
-              <a:t>Wij rekenen in beldagen en niet in uren, omdat een uur niets zegt over wat eruit komt. Een beldag is dit rijtje, elke periode opnieuw.</a:t>
+              <a:t>Wij rekenen in beldagen en niet in uren, omdat een uur niets zegt over wat eruit komt. Deze aantallen komen uit onze eigen urenregistratie en uit jullie pilot.</a:t>
             </a:r>
             <a:endParaRPr lang="en-US" sz="1200" dirty="0"/>
           </a:p>
@@ -17386,7 +17386,7 @@
                 <a:ea typeface="Arial" pitchFamily="34" charset="-122"/>
                 <a:cs typeface="Arial" pitchFamily="34" charset="-120"/>
               </a:rPr>
-              <a:t>De verwachte aantallen zijn een indicatie, gebaseerd op twee gekwalificeerde afspraken per beldag uit jullie eigen pilot. Minimaal vier beldagen per periode, prijzen excl. btw.</a:t>
+              <a:t>De verwachte aantallen gaan uit van honderdtwintig contactpogingen en twee gekwalificeerde afspraken per beldag. In jullie pilot lag dat rendement op 2,4 per beldag, dus we rekenen met een marge. Minimaal vier beldagen per periode, prijzen excl. btw.</a:t>
             </a:r>
             <a:endParaRPr lang="en-US" sz="1200" dirty="0"/>
           </a:p>

</xml_diff>

<commit_message>
GrowOn: staffelbodem naar 550 euro per beldag
Bij 36 euro uurloon en 50 euro bonus is de kostprijs 341 per beldag. De oude
bodem van 500 liet daar te weinig van over.

Co-Authored-By: Claude Opus 5 <noreply@anthropic.com>
Claude-Session: https://claude.ai/code/session_0141FN3f3hHkYQHTyvTJJGrw
</commit_message>
<xml_diff>
--- a/output/LINK. voorstel GrowOn Agency.pptx
+++ b/output/LINK. voorstel GrowOn Agency.pptx
@@ -3855,7 +3855,7 @@
                 <a:ea typeface="Arial" pitchFamily="34" charset="-122"/>
                 <a:cs typeface="Arial" pitchFamily="34" charset="-120"/>
               </a:rPr>
-              <a:t>€ 550</a:t>
+              <a:t>€ 575</a:t>
             </a:r>
             <a:endParaRPr lang="en-US" sz="1250" dirty="0"/>
           </a:p>
@@ -3894,7 +3894,7 @@
                 <a:ea typeface="Arial" pitchFamily="34" charset="-122"/>
                 <a:cs typeface="Arial" pitchFamily="34" charset="-120"/>
               </a:rPr>
-              <a:t>€ 2.750 tot € 3.850</a:t>
+              <a:t>€ 2.875 tot € 4.025</a:t>
             </a:r>
             <a:endParaRPr lang="en-US" sz="1250" dirty="0"/>
           </a:p>
@@ -4056,7 +4056,7 @@
                 <a:ea typeface="Arial" pitchFamily="34" charset="-122"/>
                 <a:cs typeface="Arial" pitchFamily="34" charset="-120"/>
               </a:rPr>
-              <a:t>€ 500</a:t>
+              <a:t>€ 550</a:t>
             </a:r>
             <a:endParaRPr lang="en-US" sz="1250" dirty="0"/>
           </a:p>
@@ -4095,7 +4095,7 @@
                 <a:ea typeface="Arial" pitchFamily="34" charset="-122"/>
                 <a:cs typeface="Arial" pitchFamily="34" charset="-120"/>
               </a:rPr>
-              <a:t>vanaf € 4.000</a:t>
+              <a:t>vanaf € 4.400</a:t>
             </a:r>
             <a:endParaRPr lang="en-US" sz="1250" dirty="0"/>
           </a:p>
@@ -5159,7 +5159,7 @@
                 <a:ea typeface="Arial" pitchFamily="34" charset="-122"/>
                 <a:cs typeface="Arial" pitchFamily="34" charset="-120"/>
               </a:rPr>
-              <a:t>De dagprijs zakt van 600 naar 500 euro bij acht beldagen. Daarmee kom je op dezelfde prijs per afspraak als in de pilot, met tweeënhalf keer zoveel afspraken.</a:t>
+              <a:t>De dagprijs zakt van 600 naar 550 euro bij acht beldagen. Daarmee gaat de prijs per afspraak van 240 naar 220 euro, met twee keer zoveel afspraken.</a:t>
             </a:r>
             <a:endParaRPr lang="en-US" sz="875" dirty="0"/>
           </a:p>
@@ -5298,7 +5298,7 @@
                 <a:ea typeface="Arial" pitchFamily="34" charset="-122"/>
                 <a:cs typeface="Arial" pitchFamily="34" charset="-120"/>
               </a:rPr>
-              <a:t>vanaf 8 beldagen € 500, excl. btw</a:t>
+              <a:t>vanaf 8 beldagen € 550, excl. btw</a:t>
             </a:r>
             <a:endParaRPr lang="en-US" sz="800" dirty="0"/>
           </a:p>
@@ -7633,7 +7633,7 @@
                 <a:ea typeface="Arial" pitchFamily="34" charset="-122"/>
                 <a:cs typeface="Arial" pitchFamily="34" charset="-120"/>
               </a:rPr>
-              <a:t>€ 500</a:t>
+              <a:t>€ 550</a:t>
             </a:r>
             <a:endParaRPr lang="en-US" sz="1150" dirty="0"/>
           </a:p>
@@ -7734,7 +7734,7 @@
                 <a:ea typeface="Arial" pitchFamily="34" charset="-122"/>
                 <a:cs typeface="Arial" pitchFamily="34" charset="-120"/>
               </a:rPr>
-              <a:t>± € 200</a:t>
+              <a:t>± € 220</a:t>
             </a:r>
             <a:endParaRPr lang="en-US" sz="1150" dirty="0"/>
           </a:p>
@@ -7793,7 +7793,7 @@
                 <a:ea typeface="Arial" pitchFamily="34" charset="-122"/>
                 <a:cs typeface="Arial" pitchFamily="34" charset="-120"/>
               </a:rPr>
-              <a:t>Je betaalt nu al bijna zeshonderd euro per beldag, alleen koop je er maar bijna drie per periode. Bij acht beldagen betaal je dezelfde prijs per afspraak als nu, met tweeënhalf keer zoveel afspraken.</a:t>
+              <a:t>Je betaalt nu al bijna zeshonderd euro per beldag, alleen koop je er maar bijna drie per periode. Bij acht beldagen zakt de dagprijs naar 550 euro en de prijs per afspraak naar 220, met twee keer zoveel afspraken.</a:t>
             </a:r>
             <a:endParaRPr lang="en-US" sz="1200" dirty="0"/>
           </a:p>

</xml_diff>

<commit_message>
GrowOn: er verandert weinig, met gratis beldag en opschalen naar 550
- cover en vergelijking herschreven rond continuiteit: zelfde team en lijst,
  vanaf werkperiode 4 beldagen met harde aantallen
- vergelijking toont nu, vier beldagen en acht beldagen naast elkaar, met de
  dagprijs die van 600 naar 550 zakt bij verdubbeling
- doorbellen vervangen door een gratis beldag bij minder dan tien afspraken

Co-Authored-By: Claude Opus 5 <noreply@anthropic.com>
Claude-Session: https://claude.ai/code/session_0141FN3f3hHkYQHTyvTJJGrw
</commit_message>
<xml_diff>
--- a/output/LINK. voorstel GrowOn Agency.pptx
+++ b/output/LINK. voorstel GrowOn Agency.pptx
@@ -2964,7 +2964,7 @@
                 <a:ea typeface="Arial" pitchFamily="34" charset="-122"/>
                 <a:cs typeface="Arial" pitchFamily="34" charset="-120"/>
               </a:rPr>
-              <a:t>Twaalf weken bellen zit erop. In deze presentatie staat wat het heeft opgeleverd, wat we onderweg hebben geleerd en hoe we het vanaf november willen inrichten.</a:t>
+              <a:t>Er verandert weinig. Zelfde team, zelfde bellijst en dezelfde wekelijkse rapportage. Vanaf werkperiode 4 rekenen we in beldagen, met harde aantallen en een scherpere afspraak over wat een afspraak is.</a:t>
             </a:r>
             <a:endParaRPr lang="en-US" sz="1400" dirty="0"/>
           </a:p>
@@ -4945,7 +4945,7 @@
                 <a:ea typeface="Arial" pitchFamily="34" charset="-122"/>
                 <a:cs typeface="Arial" pitchFamily="34" charset="-120"/>
               </a:rPr>
-              <a:t>Niet gehaald, dan bellen we door</a:t>
+              <a:t>Niet gehaald is een gratis beldag</a:t>
             </a:r>
             <a:endParaRPr lang="en-US" sz="1150" dirty="0"/>
           </a:p>
@@ -4987,7 +4987,7 @@
                 <a:ea typeface="Arial" pitchFamily="34" charset="-122"/>
                 <a:cs typeface="Arial" pitchFamily="34" charset="-120"/>
               </a:rPr>
-              <a:t>Blijft een werkperiode onder de KPI's, dan bellen we in de volgende periode door tot het aantal er staat. Zonder extra factuur.</a:t>
+              <a:t>Komt een werkperiode onder de tien afspraken, dan bellen we de volgende periode een dag extra die niet op de rekening komt.</a:t>
             </a:r>
             <a:endParaRPr lang="en-US" sz="875" dirty="0"/>
           </a:p>
@@ -5117,7 +5117,7 @@
                 <a:ea typeface="Arial" pitchFamily="34" charset="-122"/>
                 <a:cs typeface="Arial" pitchFamily="34" charset="-120"/>
               </a:rPr>
-              <a:t>Goedkoper naarmate je langer blijft</a:t>
+              <a:t>Elke periode opnieuw kiezen</a:t>
             </a:r>
             <a:endParaRPr lang="en-US" sz="1150" dirty="0"/>
           </a:p>
@@ -5159,7 +5159,7 @@
                 <a:ea typeface="Arial" pitchFamily="34" charset="-122"/>
                 <a:cs typeface="Arial" pitchFamily="34" charset="-120"/>
               </a:rPr>
-              <a:t>De dagprijs zakt van 600 naar 550 euro bij acht beldagen. Daarmee gaat de prijs per afspraak van 240 naar 220 euro, met twee keer zoveel afspraken.</a:t>
+              <a:t>Jullie bepalen per werkperiode het aantal beldagen, vanaf vier. Een maand opzegtermijn, geen jaarcontract en geen opstartkosten meer.</a:t>
             </a:r>
             <a:endParaRPr lang="en-US" sz="875" dirty="0"/>
           </a:p>
@@ -5575,7 +5575,7 @@
                 <a:ea typeface="Arial" pitchFamily="34" charset="-122"/>
                 <a:cs typeface="Arial" pitchFamily="34" charset="-120"/>
               </a:rPr>
-              <a:t>2,5 gekwalificeerde afspraken per beldag</a:t>
+              <a:t>10 gekwalificeerde afspraken per periode</a:t>
             </a:r>
             <a:endParaRPr lang="en-US" sz="900" dirty="0"/>
           </a:p>
@@ -5638,7 +5638,7 @@
                 <a:ea typeface="Arial" pitchFamily="34" charset="-122"/>
                 <a:cs typeface="Arial" pitchFamily="34" charset="-120"/>
               </a:rPr>
-              <a:t>Niet gehaald is doorbellen zonder factuur</a:t>
+              <a:t>Niet gehaald is een gratis beldag</a:t>
             </a:r>
             <a:endParaRPr lang="en-US" sz="900" dirty="0"/>
           </a:p>
@@ -5903,7 +5903,7 @@
                 <a:ea typeface="Arial" pitchFamily="34" charset="-122"/>
                 <a:cs typeface="Arial" pitchFamily="34" charset="-120"/>
               </a:rPr>
-              <a:t>OPSCHALEN</a:t>
+              <a:t>WAT ER VERANDERT</a:t>
             </a:r>
             <a:endParaRPr lang="en-US" sz="950" dirty="0"/>
           </a:p>
@@ -5945,7 +5945,7 @@
                 <a:ea typeface="Arial" pitchFamily="34" charset="-122"/>
                 <a:cs typeface="Arial" pitchFamily="34" charset="-120"/>
               </a:rPr>
-              <a:t>Hetzelfde ritme, of </a:t>
+              <a:t>Hetzelfde werk, nu met </a:t>
             </a:r>
             <a:pPr algn="l" indent="0" marL="0">
               <a:lnSpc>
@@ -5962,7 +5962,7 @@
                 <a:ea typeface="Georgia" pitchFamily="34" charset="-122"/>
                 <a:cs typeface="Georgia" pitchFamily="34" charset="-120"/>
               </a:rPr>
-              <a:t>twee keer zoveel</a:t>
+              <a:t>harde aantallen</a:t>
             </a:r>
             <a:pPr algn="l" indent="0" marL="0">
               <a:lnSpc>
@@ -6082,7 +6082,7 @@
                 <a:ea typeface="Arial" pitchFamily="34" charset="-122"/>
                 <a:cs typeface="Arial" pitchFamily="34" charset="-120"/>
               </a:rPr>
-              <a:t>€ 1.600 per werkperiode</a:t>
+              <a:t>Zoals het de afgelopen twaalf weken liep</a:t>
             </a:r>
             <a:endParaRPr lang="en-US" sz="1250" dirty="0"/>
           </a:p>
@@ -6121,7 +6121,7 @@
                 <a:ea typeface="Arial" pitchFamily="34" charset="-122"/>
                 <a:cs typeface="Arial" pitchFamily="34" charset="-120"/>
               </a:rPr>
-              <a:t>Beldagen</a:t>
+              <a:t>Beldagen per periode</a:t>
             </a:r>
             <a:endParaRPr lang="en-US" sz="950" dirty="0"/>
           </a:p>
@@ -6323,7 +6323,7 @@
                 <a:ea typeface="Arial" pitchFamily="34" charset="-122"/>
                 <a:cs typeface="Arial" pitchFamily="34" charset="-120"/>
               </a:rPr>
-              <a:t>Afspraken</a:t>
+              <a:t>Gekwalificeerde afspraken</a:t>
             </a:r>
             <a:endParaRPr lang="en-US" sz="950" dirty="0"/>
           </a:p>
@@ -6463,7 +6463,7 @@
                 <a:ea typeface="Arial" pitchFamily="34" charset="-122"/>
                 <a:cs typeface="Arial" pitchFamily="34" charset="-120"/>
               </a:rPr>
-              <a:t>± € 590</a:t>
+              <a:t>± € 593</a:t>
             </a:r>
             <a:endParaRPr lang="en-US" sz="1150" dirty="0"/>
           </a:p>
@@ -6525,7 +6525,7 @@
                 <a:ea typeface="Arial" pitchFamily="34" charset="-122"/>
                 <a:cs typeface="Arial" pitchFamily="34" charset="-120"/>
               </a:rPr>
-              <a:t>Prijs per afspraak</a:t>
+              <a:t>Prijs per werkperiode</a:t>
             </a:r>
             <a:endParaRPr lang="en-US" sz="950" dirty="0"/>
           </a:p>
@@ -6564,7 +6564,7 @@
                 <a:ea typeface="Arial" pitchFamily="34" charset="-122"/>
                 <a:cs typeface="Arial" pitchFamily="34" charset="-120"/>
               </a:rPr>
-              <a:t>± € 200</a:t>
+              <a:t>€ 1.600</a:t>
             </a:r>
             <a:endParaRPr lang="en-US" sz="1150" dirty="0"/>
           </a:p>
@@ -6587,7 +6587,7 @@
             </a:avLst>
           </a:prstGeom>
           <a:solidFill>
-            <a:srgbClr val="F8F4EB"/>
+            <a:srgbClr val="000000"/>
           </a:solidFill>
           <a:ln/>
         </p:spPr>
@@ -6619,13 +6619,13 @@
             <a:r>
               <a:rPr lang="en-US" sz="800" b="1" spc="180" kern="0" dirty="0">
                 <a:solidFill>
-                  <a:srgbClr val="6F6A5C"/>
-                </a:solidFill>
-                <a:latin typeface="Arial" pitchFamily="34" charset="0"/>
-                <a:ea typeface="Arial" pitchFamily="34" charset="-122"/>
-                <a:cs typeface="Arial" pitchFamily="34" charset="-120"/>
-              </a:rPr>
-              <a:t>VOORSTEL</a:t>
+                  <a:srgbClr val="38B6FF"/>
+                </a:solidFill>
+                <a:latin typeface="Arial" pitchFamily="34" charset="0"/>
+                <a:ea typeface="Arial" pitchFamily="34" charset="-122"/>
+                <a:cs typeface="Arial" pitchFamily="34" charset="-120"/>
+              </a:rPr>
+              <a:t>VANAF WERKPERIODE 4</a:t>
             </a:r>
             <a:endParaRPr lang="en-US" sz="800" dirty="0"/>
           </a:p>
@@ -6661,13 +6661,13 @@
             <a:r>
               <a:rPr lang="en-US" sz="1250" b="1" dirty="0">
                 <a:solidFill>
-                  <a:srgbClr val="1C2230"/>
-                </a:solidFill>
-                <a:latin typeface="Arial" pitchFamily="34" charset="0"/>
-                <a:ea typeface="Arial" pitchFamily="34" charset="-122"/>
-                <a:cs typeface="Arial" pitchFamily="34" charset="-120"/>
-              </a:rPr>
-              <a:t>4 beldagen per werkperiode</a:t>
+                  <a:srgbClr val="F2EFE6"/>
+                </a:solidFill>
+                <a:latin typeface="Arial" pitchFamily="34" charset="0"/>
+                <a:ea typeface="Arial" pitchFamily="34" charset="-122"/>
+                <a:cs typeface="Arial" pitchFamily="34" charset="-120"/>
+              </a:rPr>
+              <a:t>Vier beldagen per vier weken</a:t>
             </a:r>
             <a:endParaRPr lang="en-US" sz="1250" dirty="0"/>
           </a:p>
@@ -6700,13 +6700,13 @@
             <a:r>
               <a:rPr lang="en-US" sz="950" dirty="0">
                 <a:solidFill>
-                  <a:srgbClr val="6F6A5C"/>
-                </a:solidFill>
-                <a:latin typeface="Arial" pitchFamily="34" charset="0"/>
-                <a:ea typeface="Arial" pitchFamily="34" charset="-122"/>
-                <a:cs typeface="Arial" pitchFamily="34" charset="-120"/>
-              </a:rPr>
-              <a:t>Beldagen</a:t>
+                  <a:srgbClr val="C2C8D2"/>
+                </a:solidFill>
+                <a:latin typeface="Arial" pitchFamily="34" charset="0"/>
+                <a:ea typeface="Arial" pitchFamily="34" charset="-122"/>
+                <a:cs typeface="Arial" pitchFamily="34" charset="-120"/>
+              </a:rPr>
+              <a:t>Beldagen per periode</a:t>
             </a:r>
             <a:endParaRPr lang="en-US" sz="950" dirty="0"/>
           </a:p>
@@ -6739,7 +6739,7 @@
             <a:r>
               <a:rPr lang="en-US" sz="1150" b="1" dirty="0">
                 <a:solidFill>
-                  <a:srgbClr val="1C2230"/>
+                  <a:srgbClr val="38B6FF"/>
                 </a:solidFill>
                 <a:latin typeface="Arial" pitchFamily="34" charset="0"/>
                 <a:ea typeface="Arial" pitchFamily="34" charset="-122"/>
@@ -6760,6 +6760,591 @@
         <p:spPr>
           <a:xfrm>
             <a:off x="4533889" y="3728711"/>
+            <a:ext cx="3124192" cy="0"/>
+          </a:xfrm>
+          <a:prstGeom prst="line">
+            <a:avLst/>
+          </a:prstGeom>
+          <a:noFill/>
+          <a:ln w="9525">
+            <a:solidFill>
+              <a:srgbClr val="3A4152"/>
+            </a:solidFill>
+            <a:prstDash val="solid"/>
+          </a:ln>
+        </p:spPr>
+      </p:sp>
+      <p:sp>
+        <p:nvSpPr>
+          <p:cNvPr id="30" name="Text 28"/>
+          <p:cNvSpPr txBox="1"/>
+          <p:nvPr/>
+        </p:nvSpPr>
+        <p:spPr>
+          <a:xfrm>
+            <a:off x="4533889" y="3728711"/>
+            <a:ext cx="2578094" cy="350519"/>
+          </a:xfrm>
+          <a:prstGeom prst="rect">
+            <a:avLst/>
+          </a:prstGeom>
+          <a:noFill/>
+          <a:ln/>
+        </p:spPr>
+        <p:txBody>
+          <a:bodyPr wrap="square" lIns="0" tIns="0" rIns="0" bIns="0" rtlCol="0" anchor="ctr"/>
+          <a:lstStyle/>
+          <a:p>
+            <a:pPr indent="0" marL="0">
+              <a:buNone/>
+            </a:pPr>
+            <a:r>
+              <a:rPr lang="en-US" sz="950" dirty="0">
+                <a:solidFill>
+                  <a:srgbClr val="C2C8D2"/>
+                </a:solidFill>
+                <a:latin typeface="Arial" pitchFamily="34" charset="0"/>
+                <a:ea typeface="Arial" pitchFamily="34" charset="-122"/>
+                <a:cs typeface="Arial" pitchFamily="34" charset="-120"/>
+              </a:rPr>
+              <a:t>Contactpogingen</a:t>
+            </a:r>
+            <a:endParaRPr lang="en-US" sz="950" dirty="0"/>
+          </a:p>
+        </p:txBody>
+      </p:sp>
+      <p:sp>
+        <p:nvSpPr>
+          <p:cNvPr id="31" name="Text 29"/>
+          <p:cNvSpPr txBox="1"/>
+          <p:nvPr/>
+        </p:nvSpPr>
+        <p:spPr>
+          <a:xfrm>
+            <a:off x="6832583" y="3728711"/>
+            <a:ext cx="825498" cy="350519"/>
+          </a:xfrm>
+          <a:prstGeom prst="rect">
+            <a:avLst/>
+          </a:prstGeom>
+          <a:noFill/>
+          <a:ln/>
+        </p:spPr>
+        <p:txBody>
+          <a:bodyPr wrap="square" lIns="0" tIns="0" rIns="0" bIns="0" rtlCol="0" anchor="ctr"/>
+          <a:lstStyle/>
+          <a:p>
+            <a:pPr algn="r" indent="0" marL="0">
+              <a:buNone/>
+            </a:pPr>
+            <a:r>
+              <a:rPr lang="en-US" sz="1150" b="1" dirty="0">
+                <a:solidFill>
+                  <a:srgbClr val="38B6FF"/>
+                </a:solidFill>
+                <a:latin typeface="Arial" pitchFamily="34" charset="0"/>
+                <a:ea typeface="Arial" pitchFamily="34" charset="-122"/>
+                <a:cs typeface="Arial" pitchFamily="34" charset="-120"/>
+              </a:rPr>
+              <a:t>600</a:t>
+            </a:r>
+            <a:endParaRPr lang="en-US" sz="1150" dirty="0"/>
+          </a:p>
+        </p:txBody>
+      </p:sp>
+      <p:sp>
+        <p:nvSpPr>
+          <p:cNvPr id="32" name="Shape 30"/>
+          <p:cNvSpPr/>
+          <p:nvPr/>
+        </p:nvSpPr>
+        <p:spPr>
+          <a:xfrm>
+            <a:off x="4533889" y="4079230"/>
+            <a:ext cx="3124192" cy="0"/>
+          </a:xfrm>
+          <a:prstGeom prst="line">
+            <a:avLst/>
+          </a:prstGeom>
+          <a:noFill/>
+          <a:ln w="9525">
+            <a:solidFill>
+              <a:srgbClr val="3A4152"/>
+            </a:solidFill>
+            <a:prstDash val="solid"/>
+          </a:ln>
+        </p:spPr>
+      </p:sp>
+      <p:sp>
+        <p:nvSpPr>
+          <p:cNvPr id="33" name="Text 31"/>
+          <p:cNvSpPr txBox="1"/>
+          <p:nvPr/>
+        </p:nvSpPr>
+        <p:spPr>
+          <a:xfrm>
+            <a:off x="4533889" y="4079230"/>
+            <a:ext cx="2578094" cy="350519"/>
+          </a:xfrm>
+          <a:prstGeom prst="rect">
+            <a:avLst/>
+          </a:prstGeom>
+          <a:noFill/>
+          <a:ln/>
+        </p:spPr>
+        <p:txBody>
+          <a:bodyPr wrap="square" lIns="0" tIns="0" rIns="0" bIns="0" rtlCol="0" anchor="ctr"/>
+          <a:lstStyle/>
+          <a:p>
+            <a:pPr indent="0" marL="0">
+              <a:buNone/>
+            </a:pPr>
+            <a:r>
+              <a:rPr lang="en-US" sz="950" dirty="0">
+                <a:solidFill>
+                  <a:srgbClr val="C2C8D2"/>
+                </a:solidFill>
+                <a:latin typeface="Arial" pitchFamily="34" charset="0"/>
+                <a:ea typeface="Arial" pitchFamily="34" charset="-122"/>
+                <a:cs typeface="Arial" pitchFamily="34" charset="-120"/>
+              </a:rPr>
+              <a:t>Gekwalificeerde afspraken</a:t>
+            </a:r>
+            <a:endParaRPr lang="en-US" sz="950" dirty="0"/>
+          </a:p>
+        </p:txBody>
+      </p:sp>
+      <p:sp>
+        <p:nvSpPr>
+          <p:cNvPr id="34" name="Text 32"/>
+          <p:cNvSpPr txBox="1"/>
+          <p:nvPr/>
+        </p:nvSpPr>
+        <p:spPr>
+          <a:xfrm>
+            <a:off x="6832583" y="4079230"/>
+            <a:ext cx="825498" cy="350519"/>
+          </a:xfrm>
+          <a:prstGeom prst="rect">
+            <a:avLst/>
+          </a:prstGeom>
+          <a:noFill/>
+          <a:ln/>
+        </p:spPr>
+        <p:txBody>
+          <a:bodyPr wrap="square" lIns="0" tIns="0" rIns="0" bIns="0" rtlCol="0" anchor="ctr"/>
+          <a:lstStyle/>
+          <a:p>
+            <a:pPr algn="r" indent="0" marL="0">
+              <a:buNone/>
+            </a:pPr>
+            <a:r>
+              <a:rPr lang="en-US" sz="1150" b="1" dirty="0">
+                <a:solidFill>
+                  <a:srgbClr val="38B6FF"/>
+                </a:solidFill>
+                <a:latin typeface="Arial" pitchFamily="34" charset="0"/>
+                <a:ea typeface="Arial" pitchFamily="34" charset="-122"/>
+                <a:cs typeface="Arial" pitchFamily="34" charset="-120"/>
+              </a:rPr>
+              <a:t>10</a:t>
+            </a:r>
+            <a:endParaRPr lang="en-US" sz="1150" dirty="0"/>
+          </a:p>
+        </p:txBody>
+      </p:sp>
+      <p:sp>
+        <p:nvSpPr>
+          <p:cNvPr id="35" name="Shape 33"/>
+          <p:cNvSpPr/>
+          <p:nvPr/>
+        </p:nvSpPr>
+        <p:spPr>
+          <a:xfrm>
+            <a:off x="4533889" y="4429749"/>
+            <a:ext cx="3124192" cy="0"/>
+          </a:xfrm>
+          <a:prstGeom prst="line">
+            <a:avLst/>
+          </a:prstGeom>
+          <a:noFill/>
+          <a:ln w="9525">
+            <a:solidFill>
+              <a:srgbClr val="3A4152"/>
+            </a:solidFill>
+            <a:prstDash val="solid"/>
+          </a:ln>
+        </p:spPr>
+      </p:sp>
+      <p:sp>
+        <p:nvSpPr>
+          <p:cNvPr id="36" name="Text 34"/>
+          <p:cNvSpPr txBox="1"/>
+          <p:nvPr/>
+        </p:nvSpPr>
+        <p:spPr>
+          <a:xfrm>
+            <a:off x="4533889" y="4429749"/>
+            <a:ext cx="2578094" cy="350519"/>
+          </a:xfrm>
+          <a:prstGeom prst="rect">
+            <a:avLst/>
+          </a:prstGeom>
+          <a:noFill/>
+          <a:ln/>
+        </p:spPr>
+        <p:txBody>
+          <a:bodyPr wrap="square" lIns="0" tIns="0" rIns="0" bIns="0" rtlCol="0" anchor="ctr"/>
+          <a:lstStyle/>
+          <a:p>
+            <a:pPr indent="0" marL="0">
+              <a:buNone/>
+            </a:pPr>
+            <a:r>
+              <a:rPr lang="en-US" sz="950" dirty="0">
+                <a:solidFill>
+                  <a:srgbClr val="C2C8D2"/>
+                </a:solidFill>
+                <a:latin typeface="Arial" pitchFamily="34" charset="0"/>
+                <a:ea typeface="Arial" pitchFamily="34" charset="-122"/>
+                <a:cs typeface="Arial" pitchFamily="34" charset="-120"/>
+              </a:rPr>
+              <a:t>Prijs per beldag</a:t>
+            </a:r>
+            <a:endParaRPr lang="en-US" sz="950" dirty="0"/>
+          </a:p>
+        </p:txBody>
+      </p:sp>
+      <p:sp>
+        <p:nvSpPr>
+          <p:cNvPr id="37" name="Text 35"/>
+          <p:cNvSpPr txBox="1"/>
+          <p:nvPr/>
+        </p:nvSpPr>
+        <p:spPr>
+          <a:xfrm>
+            <a:off x="6832583" y="4429749"/>
+            <a:ext cx="825498" cy="350519"/>
+          </a:xfrm>
+          <a:prstGeom prst="rect">
+            <a:avLst/>
+          </a:prstGeom>
+          <a:noFill/>
+          <a:ln/>
+        </p:spPr>
+        <p:txBody>
+          <a:bodyPr wrap="square" lIns="0" tIns="0" rIns="0" bIns="0" rtlCol="0" anchor="ctr"/>
+          <a:lstStyle/>
+          <a:p>
+            <a:pPr algn="r" indent="0" marL="0">
+              <a:buNone/>
+            </a:pPr>
+            <a:r>
+              <a:rPr lang="en-US" sz="1150" b="1" dirty="0">
+                <a:solidFill>
+                  <a:srgbClr val="38B6FF"/>
+                </a:solidFill>
+                <a:latin typeface="Arial" pitchFamily="34" charset="0"/>
+                <a:ea typeface="Arial" pitchFamily="34" charset="-122"/>
+                <a:cs typeface="Arial" pitchFamily="34" charset="-120"/>
+              </a:rPr>
+              <a:t>€ 600</a:t>
+            </a:r>
+            <a:endParaRPr lang="en-US" sz="1150" dirty="0"/>
+          </a:p>
+        </p:txBody>
+      </p:sp>
+      <p:sp>
+        <p:nvSpPr>
+          <p:cNvPr id="38" name="Shape 36"/>
+          <p:cNvSpPr/>
+          <p:nvPr/>
+        </p:nvSpPr>
+        <p:spPr>
+          <a:xfrm>
+            <a:off x="4533889" y="4780268"/>
+            <a:ext cx="3124192" cy="0"/>
+          </a:xfrm>
+          <a:prstGeom prst="line">
+            <a:avLst/>
+          </a:prstGeom>
+          <a:noFill/>
+          <a:ln w="9525">
+            <a:solidFill>
+              <a:srgbClr val="3A4152"/>
+            </a:solidFill>
+            <a:prstDash val="solid"/>
+          </a:ln>
+        </p:spPr>
+      </p:sp>
+      <p:sp>
+        <p:nvSpPr>
+          <p:cNvPr id="39" name="Text 37"/>
+          <p:cNvSpPr txBox="1"/>
+          <p:nvPr/>
+        </p:nvSpPr>
+        <p:spPr>
+          <a:xfrm>
+            <a:off x="4533889" y="4780268"/>
+            <a:ext cx="2578094" cy="350519"/>
+          </a:xfrm>
+          <a:prstGeom prst="rect">
+            <a:avLst/>
+          </a:prstGeom>
+          <a:noFill/>
+          <a:ln/>
+        </p:spPr>
+        <p:txBody>
+          <a:bodyPr wrap="square" lIns="0" tIns="0" rIns="0" bIns="0" rtlCol="0" anchor="ctr"/>
+          <a:lstStyle/>
+          <a:p>
+            <a:pPr indent="0" marL="0">
+              <a:buNone/>
+            </a:pPr>
+            <a:r>
+              <a:rPr lang="en-US" sz="950" dirty="0">
+                <a:solidFill>
+                  <a:srgbClr val="C2C8D2"/>
+                </a:solidFill>
+                <a:latin typeface="Arial" pitchFamily="34" charset="0"/>
+                <a:ea typeface="Arial" pitchFamily="34" charset="-122"/>
+                <a:cs typeface="Arial" pitchFamily="34" charset="-120"/>
+              </a:rPr>
+              <a:t>Prijs per werkperiode</a:t>
+            </a:r>
+            <a:endParaRPr lang="en-US" sz="950" dirty="0"/>
+          </a:p>
+        </p:txBody>
+      </p:sp>
+      <p:sp>
+        <p:nvSpPr>
+          <p:cNvPr id="40" name="Text 38"/>
+          <p:cNvSpPr txBox="1"/>
+          <p:nvPr/>
+        </p:nvSpPr>
+        <p:spPr>
+          <a:xfrm>
+            <a:off x="6832583" y="4780268"/>
+            <a:ext cx="825498" cy="350519"/>
+          </a:xfrm>
+          <a:prstGeom prst="rect">
+            <a:avLst/>
+          </a:prstGeom>
+          <a:noFill/>
+          <a:ln/>
+        </p:spPr>
+        <p:txBody>
+          <a:bodyPr wrap="square" lIns="0" tIns="0" rIns="0" bIns="0" rtlCol="0" anchor="ctr"/>
+          <a:lstStyle/>
+          <a:p>
+            <a:pPr algn="r" indent="0" marL="0">
+              <a:buNone/>
+            </a:pPr>
+            <a:r>
+              <a:rPr lang="en-US" sz="1150" b="1" dirty="0">
+                <a:solidFill>
+                  <a:srgbClr val="38B6FF"/>
+                </a:solidFill>
+                <a:latin typeface="Arial" pitchFamily="34" charset="0"/>
+                <a:ea typeface="Arial" pitchFamily="34" charset="-122"/>
+                <a:cs typeface="Arial" pitchFamily="34" charset="-120"/>
+              </a:rPr>
+              <a:t>€ 2.400</a:t>
+            </a:r>
+            <a:endParaRPr lang="en-US" sz="1150" dirty="0"/>
+          </a:p>
+        </p:txBody>
+      </p:sp>
+      <p:sp>
+        <p:nvSpPr>
+          <p:cNvPr id="41" name="Shape 39"/>
+          <p:cNvSpPr/>
+          <p:nvPr/>
+        </p:nvSpPr>
+        <p:spPr>
+          <a:xfrm>
+            <a:off x="8026380" y="2489194"/>
+            <a:ext cx="3555991" cy="2768593"/>
+          </a:xfrm>
+          <a:prstGeom prst="roundRect">
+            <a:avLst>
+              <a:gd name="adj" fmla="val 3670"/>
+            </a:avLst>
+          </a:prstGeom>
+          <a:solidFill>
+            <a:srgbClr val="F8F4EB"/>
+          </a:solidFill>
+          <a:ln/>
+        </p:spPr>
+      </p:sp>
+      <p:sp>
+        <p:nvSpPr>
+          <p:cNvPr id="42" name="Text 40"/>
+          <p:cNvSpPr txBox="1"/>
+          <p:nvPr/>
+        </p:nvSpPr>
+        <p:spPr>
+          <a:xfrm>
+            <a:off x="8242279" y="2743193"/>
+            <a:ext cx="3124192" cy="190500"/>
+          </a:xfrm>
+          <a:prstGeom prst="rect">
+            <a:avLst/>
+          </a:prstGeom>
+          <a:noFill/>
+          <a:ln/>
+        </p:spPr>
+        <p:txBody>
+          <a:bodyPr wrap="square" lIns="0" tIns="0" rIns="0" bIns="0" rtlCol="0" anchor="ctr"/>
+          <a:lstStyle/>
+          <a:p>
+            <a:pPr indent="0" marL="0">
+              <a:buNone/>
+            </a:pPr>
+            <a:r>
+              <a:rPr lang="en-US" sz="800" b="1" spc="180" kern="0" dirty="0">
+                <a:solidFill>
+                  <a:srgbClr val="6F6A5C"/>
+                </a:solidFill>
+                <a:latin typeface="Arial" pitchFamily="34" charset="0"/>
+                <a:ea typeface="Arial" pitchFamily="34" charset="-122"/>
+                <a:cs typeface="Arial" pitchFamily="34" charset="-120"/>
+              </a:rPr>
+              <a:t>OF DUBBEL</a:t>
+            </a:r>
+            <a:endParaRPr lang="en-US" sz="800" dirty="0"/>
+          </a:p>
+        </p:txBody>
+      </p:sp>
+      <p:sp>
+        <p:nvSpPr>
+          <p:cNvPr id="43" name="Text 41"/>
+          <p:cNvSpPr txBox="1"/>
+          <p:nvPr/>
+        </p:nvSpPr>
+        <p:spPr>
+          <a:xfrm>
+            <a:off x="8242279" y="2959093"/>
+            <a:ext cx="3124192" cy="355599"/>
+          </a:xfrm>
+          <a:prstGeom prst="rect">
+            <a:avLst/>
+          </a:prstGeom>
+          <a:noFill/>
+          <a:ln/>
+        </p:spPr>
+        <p:txBody>
+          <a:bodyPr wrap="square" lIns="0" tIns="0" rIns="0" bIns="0" rtlCol="0" anchor="ctr"/>
+          <a:lstStyle/>
+          <a:p>
+            <a:pPr indent="0" marL="0">
+              <a:lnSpc>
+                <a:spcPct val="115000"/>
+              </a:lnSpc>
+              <a:buNone/>
+            </a:pPr>
+            <a:r>
+              <a:rPr lang="en-US" sz="1250" b="1" dirty="0">
+                <a:solidFill>
+                  <a:srgbClr val="1C2230"/>
+                </a:solidFill>
+                <a:latin typeface="Arial" pitchFamily="34" charset="0"/>
+                <a:ea typeface="Arial" pitchFamily="34" charset="-122"/>
+                <a:cs typeface="Arial" pitchFamily="34" charset="-120"/>
+              </a:rPr>
+              <a:t>Acht beldagen per vier weken</a:t>
+            </a:r>
+            <a:endParaRPr lang="en-US" sz="1250" dirty="0"/>
+          </a:p>
+        </p:txBody>
+      </p:sp>
+      <p:sp>
+        <p:nvSpPr>
+          <p:cNvPr id="44" name="Text 42"/>
+          <p:cNvSpPr txBox="1"/>
+          <p:nvPr/>
+        </p:nvSpPr>
+        <p:spPr>
+          <a:xfrm>
+            <a:off x="8242279" y="3378192"/>
+            <a:ext cx="2578094" cy="350519"/>
+          </a:xfrm>
+          <a:prstGeom prst="rect">
+            <a:avLst/>
+          </a:prstGeom>
+          <a:noFill/>
+          <a:ln/>
+        </p:spPr>
+        <p:txBody>
+          <a:bodyPr wrap="square" lIns="0" tIns="0" rIns="0" bIns="0" rtlCol="0" anchor="ctr"/>
+          <a:lstStyle/>
+          <a:p>
+            <a:pPr indent="0" marL="0">
+              <a:buNone/>
+            </a:pPr>
+            <a:r>
+              <a:rPr lang="en-US" sz="950" dirty="0">
+                <a:solidFill>
+                  <a:srgbClr val="6F6A5C"/>
+                </a:solidFill>
+                <a:latin typeface="Arial" pitchFamily="34" charset="0"/>
+                <a:ea typeface="Arial" pitchFamily="34" charset="-122"/>
+                <a:cs typeface="Arial" pitchFamily="34" charset="-120"/>
+              </a:rPr>
+              <a:t>Beldagen per periode</a:t>
+            </a:r>
+            <a:endParaRPr lang="en-US" sz="950" dirty="0"/>
+          </a:p>
+        </p:txBody>
+      </p:sp>
+      <p:sp>
+        <p:nvSpPr>
+          <p:cNvPr id="45" name="Text 43"/>
+          <p:cNvSpPr txBox="1"/>
+          <p:nvPr/>
+        </p:nvSpPr>
+        <p:spPr>
+          <a:xfrm>
+            <a:off x="10540974" y="3378192"/>
+            <a:ext cx="825498" cy="350519"/>
+          </a:xfrm>
+          <a:prstGeom prst="rect">
+            <a:avLst/>
+          </a:prstGeom>
+          <a:noFill/>
+          <a:ln/>
+        </p:spPr>
+        <p:txBody>
+          <a:bodyPr wrap="square" lIns="0" tIns="0" rIns="0" bIns="0" rtlCol="0" anchor="ctr"/>
+          <a:lstStyle/>
+          <a:p>
+            <a:pPr algn="r" indent="0" marL="0">
+              <a:buNone/>
+            </a:pPr>
+            <a:r>
+              <a:rPr lang="en-US" sz="1150" b="1" dirty="0">
+                <a:solidFill>
+                  <a:srgbClr val="1C2230"/>
+                </a:solidFill>
+                <a:latin typeface="Arial" pitchFamily="34" charset="0"/>
+                <a:ea typeface="Arial" pitchFamily="34" charset="-122"/>
+                <a:cs typeface="Arial" pitchFamily="34" charset="-120"/>
+              </a:rPr>
+              <a:t>8</a:t>
+            </a:r>
+            <a:endParaRPr lang="en-US" sz="1150" dirty="0"/>
+          </a:p>
+        </p:txBody>
+      </p:sp>
+      <p:sp>
+        <p:nvSpPr>
+          <p:cNvPr id="46" name="Shape 44"/>
+          <p:cNvSpPr/>
+          <p:nvPr/>
+        </p:nvSpPr>
+        <p:spPr>
+          <a:xfrm>
+            <a:off x="8242279" y="3728711"/>
             <a:ext cx="3124192" cy="0"/>
           </a:xfrm>
           <a:prstGeom prst="line">
@@ -6776,13 +7361,13 @@
       </p:sp>
       <p:sp>
         <p:nvSpPr>
-          <p:cNvPr id="30" name="Text 28"/>
-          <p:cNvSpPr txBox="1"/>
-          <p:nvPr/>
-        </p:nvSpPr>
-        <p:spPr>
-          <a:xfrm>
-            <a:off x="4533889" y="3728711"/>
+          <p:cNvPr id="47" name="Text 45"/>
+          <p:cNvSpPr txBox="1"/>
+          <p:nvPr/>
+        </p:nvSpPr>
+        <p:spPr>
+          <a:xfrm>
+            <a:off x="8242279" y="3728711"/>
             <a:ext cx="2578094" cy="350519"/>
           </a:xfrm>
           <a:prstGeom prst="rect">
@@ -6815,13 +7400,13 @@
       </p:sp>
       <p:sp>
         <p:nvSpPr>
-          <p:cNvPr id="31" name="Text 29"/>
-          <p:cNvSpPr txBox="1"/>
-          <p:nvPr/>
-        </p:nvSpPr>
-        <p:spPr>
-          <a:xfrm>
-            <a:off x="6832583" y="3728711"/>
+          <p:cNvPr id="48" name="Text 46"/>
+          <p:cNvSpPr txBox="1"/>
+          <p:nvPr/>
+        </p:nvSpPr>
+        <p:spPr>
+          <a:xfrm>
+            <a:off x="10540974" y="3728711"/>
             <a:ext cx="825498" cy="350519"/>
           </a:xfrm>
           <a:prstGeom prst="rect">
@@ -6846,7 +7431,7 @@
                 <a:ea typeface="Arial" pitchFamily="34" charset="-122"/>
                 <a:cs typeface="Arial" pitchFamily="34" charset="-120"/>
               </a:rPr>
-              <a:t>600</a:t>
+              <a:t>1.200</a:t>
             </a:r>
             <a:endParaRPr lang="en-US" sz="1150" dirty="0"/>
           </a:p>
@@ -6854,13 +7439,13 @@
       </p:sp>
       <p:sp>
         <p:nvSpPr>
-          <p:cNvPr id="32" name="Shape 30"/>
+          <p:cNvPr id="49" name="Shape 47"/>
           <p:cNvSpPr/>
           <p:nvPr/>
         </p:nvSpPr>
         <p:spPr>
           <a:xfrm>
-            <a:off x="4533889" y="4079230"/>
+            <a:off x="8242279" y="4079230"/>
             <a:ext cx="3124192" cy="0"/>
           </a:xfrm>
           <a:prstGeom prst="line">
@@ -6877,13 +7462,13 @@
       </p:sp>
       <p:sp>
         <p:nvSpPr>
-          <p:cNvPr id="33" name="Text 31"/>
-          <p:cNvSpPr txBox="1"/>
-          <p:nvPr/>
-        </p:nvSpPr>
-        <p:spPr>
-          <a:xfrm>
-            <a:off x="4533889" y="4079230"/>
+          <p:cNvPr id="50" name="Text 48"/>
+          <p:cNvSpPr txBox="1"/>
+          <p:nvPr/>
+        </p:nvSpPr>
+        <p:spPr>
+          <a:xfrm>
+            <a:off x="8242279" y="4079230"/>
             <a:ext cx="2578094" cy="350519"/>
           </a:xfrm>
           <a:prstGeom prst="rect">
@@ -6908,7 +7493,7 @@
                 <a:ea typeface="Arial" pitchFamily="34" charset="-122"/>
                 <a:cs typeface="Arial" pitchFamily="34" charset="-120"/>
               </a:rPr>
-              <a:t>Afspraken</a:t>
+              <a:t>Gekwalificeerde afspraken</a:t>
             </a:r>
             <a:endParaRPr lang="en-US" sz="950" dirty="0"/>
           </a:p>
@@ -6916,13 +7501,13 @@
       </p:sp>
       <p:sp>
         <p:nvSpPr>
-          <p:cNvPr id="34" name="Text 32"/>
-          <p:cNvSpPr txBox="1"/>
-          <p:nvPr/>
-        </p:nvSpPr>
-        <p:spPr>
-          <a:xfrm>
-            <a:off x="6832583" y="4079230"/>
+          <p:cNvPr id="51" name="Text 49"/>
+          <p:cNvSpPr txBox="1"/>
+          <p:nvPr/>
+        </p:nvSpPr>
+        <p:spPr>
+          <a:xfrm>
+            <a:off x="10540974" y="4079230"/>
             <a:ext cx="825498" cy="350519"/>
           </a:xfrm>
           <a:prstGeom prst="rect">
@@ -6947,7 +7532,7 @@
                 <a:ea typeface="Arial" pitchFamily="34" charset="-122"/>
                 <a:cs typeface="Arial" pitchFamily="34" charset="-120"/>
               </a:rPr>
-              <a:t>± 10</a:t>
+              <a:t>20</a:t>
             </a:r>
             <a:endParaRPr lang="en-US" sz="1150" dirty="0"/>
           </a:p>
@@ -6955,13 +7540,13 @@
       </p:sp>
       <p:sp>
         <p:nvSpPr>
-          <p:cNvPr id="35" name="Shape 33"/>
+          <p:cNvPr id="52" name="Shape 50"/>
           <p:cNvSpPr/>
           <p:nvPr/>
         </p:nvSpPr>
         <p:spPr>
           <a:xfrm>
-            <a:off x="4533889" y="4429749"/>
+            <a:off x="8242279" y="4429749"/>
             <a:ext cx="3124192" cy="0"/>
           </a:xfrm>
           <a:prstGeom prst="line">
@@ -6978,13 +7563,13 @@
       </p:sp>
       <p:sp>
         <p:nvSpPr>
-          <p:cNvPr id="36" name="Text 34"/>
-          <p:cNvSpPr txBox="1"/>
-          <p:nvPr/>
-        </p:nvSpPr>
-        <p:spPr>
-          <a:xfrm>
-            <a:off x="4533889" y="4429749"/>
+          <p:cNvPr id="53" name="Text 51"/>
+          <p:cNvSpPr txBox="1"/>
+          <p:nvPr/>
+        </p:nvSpPr>
+        <p:spPr>
+          <a:xfrm>
+            <a:off x="8242279" y="4429749"/>
             <a:ext cx="2578094" cy="350519"/>
           </a:xfrm>
           <a:prstGeom prst="rect">
@@ -7017,13 +7602,13 @@
       </p:sp>
       <p:sp>
         <p:nvSpPr>
-          <p:cNvPr id="37" name="Text 35"/>
-          <p:cNvSpPr txBox="1"/>
-          <p:nvPr/>
-        </p:nvSpPr>
-        <p:spPr>
-          <a:xfrm>
-            <a:off x="6832583" y="4429749"/>
+          <p:cNvPr id="54" name="Text 52"/>
+          <p:cNvSpPr txBox="1"/>
+          <p:nvPr/>
+        </p:nvSpPr>
+        <p:spPr>
+          <a:xfrm>
+            <a:off x="10540974" y="4429749"/>
             <a:ext cx="825498" cy="350519"/>
           </a:xfrm>
           <a:prstGeom prst="rect">
@@ -7048,7 +7633,7 @@
                 <a:ea typeface="Arial" pitchFamily="34" charset="-122"/>
                 <a:cs typeface="Arial" pitchFamily="34" charset="-120"/>
               </a:rPr>
-              <a:t>€ 600</a:t>
+              <a:t>€ 550</a:t>
             </a:r>
             <a:endParaRPr lang="en-US" sz="1150" dirty="0"/>
           </a:p>
@@ -7056,13 +7641,13 @@
       </p:sp>
       <p:sp>
         <p:nvSpPr>
-          <p:cNvPr id="38" name="Shape 36"/>
+          <p:cNvPr id="55" name="Shape 53"/>
           <p:cNvSpPr/>
           <p:nvPr/>
         </p:nvSpPr>
         <p:spPr>
           <a:xfrm>
-            <a:off x="4533889" y="4780268"/>
+            <a:off x="8242279" y="4780268"/>
             <a:ext cx="3124192" cy="0"/>
           </a:xfrm>
           <a:prstGeom prst="line">
@@ -7079,591 +7664,6 @@
       </p:sp>
       <p:sp>
         <p:nvSpPr>
-          <p:cNvPr id="39" name="Text 37"/>
-          <p:cNvSpPr txBox="1"/>
-          <p:nvPr/>
-        </p:nvSpPr>
-        <p:spPr>
-          <a:xfrm>
-            <a:off x="4533889" y="4780268"/>
-            <a:ext cx="2578094" cy="350519"/>
-          </a:xfrm>
-          <a:prstGeom prst="rect">
-            <a:avLst/>
-          </a:prstGeom>
-          <a:noFill/>
-          <a:ln/>
-        </p:spPr>
-        <p:txBody>
-          <a:bodyPr wrap="square" lIns="0" tIns="0" rIns="0" bIns="0" rtlCol="0" anchor="ctr"/>
-          <a:lstStyle/>
-          <a:p>
-            <a:pPr indent="0" marL="0">
-              <a:buNone/>
-            </a:pPr>
-            <a:r>
-              <a:rPr lang="en-US" sz="950" dirty="0">
-                <a:solidFill>
-                  <a:srgbClr val="6F6A5C"/>
-                </a:solidFill>
-                <a:latin typeface="Arial" pitchFamily="34" charset="0"/>
-                <a:ea typeface="Arial" pitchFamily="34" charset="-122"/>
-                <a:cs typeface="Arial" pitchFamily="34" charset="-120"/>
-              </a:rPr>
-              <a:t>Prijs per afspraak</a:t>
-            </a:r>
-            <a:endParaRPr lang="en-US" sz="950" dirty="0"/>
-          </a:p>
-        </p:txBody>
-      </p:sp>
-      <p:sp>
-        <p:nvSpPr>
-          <p:cNvPr id="40" name="Text 38"/>
-          <p:cNvSpPr txBox="1"/>
-          <p:nvPr/>
-        </p:nvSpPr>
-        <p:spPr>
-          <a:xfrm>
-            <a:off x="6832583" y="4780268"/>
-            <a:ext cx="825498" cy="350519"/>
-          </a:xfrm>
-          <a:prstGeom prst="rect">
-            <a:avLst/>
-          </a:prstGeom>
-          <a:noFill/>
-          <a:ln/>
-        </p:spPr>
-        <p:txBody>
-          <a:bodyPr wrap="square" lIns="0" tIns="0" rIns="0" bIns="0" rtlCol="0" anchor="ctr"/>
-          <a:lstStyle/>
-          <a:p>
-            <a:pPr algn="r" indent="0" marL="0">
-              <a:buNone/>
-            </a:pPr>
-            <a:r>
-              <a:rPr lang="en-US" sz="1150" b="1" dirty="0">
-                <a:solidFill>
-                  <a:srgbClr val="1C2230"/>
-                </a:solidFill>
-                <a:latin typeface="Arial" pitchFamily="34" charset="0"/>
-                <a:ea typeface="Arial" pitchFamily="34" charset="-122"/>
-                <a:cs typeface="Arial" pitchFamily="34" charset="-120"/>
-              </a:rPr>
-              <a:t>± € 240</a:t>
-            </a:r>
-            <a:endParaRPr lang="en-US" sz="1150" dirty="0"/>
-          </a:p>
-        </p:txBody>
-      </p:sp>
-      <p:sp>
-        <p:nvSpPr>
-          <p:cNvPr id="41" name="Shape 39"/>
-          <p:cNvSpPr/>
-          <p:nvPr/>
-        </p:nvSpPr>
-        <p:spPr>
-          <a:xfrm>
-            <a:off x="8026380" y="2489194"/>
-            <a:ext cx="3555991" cy="2768593"/>
-          </a:xfrm>
-          <a:prstGeom prst="roundRect">
-            <a:avLst>
-              <a:gd name="adj" fmla="val 3670"/>
-            </a:avLst>
-          </a:prstGeom>
-          <a:solidFill>
-            <a:srgbClr val="000000"/>
-          </a:solidFill>
-          <a:ln/>
-        </p:spPr>
-      </p:sp>
-      <p:sp>
-        <p:nvSpPr>
-          <p:cNvPr id="42" name="Text 40"/>
-          <p:cNvSpPr txBox="1"/>
-          <p:nvPr/>
-        </p:nvSpPr>
-        <p:spPr>
-          <a:xfrm>
-            <a:off x="8242279" y="2743193"/>
-            <a:ext cx="3124192" cy="190500"/>
-          </a:xfrm>
-          <a:prstGeom prst="rect">
-            <a:avLst/>
-          </a:prstGeom>
-          <a:noFill/>
-          <a:ln/>
-        </p:spPr>
-        <p:txBody>
-          <a:bodyPr wrap="square" lIns="0" tIns="0" rIns="0" bIns="0" rtlCol="0" anchor="ctr"/>
-          <a:lstStyle/>
-          <a:p>
-            <a:pPr indent="0" marL="0">
-              <a:buNone/>
-            </a:pPr>
-            <a:r>
-              <a:rPr lang="en-US" sz="800" b="1" spc="180" kern="0" dirty="0">
-                <a:solidFill>
-                  <a:srgbClr val="38B6FF"/>
-                </a:solidFill>
-                <a:latin typeface="Arial" pitchFamily="34" charset="0"/>
-                <a:ea typeface="Arial" pitchFamily="34" charset="-122"/>
-                <a:cs typeface="Arial" pitchFamily="34" charset="-120"/>
-              </a:rPr>
-              <a:t>OPSCHALEN</a:t>
-            </a:r>
-            <a:endParaRPr lang="en-US" sz="800" dirty="0"/>
-          </a:p>
-        </p:txBody>
-      </p:sp>
-      <p:sp>
-        <p:nvSpPr>
-          <p:cNvPr id="43" name="Text 41"/>
-          <p:cNvSpPr txBox="1"/>
-          <p:nvPr/>
-        </p:nvSpPr>
-        <p:spPr>
-          <a:xfrm>
-            <a:off x="8242279" y="2959093"/>
-            <a:ext cx="3124192" cy="355599"/>
-          </a:xfrm>
-          <a:prstGeom prst="rect">
-            <a:avLst/>
-          </a:prstGeom>
-          <a:noFill/>
-          <a:ln/>
-        </p:spPr>
-        <p:txBody>
-          <a:bodyPr wrap="square" lIns="0" tIns="0" rIns="0" bIns="0" rtlCol="0" anchor="ctr"/>
-          <a:lstStyle/>
-          <a:p>
-            <a:pPr indent="0" marL="0">
-              <a:lnSpc>
-                <a:spcPct val="115000"/>
-              </a:lnSpc>
-              <a:buNone/>
-            </a:pPr>
-            <a:r>
-              <a:rPr lang="en-US" sz="1250" b="1" dirty="0">
-                <a:solidFill>
-                  <a:srgbClr val="F2EFE6"/>
-                </a:solidFill>
-                <a:latin typeface="Arial" pitchFamily="34" charset="0"/>
-                <a:ea typeface="Arial" pitchFamily="34" charset="-122"/>
-                <a:cs typeface="Arial" pitchFamily="34" charset="-120"/>
-              </a:rPr>
-              <a:t>8 beldagen per werkperiode</a:t>
-            </a:r>
-            <a:endParaRPr lang="en-US" sz="1250" dirty="0"/>
-          </a:p>
-        </p:txBody>
-      </p:sp>
-      <p:sp>
-        <p:nvSpPr>
-          <p:cNvPr id="44" name="Text 42"/>
-          <p:cNvSpPr txBox="1"/>
-          <p:nvPr/>
-        </p:nvSpPr>
-        <p:spPr>
-          <a:xfrm>
-            <a:off x="8242279" y="3378192"/>
-            <a:ext cx="2578094" cy="350519"/>
-          </a:xfrm>
-          <a:prstGeom prst="rect">
-            <a:avLst/>
-          </a:prstGeom>
-          <a:noFill/>
-          <a:ln/>
-        </p:spPr>
-        <p:txBody>
-          <a:bodyPr wrap="square" lIns="0" tIns="0" rIns="0" bIns="0" rtlCol="0" anchor="ctr"/>
-          <a:lstStyle/>
-          <a:p>
-            <a:pPr indent="0" marL="0">
-              <a:buNone/>
-            </a:pPr>
-            <a:r>
-              <a:rPr lang="en-US" sz="950" dirty="0">
-                <a:solidFill>
-                  <a:srgbClr val="C2C8D2"/>
-                </a:solidFill>
-                <a:latin typeface="Arial" pitchFamily="34" charset="0"/>
-                <a:ea typeface="Arial" pitchFamily="34" charset="-122"/>
-                <a:cs typeface="Arial" pitchFamily="34" charset="-120"/>
-              </a:rPr>
-              <a:t>Beldagen</a:t>
-            </a:r>
-            <a:endParaRPr lang="en-US" sz="950" dirty="0"/>
-          </a:p>
-        </p:txBody>
-      </p:sp>
-      <p:sp>
-        <p:nvSpPr>
-          <p:cNvPr id="45" name="Text 43"/>
-          <p:cNvSpPr txBox="1"/>
-          <p:nvPr/>
-        </p:nvSpPr>
-        <p:spPr>
-          <a:xfrm>
-            <a:off x="10540974" y="3378192"/>
-            <a:ext cx="825498" cy="350519"/>
-          </a:xfrm>
-          <a:prstGeom prst="rect">
-            <a:avLst/>
-          </a:prstGeom>
-          <a:noFill/>
-          <a:ln/>
-        </p:spPr>
-        <p:txBody>
-          <a:bodyPr wrap="square" lIns="0" tIns="0" rIns="0" bIns="0" rtlCol="0" anchor="ctr"/>
-          <a:lstStyle/>
-          <a:p>
-            <a:pPr algn="r" indent="0" marL="0">
-              <a:buNone/>
-            </a:pPr>
-            <a:r>
-              <a:rPr lang="en-US" sz="1150" b="1" dirty="0">
-                <a:solidFill>
-                  <a:srgbClr val="38B6FF"/>
-                </a:solidFill>
-                <a:latin typeface="Arial" pitchFamily="34" charset="0"/>
-                <a:ea typeface="Arial" pitchFamily="34" charset="-122"/>
-                <a:cs typeface="Arial" pitchFamily="34" charset="-120"/>
-              </a:rPr>
-              <a:t>8</a:t>
-            </a:r>
-            <a:endParaRPr lang="en-US" sz="1150" dirty="0"/>
-          </a:p>
-        </p:txBody>
-      </p:sp>
-      <p:sp>
-        <p:nvSpPr>
-          <p:cNvPr id="46" name="Shape 44"/>
-          <p:cNvSpPr/>
-          <p:nvPr/>
-        </p:nvSpPr>
-        <p:spPr>
-          <a:xfrm>
-            <a:off x="8242279" y="3728711"/>
-            <a:ext cx="3124192" cy="0"/>
-          </a:xfrm>
-          <a:prstGeom prst="line">
-            <a:avLst/>
-          </a:prstGeom>
-          <a:noFill/>
-          <a:ln w="9525">
-            <a:solidFill>
-              <a:srgbClr val="3A4152"/>
-            </a:solidFill>
-            <a:prstDash val="solid"/>
-          </a:ln>
-        </p:spPr>
-      </p:sp>
-      <p:sp>
-        <p:nvSpPr>
-          <p:cNvPr id="47" name="Text 45"/>
-          <p:cNvSpPr txBox="1"/>
-          <p:nvPr/>
-        </p:nvSpPr>
-        <p:spPr>
-          <a:xfrm>
-            <a:off x="8242279" y="3728711"/>
-            <a:ext cx="2578094" cy="350519"/>
-          </a:xfrm>
-          <a:prstGeom prst="rect">
-            <a:avLst/>
-          </a:prstGeom>
-          <a:noFill/>
-          <a:ln/>
-        </p:spPr>
-        <p:txBody>
-          <a:bodyPr wrap="square" lIns="0" tIns="0" rIns="0" bIns="0" rtlCol="0" anchor="ctr"/>
-          <a:lstStyle/>
-          <a:p>
-            <a:pPr indent="0" marL="0">
-              <a:buNone/>
-            </a:pPr>
-            <a:r>
-              <a:rPr lang="en-US" sz="950" dirty="0">
-                <a:solidFill>
-                  <a:srgbClr val="C2C8D2"/>
-                </a:solidFill>
-                <a:latin typeface="Arial" pitchFamily="34" charset="0"/>
-                <a:ea typeface="Arial" pitchFamily="34" charset="-122"/>
-                <a:cs typeface="Arial" pitchFamily="34" charset="-120"/>
-              </a:rPr>
-              <a:t>Contactpogingen</a:t>
-            </a:r>
-            <a:endParaRPr lang="en-US" sz="950" dirty="0"/>
-          </a:p>
-        </p:txBody>
-      </p:sp>
-      <p:sp>
-        <p:nvSpPr>
-          <p:cNvPr id="48" name="Text 46"/>
-          <p:cNvSpPr txBox="1"/>
-          <p:nvPr/>
-        </p:nvSpPr>
-        <p:spPr>
-          <a:xfrm>
-            <a:off x="10540974" y="3728711"/>
-            <a:ext cx="825498" cy="350519"/>
-          </a:xfrm>
-          <a:prstGeom prst="rect">
-            <a:avLst/>
-          </a:prstGeom>
-          <a:noFill/>
-          <a:ln/>
-        </p:spPr>
-        <p:txBody>
-          <a:bodyPr wrap="square" lIns="0" tIns="0" rIns="0" bIns="0" rtlCol="0" anchor="ctr"/>
-          <a:lstStyle/>
-          <a:p>
-            <a:pPr algn="r" indent="0" marL="0">
-              <a:buNone/>
-            </a:pPr>
-            <a:r>
-              <a:rPr lang="en-US" sz="1150" b="1" dirty="0">
-                <a:solidFill>
-                  <a:srgbClr val="38B6FF"/>
-                </a:solidFill>
-                <a:latin typeface="Arial" pitchFamily="34" charset="0"/>
-                <a:ea typeface="Arial" pitchFamily="34" charset="-122"/>
-                <a:cs typeface="Arial" pitchFamily="34" charset="-120"/>
-              </a:rPr>
-              <a:t>1.200</a:t>
-            </a:r>
-            <a:endParaRPr lang="en-US" sz="1150" dirty="0"/>
-          </a:p>
-        </p:txBody>
-      </p:sp>
-      <p:sp>
-        <p:nvSpPr>
-          <p:cNvPr id="49" name="Shape 47"/>
-          <p:cNvSpPr/>
-          <p:nvPr/>
-        </p:nvSpPr>
-        <p:spPr>
-          <a:xfrm>
-            <a:off x="8242279" y="4079230"/>
-            <a:ext cx="3124192" cy="0"/>
-          </a:xfrm>
-          <a:prstGeom prst="line">
-            <a:avLst/>
-          </a:prstGeom>
-          <a:noFill/>
-          <a:ln w="9525">
-            <a:solidFill>
-              <a:srgbClr val="3A4152"/>
-            </a:solidFill>
-            <a:prstDash val="solid"/>
-          </a:ln>
-        </p:spPr>
-      </p:sp>
-      <p:sp>
-        <p:nvSpPr>
-          <p:cNvPr id="50" name="Text 48"/>
-          <p:cNvSpPr txBox="1"/>
-          <p:nvPr/>
-        </p:nvSpPr>
-        <p:spPr>
-          <a:xfrm>
-            <a:off x="8242279" y="4079230"/>
-            <a:ext cx="2578094" cy="350519"/>
-          </a:xfrm>
-          <a:prstGeom prst="rect">
-            <a:avLst/>
-          </a:prstGeom>
-          <a:noFill/>
-          <a:ln/>
-        </p:spPr>
-        <p:txBody>
-          <a:bodyPr wrap="square" lIns="0" tIns="0" rIns="0" bIns="0" rtlCol="0" anchor="ctr"/>
-          <a:lstStyle/>
-          <a:p>
-            <a:pPr indent="0" marL="0">
-              <a:buNone/>
-            </a:pPr>
-            <a:r>
-              <a:rPr lang="en-US" sz="950" dirty="0">
-                <a:solidFill>
-                  <a:srgbClr val="C2C8D2"/>
-                </a:solidFill>
-                <a:latin typeface="Arial" pitchFamily="34" charset="0"/>
-                <a:ea typeface="Arial" pitchFamily="34" charset="-122"/>
-                <a:cs typeface="Arial" pitchFamily="34" charset="-120"/>
-              </a:rPr>
-              <a:t>Afspraken</a:t>
-            </a:r>
-            <a:endParaRPr lang="en-US" sz="950" dirty="0"/>
-          </a:p>
-        </p:txBody>
-      </p:sp>
-      <p:sp>
-        <p:nvSpPr>
-          <p:cNvPr id="51" name="Text 49"/>
-          <p:cNvSpPr txBox="1"/>
-          <p:nvPr/>
-        </p:nvSpPr>
-        <p:spPr>
-          <a:xfrm>
-            <a:off x="10540974" y="4079230"/>
-            <a:ext cx="825498" cy="350519"/>
-          </a:xfrm>
-          <a:prstGeom prst="rect">
-            <a:avLst/>
-          </a:prstGeom>
-          <a:noFill/>
-          <a:ln/>
-        </p:spPr>
-        <p:txBody>
-          <a:bodyPr wrap="square" lIns="0" tIns="0" rIns="0" bIns="0" rtlCol="0" anchor="ctr"/>
-          <a:lstStyle/>
-          <a:p>
-            <a:pPr algn="r" indent="0" marL="0">
-              <a:buNone/>
-            </a:pPr>
-            <a:r>
-              <a:rPr lang="en-US" sz="1150" b="1" dirty="0">
-                <a:solidFill>
-                  <a:srgbClr val="38B6FF"/>
-                </a:solidFill>
-                <a:latin typeface="Arial" pitchFamily="34" charset="0"/>
-                <a:ea typeface="Arial" pitchFamily="34" charset="-122"/>
-                <a:cs typeface="Arial" pitchFamily="34" charset="-120"/>
-              </a:rPr>
-              <a:t>± 20</a:t>
-            </a:r>
-            <a:endParaRPr lang="en-US" sz="1150" dirty="0"/>
-          </a:p>
-        </p:txBody>
-      </p:sp>
-      <p:sp>
-        <p:nvSpPr>
-          <p:cNvPr id="52" name="Shape 50"/>
-          <p:cNvSpPr/>
-          <p:nvPr/>
-        </p:nvSpPr>
-        <p:spPr>
-          <a:xfrm>
-            <a:off x="8242279" y="4429749"/>
-            <a:ext cx="3124192" cy="0"/>
-          </a:xfrm>
-          <a:prstGeom prst="line">
-            <a:avLst/>
-          </a:prstGeom>
-          <a:noFill/>
-          <a:ln w="9525">
-            <a:solidFill>
-              <a:srgbClr val="3A4152"/>
-            </a:solidFill>
-            <a:prstDash val="solid"/>
-          </a:ln>
-        </p:spPr>
-      </p:sp>
-      <p:sp>
-        <p:nvSpPr>
-          <p:cNvPr id="53" name="Text 51"/>
-          <p:cNvSpPr txBox="1"/>
-          <p:nvPr/>
-        </p:nvSpPr>
-        <p:spPr>
-          <a:xfrm>
-            <a:off x="8242279" y="4429749"/>
-            <a:ext cx="2578094" cy="350519"/>
-          </a:xfrm>
-          <a:prstGeom prst="rect">
-            <a:avLst/>
-          </a:prstGeom>
-          <a:noFill/>
-          <a:ln/>
-        </p:spPr>
-        <p:txBody>
-          <a:bodyPr wrap="square" lIns="0" tIns="0" rIns="0" bIns="0" rtlCol="0" anchor="ctr"/>
-          <a:lstStyle/>
-          <a:p>
-            <a:pPr indent="0" marL="0">
-              <a:buNone/>
-            </a:pPr>
-            <a:r>
-              <a:rPr lang="en-US" sz="950" dirty="0">
-                <a:solidFill>
-                  <a:srgbClr val="C2C8D2"/>
-                </a:solidFill>
-                <a:latin typeface="Arial" pitchFamily="34" charset="0"/>
-                <a:ea typeface="Arial" pitchFamily="34" charset="-122"/>
-                <a:cs typeface="Arial" pitchFamily="34" charset="-120"/>
-              </a:rPr>
-              <a:t>Prijs per beldag</a:t>
-            </a:r>
-            <a:endParaRPr lang="en-US" sz="950" dirty="0"/>
-          </a:p>
-        </p:txBody>
-      </p:sp>
-      <p:sp>
-        <p:nvSpPr>
-          <p:cNvPr id="54" name="Text 52"/>
-          <p:cNvSpPr txBox="1"/>
-          <p:nvPr/>
-        </p:nvSpPr>
-        <p:spPr>
-          <a:xfrm>
-            <a:off x="10540974" y="4429749"/>
-            <a:ext cx="825498" cy="350519"/>
-          </a:xfrm>
-          <a:prstGeom prst="rect">
-            <a:avLst/>
-          </a:prstGeom>
-          <a:noFill/>
-          <a:ln/>
-        </p:spPr>
-        <p:txBody>
-          <a:bodyPr wrap="square" lIns="0" tIns="0" rIns="0" bIns="0" rtlCol="0" anchor="ctr"/>
-          <a:lstStyle/>
-          <a:p>
-            <a:pPr algn="r" indent="0" marL="0">
-              <a:buNone/>
-            </a:pPr>
-            <a:r>
-              <a:rPr lang="en-US" sz="1150" b="1" dirty="0">
-                <a:solidFill>
-                  <a:srgbClr val="38B6FF"/>
-                </a:solidFill>
-                <a:latin typeface="Arial" pitchFamily="34" charset="0"/>
-                <a:ea typeface="Arial" pitchFamily="34" charset="-122"/>
-                <a:cs typeface="Arial" pitchFamily="34" charset="-120"/>
-              </a:rPr>
-              <a:t>€ 550</a:t>
-            </a:r>
-            <a:endParaRPr lang="en-US" sz="1150" dirty="0"/>
-          </a:p>
-        </p:txBody>
-      </p:sp>
-      <p:sp>
-        <p:nvSpPr>
-          <p:cNvPr id="55" name="Shape 53"/>
-          <p:cNvSpPr/>
-          <p:nvPr/>
-        </p:nvSpPr>
-        <p:spPr>
-          <a:xfrm>
-            <a:off x="8242279" y="4780268"/>
-            <a:ext cx="3124192" cy="0"/>
-          </a:xfrm>
-          <a:prstGeom prst="line">
-            <a:avLst/>
-          </a:prstGeom>
-          <a:noFill/>
-          <a:ln w="9525">
-            <a:solidFill>
-              <a:srgbClr val="3A4152"/>
-            </a:solidFill>
-            <a:prstDash val="solid"/>
-          </a:ln>
-        </p:spPr>
-      </p:sp>
-      <p:sp>
-        <p:nvSpPr>
           <p:cNvPr id="56" name="Text 54"/>
           <p:cNvSpPr txBox="1"/>
           <p:nvPr/>
@@ -7689,13 +7689,13 @@
             <a:r>
               <a:rPr lang="en-US" sz="950" dirty="0">
                 <a:solidFill>
-                  <a:srgbClr val="C2C8D2"/>
-                </a:solidFill>
-                <a:latin typeface="Arial" pitchFamily="34" charset="0"/>
-                <a:ea typeface="Arial" pitchFamily="34" charset="-122"/>
-                <a:cs typeface="Arial" pitchFamily="34" charset="-120"/>
-              </a:rPr>
-              <a:t>Prijs per afspraak</a:t>
+                  <a:srgbClr val="6F6A5C"/>
+                </a:solidFill>
+                <a:latin typeface="Arial" pitchFamily="34" charset="0"/>
+                <a:ea typeface="Arial" pitchFamily="34" charset="-122"/>
+                <a:cs typeface="Arial" pitchFamily="34" charset="-120"/>
+              </a:rPr>
+              <a:t>Prijs per werkperiode</a:t>
             </a:r>
             <a:endParaRPr lang="en-US" sz="950" dirty="0"/>
           </a:p>
@@ -7728,13 +7728,13 @@
             <a:r>
               <a:rPr lang="en-US" sz="1150" b="1" dirty="0">
                 <a:solidFill>
-                  <a:srgbClr val="38B6FF"/>
-                </a:solidFill>
-                <a:latin typeface="Arial" pitchFamily="34" charset="0"/>
-                <a:ea typeface="Arial" pitchFamily="34" charset="-122"/>
-                <a:cs typeface="Arial" pitchFamily="34" charset="-120"/>
-              </a:rPr>
-              <a:t>± € 220</a:t>
+                  <a:srgbClr val="1C2230"/>
+                </a:solidFill>
+                <a:latin typeface="Arial" pitchFamily="34" charset="0"/>
+                <a:ea typeface="Arial" pitchFamily="34" charset="-122"/>
+                <a:cs typeface="Arial" pitchFamily="34" charset="-120"/>
+              </a:rPr>
+              <a:t>€ 4.400</a:t>
             </a:r>
             <a:endParaRPr lang="en-US" sz="1150" dirty="0"/>
           </a:p>
@@ -7793,7 +7793,7 @@
                 <a:ea typeface="Arial" pitchFamily="34" charset="-122"/>
                 <a:cs typeface="Arial" pitchFamily="34" charset="-120"/>
               </a:rPr>
-              <a:t>Je betaalt nu al bijna zeshonderd euro per beldag, alleen koop je er maar bijna drie per periode. Bij acht beldagen zakt de dagprijs naar 550 euro en de prijs per afspraak naar 220, met twee keer zoveel afspraken.</a:t>
+              <a:t>De dagprijs blijft gelijk aan wat je nu per beldag betaalt. Neem je het dubbele af, dan zakt die naar 550 euro per beldag en betaal je 220 euro per afspraak in plaats van 240.</a:t>
             </a:r>
             <a:endParaRPr lang="en-US" sz="1200" dirty="0"/>
           </a:p>
@@ -9307,7 +9307,7 @@
                 <a:ea typeface="Arial" pitchFamily="34" charset="-122"/>
                 <a:cs typeface="Arial" pitchFamily="34" charset="-120"/>
               </a:rPr>
-              <a:t>Niet gehaald is doorbellen</a:t>
+              <a:t>Niet gehaald is een gratis beldag</a:t>
             </a:r>
             <a:endParaRPr lang="en-US" sz="1200" dirty="0"/>
           </a:p>
@@ -9349,7 +9349,7 @@
                 <a:ea typeface="Arial" pitchFamily="34" charset="-122"/>
                 <a:cs typeface="Arial" pitchFamily="34" charset="-120"/>
               </a:rPr>
-              <a:t>We bellen door tot het aantal er staat, zonder extra factuur.</a:t>
+              <a:t>Onder de tien afspraken in een werkperiode, dan bellen we de volgende periode een dag extra zonder factuur.</a:t>
             </a:r>
             <a:endParaRPr lang="en-US" sz="950" dirty="0"/>
           </a:p>
@@ -18730,7 +18730,7 @@
                 <a:ea typeface="Arial" pitchFamily="34" charset="-122"/>
                 <a:cs typeface="Arial" pitchFamily="34" charset="-120"/>
               </a:rPr>
-              <a:t>De zes uur bellen maken we altijd vol, dus de bovenste drie liggen vast. Halen we de afspraken niet, dan bellen we door tot het aantal er staat, zonder dat daar een factuur tegenover staat.</a:t>
+              <a:t>De zes uur bellen maken we altijd vol, dus de bovenste drie liggen vast. Halen we de tien afspraken niet, dan krijgen jullie de volgende periode een beldag van ons cadeau.</a:t>
             </a:r>
             <a:endParaRPr lang="en-US" sz="1200" dirty="0"/>
           </a:p>

</xml_diff>

<commit_message>
GrowOn: alleen de tien afspraken garanderen, terugbelafspraken eruit
Pogingen staan vast, gesproken bedrijven zijn een verwachting en alleen de
tien afspraken zijn een garantie met een gratis beldag als remedie.

Co-Authored-By: Claude Opus 5 <noreply@anthropic.com>
Claude-Session: https://claude.ai/code/session_0141FN3f3hHkYQHTyvTJJGrw
</commit_message>
<xml_diff>
--- a/output/LINK. voorstel GrowOn Agency.pptx
+++ b/output/LINK. voorstel GrowOn Agency.pptx
@@ -4773,7 +4773,7 @@
                 <a:ea typeface="Arial" pitchFamily="34" charset="-122"/>
                 <a:cs typeface="Arial" pitchFamily="34" charset="-120"/>
               </a:rPr>
-              <a:t>Vier harde KPI's</a:t>
+              <a:t>Tien afspraken per periode</a:t>
             </a:r>
             <a:endParaRPr lang="en-US" sz="1150" dirty="0"/>
           </a:p>
@@ -4815,7 +4815,7 @@
                 <a:ea typeface="Arial" pitchFamily="34" charset="-122"/>
                 <a:cs typeface="Arial" pitchFamily="34" charset="-120"/>
               </a:rPr>
-              <a:t>Contactpogingen, gesproken bedrijven, terugbelafspraken en gekwalificeerde afspraken. Vastgelegd per beldag en zichtbaar in elke rapportage.</a:t>
+              <a:t>Dat is de afspraak waar je ons aan mag houden. Het aantal pogingen en gesprekken laten we zien in de rapportage, maar de tien afspraken zijn wat we garanderen.</a:t>
             </a:r>
             <a:endParaRPr lang="en-US" sz="875" dirty="0"/>
           </a:p>
@@ -9157,7 +9157,7 @@
                 <a:ea typeface="Arial" pitchFamily="34" charset="-122"/>
                 <a:cs typeface="Arial" pitchFamily="34" charset="-120"/>
               </a:rPr>
-              <a:t>Vier KPI's in de overeenkomst</a:t>
+              <a:t>Tien afspraken per werkperiode</a:t>
             </a:r>
             <a:endParaRPr lang="en-US" sz="1200" dirty="0"/>
           </a:p>
@@ -9199,7 +9199,7 @@
                 <a:ea typeface="Arial" pitchFamily="34" charset="-122"/>
                 <a:cs typeface="Arial" pitchFamily="34" charset="-120"/>
               </a:rPr>
-              <a:t>Pogingen, gesproken bedrijven, terugbelafspraken en gekwalificeerde afspraken, per beldag vastgelegd.</a:t>
+              <a:t>Dat is wat we garanderen bij vier beldagen. Alles eromheen laten we zien in de wekelijkse rapportage.</a:t>
             </a:r>
             <a:endParaRPr lang="en-US" sz="950" dirty="0"/>
           </a:p>
@@ -17677,7 +17677,7 @@
                 <a:ea typeface="Arial" pitchFamily="34" charset="-122"/>
                 <a:cs typeface="Arial" pitchFamily="34" charset="-120"/>
               </a:rPr>
-              <a:t>DE AFSPRAKEN DIE WE MET ELKAAR MAKEN</a:t>
+              <a:t>WAT JE KRIJGT</a:t>
             </a:r>
             <a:endParaRPr lang="en-US" sz="950" dirty="0"/>
           </a:p>
@@ -17719,7 +17719,7 @@
                 <a:ea typeface="Arial" pitchFamily="34" charset="-122"/>
                 <a:cs typeface="Arial" pitchFamily="34" charset="-120"/>
               </a:rPr>
-              <a:t>Vier cijfers waar je ons op mag </a:t>
+              <a:t>Eén belofte: </a:t>
             </a:r>
             <a:pPr algn="l" indent="0" marL="0">
               <a:lnSpc>
@@ -17736,7 +17736,7 @@
                 <a:ea typeface="Georgia" pitchFamily="34" charset="-122"/>
                 <a:cs typeface="Georgia" pitchFamily="34" charset="-120"/>
               </a:rPr>
-              <a:t>afrekenen</a:t>
+              <a:t>tien afspraken</a:t>
             </a:r>
             <a:pPr algn="l" indent="0" marL="0">
               <a:lnSpc>
@@ -17753,7 +17753,7 @@
                 <a:ea typeface="Arial" pitchFamily="34" charset="-122"/>
                 <a:cs typeface="Arial" pitchFamily="34" charset="-120"/>
               </a:rPr>
-              <a:t>.</a:t>
+              <a:t> per werkperiode.</a:t>
             </a:r>
             <a:endParaRPr lang="en-US" sz="3200" dirty="0"/>
           </a:p>
@@ -17768,11 +17768,11 @@
         <p:spPr>
           <a:xfrm>
             <a:off x="609598" y="2666993"/>
-            <a:ext cx="10972773" cy="2793993"/>
+            <a:ext cx="10972773" cy="2355844"/>
           </a:xfrm>
           <a:prstGeom prst="roundRect">
             <a:avLst>
-              <a:gd name="adj" fmla="val 3636"/>
+              <a:gd name="adj" fmla="val 4313"/>
             </a:avLst>
           </a:prstGeom>
           <a:ln w="9525">
@@ -17971,7 +17971,7 @@
         <p:spPr>
           <a:xfrm>
             <a:off x="888998" y="3136892"/>
-            <a:ext cx="2920993" cy="581024"/>
+            <a:ext cx="2920993" cy="628648"/>
           </a:xfrm>
           <a:prstGeom prst="rect">
             <a:avLst/>
@@ -17997,6 +17997,20 @@
               </a:rPr>
               <a:t>Contactpogingen</a:t>
             </a:r>
+            <a:pPr indent="0" marL="0">
+              <a:buNone/>
+            </a:pPr>
+            <a:r>
+              <a:rPr lang="en-US" sz="1000" i="1" dirty="0">
+                <a:solidFill>
+                  <a:srgbClr val="38B6FF"/>
+                </a:solidFill>
+                <a:latin typeface="Georgia" pitchFamily="34" charset="0"/>
+                <a:ea typeface="Georgia" pitchFamily="34" charset="-122"/>
+                <a:cs typeface="Georgia" pitchFamily="34" charset="-120"/>
+              </a:rPr>
+              <a:t>   vast</a:t>
+            </a:r>
             <a:endParaRPr lang="en-US" sz="1250" dirty="0"/>
           </a:p>
         </p:txBody>
@@ -18010,7 +18024,7 @@
         <p:spPr>
           <a:xfrm>
             <a:off x="3886190" y="3136892"/>
-            <a:ext cx="2349494" cy="581024"/>
+            <a:ext cx="2349494" cy="628648"/>
           </a:xfrm>
           <a:prstGeom prst="rect">
             <a:avLst/>
@@ -18049,7 +18063,7 @@
         <p:spPr>
           <a:xfrm>
             <a:off x="6324584" y="3136892"/>
-            <a:ext cx="2349494" cy="581024"/>
+            <a:ext cx="2349494" cy="628648"/>
           </a:xfrm>
           <a:prstGeom prst="rect">
             <a:avLst/>
@@ -18088,7 +18102,7 @@
         <p:spPr>
           <a:xfrm>
             <a:off x="8737578" y="3136892"/>
-            <a:ext cx="2539994" cy="581024"/>
+            <a:ext cx="2539994" cy="628648"/>
           </a:xfrm>
           <a:prstGeom prst="rect">
             <a:avLst/>
@@ -18126,7 +18140,7 @@
         </p:nvSpPr>
         <p:spPr>
           <a:xfrm>
-            <a:off x="609598" y="3717916"/>
+            <a:off x="609598" y="3765541"/>
             <a:ext cx="10972773" cy="0"/>
           </a:xfrm>
           <a:prstGeom prst="line">
@@ -18149,8 +18163,8 @@
         </p:nvSpPr>
         <p:spPr>
           <a:xfrm>
-            <a:off x="888998" y="3717916"/>
-            <a:ext cx="2920993" cy="581024"/>
+            <a:off x="888998" y="3765541"/>
+            <a:ext cx="2920993" cy="628648"/>
           </a:xfrm>
           <a:prstGeom prst="rect">
             <a:avLst/>
@@ -18176,6 +18190,20 @@
               </a:rPr>
               <a:t>Bedrijven gesproken</a:t>
             </a:r>
+            <a:pPr indent="0" marL="0">
+              <a:buNone/>
+            </a:pPr>
+            <a:r>
+              <a:rPr lang="en-US" sz="1000" i="1" dirty="0">
+                <a:solidFill>
+                  <a:srgbClr val="38B6FF"/>
+                </a:solidFill>
+                <a:latin typeface="Georgia" pitchFamily="34" charset="0"/>
+                <a:ea typeface="Georgia" pitchFamily="34" charset="-122"/>
+                <a:cs typeface="Georgia" pitchFamily="34" charset="-120"/>
+              </a:rPr>
+              <a:t>   verwachting</a:t>
+            </a:r>
             <a:endParaRPr lang="en-US" sz="1250" dirty="0"/>
           </a:p>
         </p:txBody>
@@ -18188,8 +18216,8 @@
         </p:nvSpPr>
         <p:spPr>
           <a:xfrm>
-            <a:off x="3886190" y="3717916"/>
-            <a:ext cx="2349494" cy="581024"/>
+            <a:off x="3886190" y="3765541"/>
+            <a:ext cx="2349494" cy="628648"/>
           </a:xfrm>
           <a:prstGeom prst="rect">
             <a:avLst/>
@@ -18227,8 +18255,8 @@
         </p:nvSpPr>
         <p:spPr>
           <a:xfrm>
-            <a:off x="6324584" y="3717916"/>
-            <a:ext cx="2349494" cy="581024"/>
+            <a:off x="6324584" y="3765541"/>
+            <a:ext cx="2349494" cy="628648"/>
           </a:xfrm>
           <a:prstGeom prst="rect">
             <a:avLst/>
@@ -18266,8 +18294,8 @@
         </p:nvSpPr>
         <p:spPr>
           <a:xfrm>
-            <a:off x="8737578" y="3717916"/>
-            <a:ext cx="2539994" cy="581024"/>
+            <a:off x="8737578" y="3765541"/>
+            <a:ext cx="2539994" cy="628648"/>
           </a:xfrm>
           <a:prstGeom prst="rect">
             <a:avLst/>
@@ -18305,7 +18333,29 @@
         </p:nvSpPr>
         <p:spPr>
           <a:xfrm>
-            <a:off x="609598" y="4298939"/>
+            <a:off x="615948" y="4394189"/>
+            <a:ext cx="10960073" cy="628648"/>
+          </a:xfrm>
+          <a:prstGeom prst="rect">
+            <a:avLst/>
+          </a:prstGeom>
+          <a:solidFill>
+            <a:srgbClr val="38B6FF">
+              <a:alpha val="11000"/>
+            </a:srgbClr>
+          </a:solidFill>
+          <a:ln/>
+        </p:spPr>
+      </p:sp>
+      <p:sp>
+        <p:nvSpPr>
+          <p:cNvPr id="23" name="Shape 21"/>
+          <p:cNvSpPr/>
+          <p:nvPr/>
+        </p:nvSpPr>
+        <p:spPr>
+          <a:xfrm>
+            <a:off x="609598" y="4394189"/>
             <a:ext cx="10972773" cy="0"/>
           </a:xfrm>
           <a:prstGeom prst="line">
@@ -18322,14 +18372,14 @@
       </p:sp>
       <p:sp>
         <p:nvSpPr>
-          <p:cNvPr id="23" name="Text 21"/>
-          <p:cNvSpPr txBox="1"/>
-          <p:nvPr/>
-        </p:nvSpPr>
-        <p:spPr>
-          <a:xfrm>
-            <a:off x="888998" y="4298939"/>
-            <a:ext cx="2920993" cy="581024"/>
+          <p:cNvPr id="24" name="Text 22"/>
+          <p:cNvSpPr txBox="1"/>
+          <p:nvPr/>
+        </p:nvSpPr>
+        <p:spPr>
+          <a:xfrm>
+            <a:off x="888998" y="4394189"/>
+            <a:ext cx="2920993" cy="628648"/>
           </a:xfrm>
           <a:prstGeom prst="rect">
             <a:avLst/>
@@ -18353,7 +18403,21 @@
                 <a:ea typeface="Arial" pitchFamily="34" charset="-122"/>
                 <a:cs typeface="Arial" pitchFamily="34" charset="-120"/>
               </a:rPr>
-              <a:t>Terugbelafspraken</a:t>
+              <a:t>Afspraken</a:t>
+            </a:r>
+            <a:pPr indent="0" marL="0">
+              <a:buNone/>
+            </a:pPr>
+            <a:r>
+              <a:rPr lang="en-US" sz="1000" i="1" dirty="0">
+                <a:solidFill>
+                  <a:srgbClr val="38B6FF"/>
+                </a:solidFill>
+                <a:latin typeface="Georgia" pitchFamily="34" charset="0"/>
+                <a:ea typeface="Georgia" pitchFamily="34" charset="-122"/>
+                <a:cs typeface="Georgia" pitchFamily="34" charset="-120"/>
+              </a:rPr>
+              <a:t>   gegarandeerd</a:t>
             </a:r>
             <a:endParaRPr lang="en-US" sz="1250" dirty="0"/>
           </a:p>
@@ -18361,14 +18425,14 @@
       </p:sp>
       <p:sp>
         <p:nvSpPr>
-          <p:cNvPr id="24" name="Text 22"/>
-          <p:cNvSpPr txBox="1"/>
-          <p:nvPr/>
-        </p:nvSpPr>
-        <p:spPr>
-          <a:xfrm>
-            <a:off x="3886190" y="4298939"/>
-            <a:ext cx="2349494" cy="581024"/>
+          <p:cNvPr id="25" name="Text 23"/>
+          <p:cNvSpPr txBox="1"/>
+          <p:nvPr/>
+        </p:nvSpPr>
+        <p:spPr>
+          <a:xfrm>
+            <a:off x="3886190" y="4394189"/>
+            <a:ext cx="2349494" cy="628648"/>
           </a:xfrm>
           <a:prstGeom prst="rect">
             <a:avLst/>
@@ -18392,7 +18456,7 @@
                 <a:ea typeface="Arial" pitchFamily="34" charset="-122"/>
                 <a:cs typeface="Arial" pitchFamily="34" charset="-120"/>
               </a:rPr>
-              <a:t>± 35</a:t>
+              <a:t>2,5</a:t>
             </a:r>
             <a:endParaRPr lang="en-US" sz="1250" dirty="0"/>
           </a:p>
@@ -18400,14 +18464,14 @@
       </p:sp>
       <p:sp>
         <p:nvSpPr>
-          <p:cNvPr id="25" name="Text 23"/>
-          <p:cNvSpPr txBox="1"/>
-          <p:nvPr/>
-        </p:nvSpPr>
-        <p:spPr>
-          <a:xfrm>
-            <a:off x="6324584" y="4298939"/>
-            <a:ext cx="2349494" cy="581024"/>
+          <p:cNvPr id="26" name="Text 24"/>
+          <p:cNvSpPr txBox="1"/>
+          <p:nvPr/>
+        </p:nvSpPr>
+        <p:spPr>
+          <a:xfrm>
+            <a:off x="6324584" y="4394189"/>
+            <a:ext cx="2349494" cy="628648"/>
           </a:xfrm>
           <a:prstGeom prst="rect">
             <a:avLst/>
@@ -18431,7 +18495,7 @@
                 <a:ea typeface="Arial" pitchFamily="34" charset="-122"/>
                 <a:cs typeface="Arial" pitchFamily="34" charset="-120"/>
               </a:rPr>
-              <a:t>± 140</a:t>
+              <a:t>10</a:t>
             </a:r>
             <a:endParaRPr lang="en-US" sz="1250" dirty="0"/>
           </a:p>
@@ -18439,14 +18503,14 @@
       </p:sp>
       <p:sp>
         <p:nvSpPr>
-          <p:cNvPr id="26" name="Text 24"/>
-          <p:cNvSpPr txBox="1"/>
-          <p:nvPr/>
-        </p:nvSpPr>
-        <p:spPr>
-          <a:xfrm>
-            <a:off x="8737578" y="4298939"/>
-            <a:ext cx="2539994" cy="581024"/>
+          <p:cNvPr id="27" name="Text 25"/>
+          <p:cNvSpPr txBox="1"/>
+          <p:nvPr/>
+        </p:nvSpPr>
+        <p:spPr>
+          <a:xfrm>
+            <a:off x="8737578" y="4394189"/>
+            <a:ext cx="2539994" cy="628648"/>
           </a:xfrm>
           <a:prstGeom prst="rect">
             <a:avLst/>
@@ -18470,7 +18534,7 @@
                 <a:ea typeface="Arial" pitchFamily="34" charset="-122"/>
                 <a:cs typeface="Arial" pitchFamily="34" charset="-120"/>
               </a:rPr>
-              <a:t>± 280</a:t>
+              <a:t>20</a:t>
             </a:r>
             <a:endParaRPr lang="en-US" sz="1250" dirty="0"/>
           </a:p>
@@ -18478,208 +18542,7 @@
       </p:sp>
       <p:sp>
         <p:nvSpPr>
-          <p:cNvPr id="27" name="Shape 25"/>
-          <p:cNvSpPr/>
-          <p:nvPr/>
-        </p:nvSpPr>
-        <p:spPr>
-          <a:xfrm>
-            <a:off x="615948" y="4879963"/>
-            <a:ext cx="10960073" cy="581024"/>
-          </a:xfrm>
-          <a:prstGeom prst="rect">
-            <a:avLst/>
-          </a:prstGeom>
-          <a:solidFill>
-            <a:srgbClr val="38B6FF">
-              <a:alpha val="11000"/>
-            </a:srgbClr>
-          </a:solidFill>
-          <a:ln/>
-        </p:spPr>
-      </p:sp>
-      <p:sp>
-        <p:nvSpPr>
           <p:cNvPr id="28" name="Shape 26"/>
-          <p:cNvSpPr/>
-          <p:nvPr/>
-        </p:nvSpPr>
-        <p:spPr>
-          <a:xfrm>
-            <a:off x="609598" y="4879963"/>
-            <a:ext cx="10972773" cy="0"/>
-          </a:xfrm>
-          <a:prstGeom prst="line">
-            <a:avLst/>
-          </a:prstGeom>
-          <a:noFill/>
-          <a:ln w="9525">
-            <a:solidFill>
-              <a:srgbClr val="3A4152"/>
-            </a:solidFill>
-            <a:prstDash val="solid"/>
-          </a:ln>
-        </p:spPr>
-      </p:sp>
-      <p:sp>
-        <p:nvSpPr>
-          <p:cNvPr id="29" name="Text 27"/>
-          <p:cNvSpPr txBox="1"/>
-          <p:nvPr/>
-        </p:nvSpPr>
-        <p:spPr>
-          <a:xfrm>
-            <a:off x="888998" y="4879963"/>
-            <a:ext cx="2920993" cy="581024"/>
-          </a:xfrm>
-          <a:prstGeom prst="rect">
-            <a:avLst/>
-          </a:prstGeom>
-          <a:noFill/>
-          <a:ln/>
-        </p:spPr>
-        <p:txBody>
-          <a:bodyPr wrap="square" lIns="0" tIns="0" rIns="0" bIns="0" rtlCol="0" anchor="ctr"/>
-          <a:lstStyle/>
-          <a:p>
-            <a:pPr indent="0" marL="0">
-              <a:buNone/>
-            </a:pPr>
-            <a:r>
-              <a:rPr lang="en-US" sz="1250" b="1" dirty="0">
-                <a:solidFill>
-                  <a:srgbClr val="F2EFE6"/>
-                </a:solidFill>
-                <a:latin typeface="Arial" pitchFamily="34" charset="0"/>
-                <a:ea typeface="Arial" pitchFamily="34" charset="-122"/>
-                <a:cs typeface="Arial" pitchFamily="34" charset="-120"/>
-              </a:rPr>
-              <a:t>Gekwalificeerde afspraken</a:t>
-            </a:r>
-            <a:endParaRPr lang="en-US" sz="1250" dirty="0"/>
-          </a:p>
-        </p:txBody>
-      </p:sp>
-      <p:sp>
-        <p:nvSpPr>
-          <p:cNvPr id="30" name="Text 28"/>
-          <p:cNvSpPr txBox="1"/>
-          <p:nvPr/>
-        </p:nvSpPr>
-        <p:spPr>
-          <a:xfrm>
-            <a:off x="3886190" y="4879963"/>
-            <a:ext cx="2349494" cy="581024"/>
-          </a:xfrm>
-          <a:prstGeom prst="rect">
-            <a:avLst/>
-          </a:prstGeom>
-          <a:noFill/>
-          <a:ln/>
-        </p:spPr>
-        <p:txBody>
-          <a:bodyPr wrap="square" lIns="0" tIns="0" rIns="0" bIns="0" rtlCol="0" anchor="ctr"/>
-          <a:lstStyle/>
-          <a:p>
-            <a:pPr indent="0" marL="0">
-              <a:buNone/>
-            </a:pPr>
-            <a:r>
-              <a:rPr lang="en-US" sz="1250" b="1" dirty="0">
-                <a:solidFill>
-                  <a:srgbClr val="F2EFE6"/>
-                </a:solidFill>
-                <a:latin typeface="Arial" pitchFamily="34" charset="0"/>
-                <a:ea typeface="Arial" pitchFamily="34" charset="-122"/>
-                <a:cs typeface="Arial" pitchFamily="34" charset="-120"/>
-              </a:rPr>
-              <a:t>2,5</a:t>
-            </a:r>
-            <a:endParaRPr lang="en-US" sz="1250" dirty="0"/>
-          </a:p>
-        </p:txBody>
-      </p:sp>
-      <p:sp>
-        <p:nvSpPr>
-          <p:cNvPr id="31" name="Text 29"/>
-          <p:cNvSpPr txBox="1"/>
-          <p:nvPr/>
-        </p:nvSpPr>
-        <p:spPr>
-          <a:xfrm>
-            <a:off x="6324584" y="4879963"/>
-            <a:ext cx="2349494" cy="581024"/>
-          </a:xfrm>
-          <a:prstGeom prst="rect">
-            <a:avLst/>
-          </a:prstGeom>
-          <a:noFill/>
-          <a:ln/>
-        </p:spPr>
-        <p:txBody>
-          <a:bodyPr wrap="square" lIns="0" tIns="0" rIns="0" bIns="0" rtlCol="0" anchor="ctr"/>
-          <a:lstStyle/>
-          <a:p>
-            <a:pPr indent="0" marL="0">
-              <a:buNone/>
-            </a:pPr>
-            <a:r>
-              <a:rPr lang="en-US" sz="1250" b="1" dirty="0">
-                <a:solidFill>
-                  <a:srgbClr val="F2EFE6"/>
-                </a:solidFill>
-                <a:latin typeface="Arial" pitchFamily="34" charset="0"/>
-                <a:ea typeface="Arial" pitchFamily="34" charset="-122"/>
-                <a:cs typeface="Arial" pitchFamily="34" charset="-120"/>
-              </a:rPr>
-              <a:t>10</a:t>
-            </a:r>
-            <a:endParaRPr lang="en-US" sz="1250" dirty="0"/>
-          </a:p>
-        </p:txBody>
-      </p:sp>
-      <p:sp>
-        <p:nvSpPr>
-          <p:cNvPr id="32" name="Text 30"/>
-          <p:cNvSpPr txBox="1"/>
-          <p:nvPr/>
-        </p:nvSpPr>
-        <p:spPr>
-          <a:xfrm>
-            <a:off x="8737578" y="4879963"/>
-            <a:ext cx="2539994" cy="581024"/>
-          </a:xfrm>
-          <a:prstGeom prst="rect">
-            <a:avLst/>
-          </a:prstGeom>
-          <a:noFill/>
-          <a:ln/>
-        </p:spPr>
-        <p:txBody>
-          <a:bodyPr wrap="square" lIns="0" tIns="0" rIns="0" bIns="0" rtlCol="0" anchor="ctr"/>
-          <a:lstStyle/>
-          <a:p>
-            <a:pPr indent="0" marL="0">
-              <a:buNone/>
-            </a:pPr>
-            <a:r>
-              <a:rPr lang="en-US" sz="1250" b="1" dirty="0">
-                <a:solidFill>
-                  <a:srgbClr val="F2EFE6"/>
-                </a:solidFill>
-                <a:latin typeface="Arial" pitchFamily="34" charset="0"/>
-                <a:ea typeface="Arial" pitchFamily="34" charset="-122"/>
-                <a:cs typeface="Arial" pitchFamily="34" charset="-120"/>
-              </a:rPr>
-              <a:t>20</a:t>
-            </a:r>
-            <a:endParaRPr lang="en-US" sz="1250" dirty="0"/>
-          </a:p>
-        </p:txBody>
-      </p:sp>
-      <p:sp>
-        <p:nvSpPr>
-          <p:cNvPr id="33" name="Shape 31"/>
           <p:cNvSpPr/>
           <p:nvPr/>
         </p:nvSpPr>
@@ -18699,7 +18562,7 @@
       </p:sp>
       <p:sp>
         <p:nvSpPr>
-          <p:cNvPr id="34" name="Text 32"/>
+          <p:cNvPr id="29" name="Text 27"/>
           <p:cNvSpPr txBox="1"/>
           <p:nvPr/>
         </p:nvSpPr>
@@ -18730,7 +18593,7 @@
                 <a:ea typeface="Arial" pitchFamily="34" charset="-122"/>
                 <a:cs typeface="Arial" pitchFamily="34" charset="-120"/>
               </a:rPr>
-              <a:t>De zes uur bellen maken we altijd vol, dus de bovenste drie liggen vast. Halen we de tien afspraken niet, dan krijgen jullie de volgende periode een beldag van ons cadeau.</a:t>
+              <a:t>De zes uur bellen maken we altijd vol, dus die honderdvijftig pogingen staan. Garanderen doen we alleen de tien afspraken, en halen we die niet, dan krijgen jullie een beldag cadeau.</a:t>
             </a:r>
             <a:endParaRPr lang="en-US" sz="1200" dirty="0"/>
           </a:p>

</xml_diff>

<commit_message>
GrowOn: zes beldagen als tussenstap en de zes-uur-claim eruit
- vergelijking toont nu, vier, zes en acht beldagen naast elkaar
- KPI-tabel op per beldag, per 4 en per 6 beldagen
- template en pptx: vier kolommen in een vergelijking

Co-Authored-By: Claude Opus 5 <noreply@anthropic.com>
Claude-Session: https://claude.ai/code/session_0141FN3f3hHkYQHTyvTJJGrw
</commit_message>
<xml_diff>
--- a/output/LINK. voorstel GrowOn Agency.pptx
+++ b/output/LINK. voorstel GrowOn Agency.pptx
@@ -5994,11 +5994,11 @@
         <p:spPr>
           <a:xfrm>
             <a:off x="609598" y="2489194"/>
-            <a:ext cx="3555991" cy="2768593"/>
+            <a:ext cx="2657468" cy="2768593"/>
           </a:xfrm>
           <a:prstGeom prst="roundRect">
             <a:avLst>
-              <a:gd name="adj" fmla="val 3670"/>
+              <a:gd name="adj" fmla="val 3823"/>
             </a:avLst>
           </a:prstGeom>
           <a:solidFill>
@@ -6015,8 +6015,8 @@
         </p:nvSpPr>
         <p:spPr>
           <a:xfrm>
-            <a:off x="825498" y="2743193"/>
-            <a:ext cx="3124192" cy="190500"/>
+            <a:off x="774698" y="2743193"/>
+            <a:ext cx="2327269" cy="190500"/>
           </a:xfrm>
           <a:prstGeom prst="rect">
             <a:avLst/>
@@ -6054,8 +6054,8 @@
         </p:nvSpPr>
         <p:spPr>
           <a:xfrm>
-            <a:off x="825498" y="2959093"/>
-            <a:ext cx="3124192" cy="355599"/>
+            <a:off x="774698" y="2959093"/>
+            <a:ext cx="2327269" cy="355599"/>
           </a:xfrm>
           <a:prstGeom prst="rect">
             <a:avLst/>
@@ -6074,7 +6074,7 @@
               <a:buNone/>
             </a:pPr>
             <a:r>
-              <a:rPr lang="en-US" sz="1250" b="1" dirty="0">
+              <a:rPr lang="en-US" sz="1050" b="1" dirty="0">
                 <a:solidFill>
                   <a:srgbClr val="1C2230"/>
                 </a:solidFill>
@@ -6082,9 +6082,9 @@
                 <a:ea typeface="Arial" pitchFamily="34" charset="-122"/>
                 <a:cs typeface="Arial" pitchFamily="34" charset="-120"/>
               </a:rPr>
-              <a:t>Zoals het de afgelopen twaalf weken liep</a:t>
-            </a:r>
-            <a:endParaRPr lang="en-US" sz="1250" dirty="0"/>
+              <a:t>Zoals het nu loopt</a:t>
+            </a:r>
+            <a:endParaRPr lang="en-US" sz="1050" dirty="0"/>
           </a:p>
         </p:txBody>
       </p:sp>
@@ -6096,24 +6096,24 @@
         </p:nvSpPr>
         <p:spPr>
           <a:xfrm>
-            <a:off x="825498" y="3378192"/>
-            <a:ext cx="2578094" cy="350519"/>
-          </a:xfrm>
-          <a:prstGeom prst="rect">
-            <a:avLst/>
-          </a:prstGeom>
-          <a:noFill/>
-          <a:ln/>
-        </p:spPr>
-        <p:txBody>
-          <a:bodyPr wrap="square" lIns="0" tIns="0" rIns="0" bIns="0" rtlCol="0" anchor="ctr"/>
-          <a:lstStyle/>
-          <a:p>
-            <a:pPr indent="0" marL="0">
-              <a:buNone/>
-            </a:pPr>
-            <a:r>
-              <a:rPr lang="en-US" sz="950" dirty="0">
+            <a:off x="774698" y="3378192"/>
+            <a:ext cx="1730371" cy="350519"/>
+          </a:xfrm>
+          <a:prstGeom prst="rect">
+            <a:avLst/>
+          </a:prstGeom>
+          <a:noFill/>
+          <a:ln/>
+        </p:spPr>
+        <p:txBody>
+          <a:bodyPr wrap="square" lIns="0" tIns="0" rIns="0" bIns="0" rtlCol="0" anchor="ctr"/>
+          <a:lstStyle/>
+          <a:p>
+            <a:pPr indent="0" marL="0">
+              <a:buNone/>
+            </a:pPr>
+            <a:r>
+              <a:rPr lang="en-US" sz="800" dirty="0">
                 <a:solidFill>
                   <a:srgbClr val="6F6A5C"/>
                 </a:solidFill>
@@ -6121,9 +6121,9 @@
                 <a:ea typeface="Arial" pitchFamily="34" charset="-122"/>
                 <a:cs typeface="Arial" pitchFamily="34" charset="-120"/>
               </a:rPr>
-              <a:t>Beldagen per periode</a:t>
-            </a:r>
-            <a:endParaRPr lang="en-US" sz="950" dirty="0"/>
+              <a:t>Beldagen</a:t>
+            </a:r>
+            <a:endParaRPr lang="en-US" sz="800" dirty="0"/>
           </a:p>
         </p:txBody>
       </p:sp>
@@ -6135,7 +6135,7 @@
         </p:nvSpPr>
         <p:spPr>
           <a:xfrm>
-            <a:off x="3124192" y="3378192"/>
+            <a:off x="2276469" y="3378192"/>
             <a:ext cx="825498" cy="350519"/>
           </a:xfrm>
           <a:prstGeom prst="rect">
@@ -6152,7 +6152,7 @@
               <a:buNone/>
             </a:pPr>
             <a:r>
-              <a:rPr lang="en-US" sz="1150" b="1" dirty="0">
+              <a:rPr lang="en-US" sz="1000" b="1" dirty="0">
                 <a:solidFill>
                   <a:srgbClr val="1C2230"/>
                 </a:solidFill>
@@ -6162,7 +6162,7 @@
               </a:rPr>
               <a:t>± 2,7</a:t>
             </a:r>
-            <a:endParaRPr lang="en-US" sz="1150" dirty="0"/>
+            <a:endParaRPr lang="en-US" sz="1000" dirty="0"/>
           </a:p>
         </p:txBody>
       </p:sp>
@@ -6174,8 +6174,8 @@
         </p:nvSpPr>
         <p:spPr>
           <a:xfrm>
-            <a:off x="825498" y="3728711"/>
-            <a:ext cx="3124192" cy="0"/>
+            <a:off x="774698" y="3728711"/>
+            <a:ext cx="2327269" cy="0"/>
           </a:xfrm>
           <a:prstGeom prst="line">
             <a:avLst/>
@@ -6197,24 +6197,24 @@
         </p:nvSpPr>
         <p:spPr>
           <a:xfrm>
-            <a:off x="825498" y="3728711"/>
-            <a:ext cx="2578094" cy="350519"/>
-          </a:xfrm>
-          <a:prstGeom prst="rect">
-            <a:avLst/>
-          </a:prstGeom>
-          <a:noFill/>
-          <a:ln/>
-        </p:spPr>
-        <p:txBody>
-          <a:bodyPr wrap="square" lIns="0" tIns="0" rIns="0" bIns="0" rtlCol="0" anchor="ctr"/>
-          <a:lstStyle/>
-          <a:p>
-            <a:pPr indent="0" marL="0">
-              <a:buNone/>
-            </a:pPr>
-            <a:r>
-              <a:rPr lang="en-US" sz="950" dirty="0">
+            <a:off x="774698" y="3728711"/>
+            <a:ext cx="1730371" cy="350519"/>
+          </a:xfrm>
+          <a:prstGeom prst="rect">
+            <a:avLst/>
+          </a:prstGeom>
+          <a:noFill/>
+          <a:ln/>
+        </p:spPr>
+        <p:txBody>
+          <a:bodyPr wrap="square" lIns="0" tIns="0" rIns="0" bIns="0" rtlCol="0" anchor="ctr"/>
+          <a:lstStyle/>
+          <a:p>
+            <a:pPr indent="0" marL="0">
+              <a:buNone/>
+            </a:pPr>
+            <a:r>
+              <a:rPr lang="en-US" sz="800" dirty="0">
                 <a:solidFill>
                   <a:srgbClr val="6F6A5C"/>
                 </a:solidFill>
@@ -6224,7 +6224,7 @@
               </a:rPr>
               <a:t>Contactpogingen</a:t>
             </a:r>
-            <a:endParaRPr lang="en-US" sz="950" dirty="0"/>
+            <a:endParaRPr lang="en-US" sz="800" dirty="0"/>
           </a:p>
         </p:txBody>
       </p:sp>
@@ -6236,7 +6236,7 @@
         </p:nvSpPr>
         <p:spPr>
           <a:xfrm>
-            <a:off x="3124192" y="3728711"/>
+            <a:off x="2276469" y="3728711"/>
             <a:ext cx="825498" cy="350519"/>
           </a:xfrm>
           <a:prstGeom prst="rect">
@@ -6253,7 +6253,7 @@
               <a:buNone/>
             </a:pPr>
             <a:r>
-              <a:rPr lang="en-US" sz="1150" b="1" dirty="0">
+              <a:rPr lang="en-US" sz="1000" b="1" dirty="0">
                 <a:solidFill>
                   <a:srgbClr val="1C2230"/>
                 </a:solidFill>
@@ -6263,7 +6263,7 @@
               </a:rPr>
               <a:t>± 400</a:t>
             </a:r>
-            <a:endParaRPr lang="en-US" sz="1150" dirty="0"/>
+            <a:endParaRPr lang="en-US" sz="1000" dirty="0"/>
           </a:p>
         </p:txBody>
       </p:sp>
@@ -6275,8 +6275,8 @@
         </p:nvSpPr>
         <p:spPr>
           <a:xfrm>
-            <a:off x="825498" y="4079230"/>
-            <a:ext cx="3124192" cy="0"/>
+            <a:off x="774698" y="4079230"/>
+            <a:ext cx="2327269" cy="0"/>
           </a:xfrm>
           <a:prstGeom prst="line">
             <a:avLst/>
@@ -6298,24 +6298,24 @@
         </p:nvSpPr>
         <p:spPr>
           <a:xfrm>
-            <a:off x="825498" y="4079230"/>
-            <a:ext cx="2578094" cy="350519"/>
-          </a:xfrm>
-          <a:prstGeom prst="rect">
-            <a:avLst/>
-          </a:prstGeom>
-          <a:noFill/>
-          <a:ln/>
-        </p:spPr>
-        <p:txBody>
-          <a:bodyPr wrap="square" lIns="0" tIns="0" rIns="0" bIns="0" rtlCol="0" anchor="ctr"/>
-          <a:lstStyle/>
-          <a:p>
-            <a:pPr indent="0" marL="0">
-              <a:buNone/>
-            </a:pPr>
-            <a:r>
-              <a:rPr lang="en-US" sz="950" dirty="0">
+            <a:off x="774698" y="4079230"/>
+            <a:ext cx="1730371" cy="350519"/>
+          </a:xfrm>
+          <a:prstGeom prst="rect">
+            <a:avLst/>
+          </a:prstGeom>
+          <a:noFill/>
+          <a:ln/>
+        </p:spPr>
+        <p:txBody>
+          <a:bodyPr wrap="square" lIns="0" tIns="0" rIns="0" bIns="0" rtlCol="0" anchor="ctr"/>
+          <a:lstStyle/>
+          <a:p>
+            <a:pPr indent="0" marL="0">
+              <a:buNone/>
+            </a:pPr>
+            <a:r>
+              <a:rPr lang="en-US" sz="800" dirty="0">
                 <a:solidFill>
                   <a:srgbClr val="6F6A5C"/>
                 </a:solidFill>
@@ -6323,9 +6323,9 @@
                 <a:ea typeface="Arial" pitchFamily="34" charset="-122"/>
                 <a:cs typeface="Arial" pitchFamily="34" charset="-120"/>
               </a:rPr>
-              <a:t>Gekwalificeerde afspraken</a:t>
-            </a:r>
-            <a:endParaRPr lang="en-US" sz="950" dirty="0"/>
+              <a:t>Afspraken</a:t>
+            </a:r>
+            <a:endParaRPr lang="en-US" sz="800" dirty="0"/>
           </a:p>
         </p:txBody>
       </p:sp>
@@ -6337,7 +6337,7 @@
         </p:nvSpPr>
         <p:spPr>
           <a:xfrm>
-            <a:off x="3124192" y="4079230"/>
+            <a:off x="2276469" y="4079230"/>
             <a:ext cx="825498" cy="350519"/>
           </a:xfrm>
           <a:prstGeom prst="rect">
@@ -6354,7 +6354,7 @@
               <a:buNone/>
             </a:pPr>
             <a:r>
-              <a:rPr lang="en-US" sz="1150" b="1" dirty="0">
+              <a:rPr lang="en-US" sz="1000" b="1" dirty="0">
                 <a:solidFill>
                   <a:srgbClr val="1C2230"/>
                 </a:solidFill>
@@ -6364,7 +6364,7 @@
               </a:rPr>
               <a:t>± 8</a:t>
             </a:r>
-            <a:endParaRPr lang="en-US" sz="1150" dirty="0"/>
+            <a:endParaRPr lang="en-US" sz="1000" dirty="0"/>
           </a:p>
         </p:txBody>
       </p:sp>
@@ -6376,8 +6376,8 @@
         </p:nvSpPr>
         <p:spPr>
           <a:xfrm>
-            <a:off x="825498" y="4429749"/>
-            <a:ext cx="3124192" cy="0"/>
+            <a:off x="774698" y="4429749"/>
+            <a:ext cx="2327269" cy="0"/>
           </a:xfrm>
           <a:prstGeom prst="line">
             <a:avLst/>
@@ -6399,24 +6399,24 @@
         </p:nvSpPr>
         <p:spPr>
           <a:xfrm>
-            <a:off x="825498" y="4429749"/>
-            <a:ext cx="2578094" cy="350519"/>
-          </a:xfrm>
-          <a:prstGeom prst="rect">
-            <a:avLst/>
-          </a:prstGeom>
-          <a:noFill/>
-          <a:ln/>
-        </p:spPr>
-        <p:txBody>
-          <a:bodyPr wrap="square" lIns="0" tIns="0" rIns="0" bIns="0" rtlCol="0" anchor="ctr"/>
-          <a:lstStyle/>
-          <a:p>
-            <a:pPr indent="0" marL="0">
-              <a:buNone/>
-            </a:pPr>
-            <a:r>
-              <a:rPr lang="en-US" sz="950" dirty="0">
+            <a:off x="774698" y="4429749"/>
+            <a:ext cx="1730371" cy="350519"/>
+          </a:xfrm>
+          <a:prstGeom prst="rect">
+            <a:avLst/>
+          </a:prstGeom>
+          <a:noFill/>
+          <a:ln/>
+        </p:spPr>
+        <p:txBody>
+          <a:bodyPr wrap="square" lIns="0" tIns="0" rIns="0" bIns="0" rtlCol="0" anchor="ctr"/>
+          <a:lstStyle/>
+          <a:p>
+            <a:pPr indent="0" marL="0">
+              <a:buNone/>
+            </a:pPr>
+            <a:r>
+              <a:rPr lang="en-US" sz="800" dirty="0">
                 <a:solidFill>
                   <a:srgbClr val="6F6A5C"/>
                 </a:solidFill>
@@ -6424,9 +6424,9 @@
                 <a:ea typeface="Arial" pitchFamily="34" charset="-122"/>
                 <a:cs typeface="Arial" pitchFamily="34" charset="-120"/>
               </a:rPr>
-              <a:t>Prijs per beldag</a:t>
-            </a:r>
-            <a:endParaRPr lang="en-US" sz="950" dirty="0"/>
+              <a:t>Per beldag</a:t>
+            </a:r>
+            <a:endParaRPr lang="en-US" sz="800" dirty="0"/>
           </a:p>
         </p:txBody>
       </p:sp>
@@ -6438,7 +6438,7 @@
         </p:nvSpPr>
         <p:spPr>
           <a:xfrm>
-            <a:off x="3124192" y="4429749"/>
+            <a:off x="2276469" y="4429749"/>
             <a:ext cx="825498" cy="350519"/>
           </a:xfrm>
           <a:prstGeom prst="rect">
@@ -6455,7 +6455,7 @@
               <a:buNone/>
             </a:pPr>
             <a:r>
-              <a:rPr lang="en-US" sz="1150" b="1" dirty="0">
+              <a:rPr lang="en-US" sz="1000" b="1" dirty="0">
                 <a:solidFill>
                   <a:srgbClr val="1C2230"/>
                 </a:solidFill>
@@ -6465,7 +6465,7 @@
               </a:rPr>
               <a:t>± € 593</a:t>
             </a:r>
-            <a:endParaRPr lang="en-US" sz="1150" dirty="0"/>
+            <a:endParaRPr lang="en-US" sz="1000" dirty="0"/>
           </a:p>
         </p:txBody>
       </p:sp>
@@ -6477,8 +6477,8 @@
         </p:nvSpPr>
         <p:spPr>
           <a:xfrm>
-            <a:off x="825498" y="4780268"/>
-            <a:ext cx="3124192" cy="0"/>
+            <a:off x="774698" y="4780268"/>
+            <a:ext cx="2327269" cy="0"/>
           </a:xfrm>
           <a:prstGeom prst="line">
             <a:avLst/>
@@ -6500,24 +6500,24 @@
         </p:nvSpPr>
         <p:spPr>
           <a:xfrm>
-            <a:off x="825498" y="4780268"/>
-            <a:ext cx="2578094" cy="350519"/>
-          </a:xfrm>
-          <a:prstGeom prst="rect">
-            <a:avLst/>
-          </a:prstGeom>
-          <a:noFill/>
-          <a:ln/>
-        </p:spPr>
-        <p:txBody>
-          <a:bodyPr wrap="square" lIns="0" tIns="0" rIns="0" bIns="0" rtlCol="0" anchor="ctr"/>
-          <a:lstStyle/>
-          <a:p>
-            <a:pPr indent="0" marL="0">
-              <a:buNone/>
-            </a:pPr>
-            <a:r>
-              <a:rPr lang="en-US" sz="950" dirty="0">
+            <a:off x="774698" y="4780268"/>
+            <a:ext cx="1730371" cy="350519"/>
+          </a:xfrm>
+          <a:prstGeom prst="rect">
+            <a:avLst/>
+          </a:prstGeom>
+          <a:noFill/>
+          <a:ln/>
+        </p:spPr>
+        <p:txBody>
+          <a:bodyPr wrap="square" lIns="0" tIns="0" rIns="0" bIns="0" rtlCol="0" anchor="ctr"/>
+          <a:lstStyle/>
+          <a:p>
+            <a:pPr indent="0" marL="0">
+              <a:buNone/>
+            </a:pPr>
+            <a:r>
+              <a:rPr lang="en-US" sz="800" dirty="0">
                 <a:solidFill>
                   <a:srgbClr val="6F6A5C"/>
                 </a:solidFill>
@@ -6525,9 +6525,9 @@
                 <a:ea typeface="Arial" pitchFamily="34" charset="-122"/>
                 <a:cs typeface="Arial" pitchFamily="34" charset="-120"/>
               </a:rPr>
-              <a:t>Prijs per werkperiode</a:t>
-            </a:r>
-            <a:endParaRPr lang="en-US" sz="950" dirty="0"/>
+              <a:t>Per werkperiode</a:t>
+            </a:r>
+            <a:endParaRPr lang="en-US" sz="800" dirty="0"/>
           </a:p>
         </p:txBody>
       </p:sp>
@@ -6539,7 +6539,7 @@
         </p:nvSpPr>
         <p:spPr>
           <a:xfrm>
-            <a:off x="3124192" y="4780268"/>
+            <a:off x="2276469" y="4780268"/>
             <a:ext cx="825498" cy="350519"/>
           </a:xfrm>
           <a:prstGeom prst="rect">
@@ -6556,7 +6556,7 @@
               <a:buNone/>
             </a:pPr>
             <a:r>
-              <a:rPr lang="en-US" sz="1150" b="1" dirty="0">
+              <a:rPr lang="en-US" sz="1000" b="1" dirty="0">
                 <a:solidFill>
                   <a:srgbClr val="1C2230"/>
                 </a:solidFill>
@@ -6566,7 +6566,7 @@
               </a:rPr>
               <a:t>€ 1.600</a:t>
             </a:r>
-            <a:endParaRPr lang="en-US" sz="1150" dirty="0"/>
+            <a:endParaRPr lang="en-US" sz="1000" dirty="0"/>
           </a:p>
         </p:txBody>
       </p:sp>
@@ -6578,12 +6578,12 @@
         </p:nvSpPr>
         <p:spPr>
           <a:xfrm>
-            <a:off x="4317989" y="2489194"/>
-            <a:ext cx="3555991" cy="2768593"/>
+            <a:off x="3381367" y="2489194"/>
+            <a:ext cx="2657468" cy="2768593"/>
           </a:xfrm>
           <a:prstGeom prst="roundRect">
             <a:avLst>
-              <a:gd name="adj" fmla="val 3670"/>
+              <a:gd name="adj" fmla="val 3823"/>
             </a:avLst>
           </a:prstGeom>
           <a:solidFill>
@@ -6600,8 +6600,8 @@
         </p:nvSpPr>
         <p:spPr>
           <a:xfrm>
-            <a:off x="4533889" y="2743193"/>
-            <a:ext cx="3124192" cy="190500"/>
+            <a:off x="3546466" y="2743193"/>
+            <a:ext cx="2327269" cy="190500"/>
           </a:xfrm>
           <a:prstGeom prst="rect">
             <a:avLst/>
@@ -6625,7 +6625,7 @@
                 <a:ea typeface="Arial" pitchFamily="34" charset="-122"/>
                 <a:cs typeface="Arial" pitchFamily="34" charset="-120"/>
               </a:rPr>
-              <a:t>VANAF WERKPERIODE 4</a:t>
+              <a:t>VOORSTEL</a:t>
             </a:r>
             <a:endParaRPr lang="en-US" sz="800" dirty="0"/>
           </a:p>
@@ -6639,8 +6639,8 @@
         </p:nvSpPr>
         <p:spPr>
           <a:xfrm>
-            <a:off x="4533889" y="2959093"/>
-            <a:ext cx="3124192" cy="355599"/>
+            <a:off x="3546466" y="2959093"/>
+            <a:ext cx="2327269" cy="355599"/>
           </a:xfrm>
           <a:prstGeom prst="rect">
             <a:avLst/>
@@ -6659,7 +6659,7 @@
               <a:buNone/>
             </a:pPr>
             <a:r>
-              <a:rPr lang="en-US" sz="1250" b="1" dirty="0">
+              <a:rPr lang="en-US" sz="1050" b="1" dirty="0">
                 <a:solidFill>
                   <a:srgbClr val="F2EFE6"/>
                 </a:solidFill>
@@ -6667,9 +6667,9 @@
                 <a:ea typeface="Arial" pitchFamily="34" charset="-122"/>
                 <a:cs typeface="Arial" pitchFamily="34" charset="-120"/>
               </a:rPr>
-              <a:t>Vier beldagen per vier weken</a:t>
-            </a:r>
-            <a:endParaRPr lang="en-US" sz="1250" dirty="0"/>
+              <a:t>Vier beldagen</a:t>
+            </a:r>
+            <a:endParaRPr lang="en-US" sz="1050" dirty="0"/>
           </a:p>
         </p:txBody>
       </p:sp>
@@ -6681,24 +6681,24 @@
         </p:nvSpPr>
         <p:spPr>
           <a:xfrm>
-            <a:off x="4533889" y="3378192"/>
-            <a:ext cx="2578094" cy="350519"/>
-          </a:xfrm>
-          <a:prstGeom prst="rect">
-            <a:avLst/>
-          </a:prstGeom>
-          <a:noFill/>
-          <a:ln/>
-        </p:spPr>
-        <p:txBody>
-          <a:bodyPr wrap="square" lIns="0" tIns="0" rIns="0" bIns="0" rtlCol="0" anchor="ctr"/>
-          <a:lstStyle/>
-          <a:p>
-            <a:pPr indent="0" marL="0">
-              <a:buNone/>
-            </a:pPr>
-            <a:r>
-              <a:rPr lang="en-US" sz="950" dirty="0">
+            <a:off x="3546466" y="3378192"/>
+            <a:ext cx="1730371" cy="350519"/>
+          </a:xfrm>
+          <a:prstGeom prst="rect">
+            <a:avLst/>
+          </a:prstGeom>
+          <a:noFill/>
+          <a:ln/>
+        </p:spPr>
+        <p:txBody>
+          <a:bodyPr wrap="square" lIns="0" tIns="0" rIns="0" bIns="0" rtlCol="0" anchor="ctr"/>
+          <a:lstStyle/>
+          <a:p>
+            <a:pPr indent="0" marL="0">
+              <a:buNone/>
+            </a:pPr>
+            <a:r>
+              <a:rPr lang="en-US" sz="800" dirty="0">
                 <a:solidFill>
                   <a:srgbClr val="C2C8D2"/>
                 </a:solidFill>
@@ -6706,9 +6706,9 @@
                 <a:ea typeface="Arial" pitchFamily="34" charset="-122"/>
                 <a:cs typeface="Arial" pitchFamily="34" charset="-120"/>
               </a:rPr>
-              <a:t>Beldagen per periode</a:t>
-            </a:r>
-            <a:endParaRPr lang="en-US" sz="950" dirty="0"/>
+              <a:t>Beldagen</a:t>
+            </a:r>
+            <a:endParaRPr lang="en-US" sz="800" dirty="0"/>
           </a:p>
         </p:txBody>
       </p:sp>
@@ -6720,7 +6720,7 @@
         </p:nvSpPr>
         <p:spPr>
           <a:xfrm>
-            <a:off x="6832583" y="3378192"/>
+            <a:off x="5048237" y="3378192"/>
             <a:ext cx="825498" cy="350519"/>
           </a:xfrm>
           <a:prstGeom prst="rect">
@@ -6737,7 +6737,7 @@
               <a:buNone/>
             </a:pPr>
             <a:r>
-              <a:rPr lang="en-US" sz="1150" b="1" dirty="0">
+              <a:rPr lang="en-US" sz="1000" b="1" dirty="0">
                 <a:solidFill>
                   <a:srgbClr val="38B6FF"/>
                 </a:solidFill>
@@ -6747,7 +6747,7 @@
               </a:rPr>
               <a:t>4</a:t>
             </a:r>
-            <a:endParaRPr lang="en-US" sz="1150" dirty="0"/>
+            <a:endParaRPr lang="en-US" sz="1000" dirty="0"/>
           </a:p>
         </p:txBody>
       </p:sp>
@@ -6759,8 +6759,8 @@
         </p:nvSpPr>
         <p:spPr>
           <a:xfrm>
-            <a:off x="4533889" y="3728711"/>
-            <a:ext cx="3124192" cy="0"/>
+            <a:off x="3546466" y="3728711"/>
+            <a:ext cx="2327269" cy="0"/>
           </a:xfrm>
           <a:prstGeom prst="line">
             <a:avLst/>
@@ -6782,24 +6782,24 @@
         </p:nvSpPr>
         <p:spPr>
           <a:xfrm>
-            <a:off x="4533889" y="3728711"/>
-            <a:ext cx="2578094" cy="350519"/>
-          </a:xfrm>
-          <a:prstGeom prst="rect">
-            <a:avLst/>
-          </a:prstGeom>
-          <a:noFill/>
-          <a:ln/>
-        </p:spPr>
-        <p:txBody>
-          <a:bodyPr wrap="square" lIns="0" tIns="0" rIns="0" bIns="0" rtlCol="0" anchor="ctr"/>
-          <a:lstStyle/>
-          <a:p>
-            <a:pPr indent="0" marL="0">
-              <a:buNone/>
-            </a:pPr>
-            <a:r>
-              <a:rPr lang="en-US" sz="950" dirty="0">
+            <a:off x="3546466" y="3728711"/>
+            <a:ext cx="1730371" cy="350519"/>
+          </a:xfrm>
+          <a:prstGeom prst="rect">
+            <a:avLst/>
+          </a:prstGeom>
+          <a:noFill/>
+          <a:ln/>
+        </p:spPr>
+        <p:txBody>
+          <a:bodyPr wrap="square" lIns="0" tIns="0" rIns="0" bIns="0" rtlCol="0" anchor="ctr"/>
+          <a:lstStyle/>
+          <a:p>
+            <a:pPr indent="0" marL="0">
+              <a:buNone/>
+            </a:pPr>
+            <a:r>
+              <a:rPr lang="en-US" sz="800" dirty="0">
                 <a:solidFill>
                   <a:srgbClr val="C2C8D2"/>
                 </a:solidFill>
@@ -6809,7 +6809,7 @@
               </a:rPr>
               <a:t>Contactpogingen</a:t>
             </a:r>
-            <a:endParaRPr lang="en-US" sz="950" dirty="0"/>
+            <a:endParaRPr lang="en-US" sz="800" dirty="0"/>
           </a:p>
         </p:txBody>
       </p:sp>
@@ -6821,7 +6821,7 @@
         </p:nvSpPr>
         <p:spPr>
           <a:xfrm>
-            <a:off x="6832583" y="3728711"/>
+            <a:off x="5048237" y="3728711"/>
             <a:ext cx="825498" cy="350519"/>
           </a:xfrm>
           <a:prstGeom prst="rect">
@@ -6838,7 +6838,7 @@
               <a:buNone/>
             </a:pPr>
             <a:r>
-              <a:rPr lang="en-US" sz="1150" b="1" dirty="0">
+              <a:rPr lang="en-US" sz="1000" b="1" dirty="0">
                 <a:solidFill>
                   <a:srgbClr val="38B6FF"/>
                 </a:solidFill>
@@ -6848,7 +6848,7 @@
               </a:rPr>
               <a:t>600</a:t>
             </a:r>
-            <a:endParaRPr lang="en-US" sz="1150" dirty="0"/>
+            <a:endParaRPr lang="en-US" sz="1000" dirty="0"/>
           </a:p>
         </p:txBody>
       </p:sp>
@@ -6860,8 +6860,8 @@
         </p:nvSpPr>
         <p:spPr>
           <a:xfrm>
-            <a:off x="4533889" y="4079230"/>
-            <a:ext cx="3124192" cy="0"/>
+            <a:off x="3546466" y="4079230"/>
+            <a:ext cx="2327269" cy="0"/>
           </a:xfrm>
           <a:prstGeom prst="line">
             <a:avLst/>
@@ -6883,24 +6883,24 @@
         </p:nvSpPr>
         <p:spPr>
           <a:xfrm>
-            <a:off x="4533889" y="4079230"/>
-            <a:ext cx="2578094" cy="350519"/>
-          </a:xfrm>
-          <a:prstGeom prst="rect">
-            <a:avLst/>
-          </a:prstGeom>
-          <a:noFill/>
-          <a:ln/>
-        </p:spPr>
-        <p:txBody>
-          <a:bodyPr wrap="square" lIns="0" tIns="0" rIns="0" bIns="0" rtlCol="0" anchor="ctr"/>
-          <a:lstStyle/>
-          <a:p>
-            <a:pPr indent="0" marL="0">
-              <a:buNone/>
-            </a:pPr>
-            <a:r>
-              <a:rPr lang="en-US" sz="950" dirty="0">
+            <a:off x="3546466" y="4079230"/>
+            <a:ext cx="1730371" cy="350519"/>
+          </a:xfrm>
+          <a:prstGeom prst="rect">
+            <a:avLst/>
+          </a:prstGeom>
+          <a:noFill/>
+          <a:ln/>
+        </p:spPr>
+        <p:txBody>
+          <a:bodyPr wrap="square" lIns="0" tIns="0" rIns="0" bIns="0" rtlCol="0" anchor="ctr"/>
+          <a:lstStyle/>
+          <a:p>
+            <a:pPr indent="0" marL="0">
+              <a:buNone/>
+            </a:pPr>
+            <a:r>
+              <a:rPr lang="en-US" sz="800" dirty="0">
                 <a:solidFill>
                   <a:srgbClr val="C2C8D2"/>
                 </a:solidFill>
@@ -6908,9 +6908,9 @@
                 <a:ea typeface="Arial" pitchFamily="34" charset="-122"/>
                 <a:cs typeface="Arial" pitchFamily="34" charset="-120"/>
               </a:rPr>
-              <a:t>Gekwalificeerde afspraken</a:t>
-            </a:r>
-            <a:endParaRPr lang="en-US" sz="950" dirty="0"/>
+              <a:t>Afspraken</a:t>
+            </a:r>
+            <a:endParaRPr lang="en-US" sz="800" dirty="0"/>
           </a:p>
         </p:txBody>
       </p:sp>
@@ -6922,7 +6922,7 @@
         </p:nvSpPr>
         <p:spPr>
           <a:xfrm>
-            <a:off x="6832583" y="4079230"/>
+            <a:off x="5048237" y="4079230"/>
             <a:ext cx="825498" cy="350519"/>
           </a:xfrm>
           <a:prstGeom prst="rect">
@@ -6939,7 +6939,7 @@
               <a:buNone/>
             </a:pPr>
             <a:r>
-              <a:rPr lang="en-US" sz="1150" b="1" dirty="0">
+              <a:rPr lang="en-US" sz="1000" b="1" dirty="0">
                 <a:solidFill>
                   <a:srgbClr val="38B6FF"/>
                 </a:solidFill>
@@ -6949,7 +6949,7 @@
               </a:rPr>
               <a:t>10</a:t>
             </a:r>
-            <a:endParaRPr lang="en-US" sz="1150" dirty="0"/>
+            <a:endParaRPr lang="en-US" sz="1000" dirty="0"/>
           </a:p>
         </p:txBody>
       </p:sp>
@@ -6961,8 +6961,8 @@
         </p:nvSpPr>
         <p:spPr>
           <a:xfrm>
-            <a:off x="4533889" y="4429749"/>
-            <a:ext cx="3124192" cy="0"/>
+            <a:off x="3546466" y="4429749"/>
+            <a:ext cx="2327269" cy="0"/>
           </a:xfrm>
           <a:prstGeom prst="line">
             <a:avLst/>
@@ -6984,24 +6984,24 @@
         </p:nvSpPr>
         <p:spPr>
           <a:xfrm>
-            <a:off x="4533889" y="4429749"/>
-            <a:ext cx="2578094" cy="350519"/>
-          </a:xfrm>
-          <a:prstGeom prst="rect">
-            <a:avLst/>
-          </a:prstGeom>
-          <a:noFill/>
-          <a:ln/>
-        </p:spPr>
-        <p:txBody>
-          <a:bodyPr wrap="square" lIns="0" tIns="0" rIns="0" bIns="0" rtlCol="0" anchor="ctr"/>
-          <a:lstStyle/>
-          <a:p>
-            <a:pPr indent="0" marL="0">
-              <a:buNone/>
-            </a:pPr>
-            <a:r>
-              <a:rPr lang="en-US" sz="950" dirty="0">
+            <a:off x="3546466" y="4429749"/>
+            <a:ext cx="1730371" cy="350519"/>
+          </a:xfrm>
+          <a:prstGeom prst="rect">
+            <a:avLst/>
+          </a:prstGeom>
+          <a:noFill/>
+          <a:ln/>
+        </p:spPr>
+        <p:txBody>
+          <a:bodyPr wrap="square" lIns="0" tIns="0" rIns="0" bIns="0" rtlCol="0" anchor="ctr"/>
+          <a:lstStyle/>
+          <a:p>
+            <a:pPr indent="0" marL="0">
+              <a:buNone/>
+            </a:pPr>
+            <a:r>
+              <a:rPr lang="en-US" sz="800" dirty="0">
                 <a:solidFill>
                   <a:srgbClr val="C2C8D2"/>
                 </a:solidFill>
@@ -7009,9 +7009,9 @@
                 <a:ea typeface="Arial" pitchFamily="34" charset="-122"/>
                 <a:cs typeface="Arial" pitchFamily="34" charset="-120"/>
               </a:rPr>
-              <a:t>Prijs per beldag</a:t>
-            </a:r>
-            <a:endParaRPr lang="en-US" sz="950" dirty="0"/>
+              <a:t>Per beldag</a:t>
+            </a:r>
+            <a:endParaRPr lang="en-US" sz="800" dirty="0"/>
           </a:p>
         </p:txBody>
       </p:sp>
@@ -7023,7 +7023,7 @@
         </p:nvSpPr>
         <p:spPr>
           <a:xfrm>
-            <a:off x="6832583" y="4429749"/>
+            <a:off x="5048237" y="4429749"/>
             <a:ext cx="825498" cy="350519"/>
           </a:xfrm>
           <a:prstGeom prst="rect">
@@ -7040,7 +7040,7 @@
               <a:buNone/>
             </a:pPr>
             <a:r>
-              <a:rPr lang="en-US" sz="1150" b="1" dirty="0">
+              <a:rPr lang="en-US" sz="1000" b="1" dirty="0">
                 <a:solidFill>
                   <a:srgbClr val="38B6FF"/>
                 </a:solidFill>
@@ -7050,7 +7050,7 @@
               </a:rPr>
               <a:t>€ 600</a:t>
             </a:r>
-            <a:endParaRPr lang="en-US" sz="1150" dirty="0"/>
+            <a:endParaRPr lang="en-US" sz="1000" dirty="0"/>
           </a:p>
         </p:txBody>
       </p:sp>
@@ -7062,8 +7062,8 @@
         </p:nvSpPr>
         <p:spPr>
           <a:xfrm>
-            <a:off x="4533889" y="4780268"/>
-            <a:ext cx="3124192" cy="0"/>
+            <a:off x="3546466" y="4780268"/>
+            <a:ext cx="2327269" cy="0"/>
           </a:xfrm>
           <a:prstGeom prst="line">
             <a:avLst/>
@@ -7085,24 +7085,24 @@
         </p:nvSpPr>
         <p:spPr>
           <a:xfrm>
-            <a:off x="4533889" y="4780268"/>
-            <a:ext cx="2578094" cy="350519"/>
-          </a:xfrm>
-          <a:prstGeom prst="rect">
-            <a:avLst/>
-          </a:prstGeom>
-          <a:noFill/>
-          <a:ln/>
-        </p:spPr>
-        <p:txBody>
-          <a:bodyPr wrap="square" lIns="0" tIns="0" rIns="0" bIns="0" rtlCol="0" anchor="ctr"/>
-          <a:lstStyle/>
-          <a:p>
-            <a:pPr indent="0" marL="0">
-              <a:buNone/>
-            </a:pPr>
-            <a:r>
-              <a:rPr lang="en-US" sz="950" dirty="0">
+            <a:off x="3546466" y="4780268"/>
+            <a:ext cx="1730371" cy="350519"/>
+          </a:xfrm>
+          <a:prstGeom prst="rect">
+            <a:avLst/>
+          </a:prstGeom>
+          <a:noFill/>
+          <a:ln/>
+        </p:spPr>
+        <p:txBody>
+          <a:bodyPr wrap="square" lIns="0" tIns="0" rIns="0" bIns="0" rtlCol="0" anchor="ctr"/>
+          <a:lstStyle/>
+          <a:p>
+            <a:pPr indent="0" marL="0">
+              <a:buNone/>
+            </a:pPr>
+            <a:r>
+              <a:rPr lang="en-US" sz="800" dirty="0">
                 <a:solidFill>
                   <a:srgbClr val="C2C8D2"/>
                 </a:solidFill>
@@ -7110,9 +7110,9 @@
                 <a:ea typeface="Arial" pitchFamily="34" charset="-122"/>
                 <a:cs typeface="Arial" pitchFamily="34" charset="-120"/>
               </a:rPr>
-              <a:t>Prijs per werkperiode</a:t>
-            </a:r>
-            <a:endParaRPr lang="en-US" sz="950" dirty="0"/>
+              <a:t>Per werkperiode</a:t>
+            </a:r>
+            <a:endParaRPr lang="en-US" sz="800" dirty="0"/>
           </a:p>
         </p:txBody>
       </p:sp>
@@ -7124,7 +7124,7 @@
         </p:nvSpPr>
         <p:spPr>
           <a:xfrm>
-            <a:off x="6832583" y="4780268"/>
+            <a:off x="5048237" y="4780268"/>
             <a:ext cx="825498" cy="350519"/>
           </a:xfrm>
           <a:prstGeom prst="rect">
@@ -7141,7 +7141,7 @@
               <a:buNone/>
             </a:pPr>
             <a:r>
-              <a:rPr lang="en-US" sz="1150" b="1" dirty="0">
+              <a:rPr lang="en-US" sz="1000" b="1" dirty="0">
                 <a:solidFill>
                   <a:srgbClr val="38B6FF"/>
                 </a:solidFill>
@@ -7151,7 +7151,7 @@
               </a:rPr>
               <a:t>€ 2.400</a:t>
             </a:r>
-            <a:endParaRPr lang="en-US" sz="1150" dirty="0"/>
+            <a:endParaRPr lang="en-US" sz="1000" dirty="0"/>
           </a:p>
         </p:txBody>
       </p:sp>
@@ -7163,12 +7163,12 @@
         </p:nvSpPr>
         <p:spPr>
           <a:xfrm>
-            <a:off x="8026380" y="2489194"/>
-            <a:ext cx="3555991" cy="2768593"/>
+            <a:off x="6153135" y="2489194"/>
+            <a:ext cx="2657468" cy="2768593"/>
           </a:xfrm>
           <a:prstGeom prst="roundRect">
             <a:avLst>
-              <a:gd name="adj" fmla="val 3670"/>
+              <a:gd name="adj" fmla="val 3823"/>
             </a:avLst>
           </a:prstGeom>
           <a:solidFill>
@@ -7185,8 +7185,8 @@
         </p:nvSpPr>
         <p:spPr>
           <a:xfrm>
-            <a:off x="8242279" y="2743193"/>
-            <a:ext cx="3124192" cy="190500"/>
+            <a:off x="6318234" y="2743193"/>
+            <a:ext cx="2327269" cy="190500"/>
           </a:xfrm>
           <a:prstGeom prst="rect">
             <a:avLst/>
@@ -7210,7 +7210,7 @@
                 <a:ea typeface="Arial" pitchFamily="34" charset="-122"/>
                 <a:cs typeface="Arial" pitchFamily="34" charset="-120"/>
               </a:rPr>
-              <a:t>OF DUBBEL</a:t>
+              <a:t>OF</a:t>
             </a:r>
             <a:endParaRPr lang="en-US" sz="800" dirty="0"/>
           </a:p>
@@ -7224,8 +7224,8 @@
         </p:nvSpPr>
         <p:spPr>
           <a:xfrm>
-            <a:off x="8242279" y="2959093"/>
-            <a:ext cx="3124192" cy="355599"/>
+            <a:off x="6318234" y="2959093"/>
+            <a:ext cx="2327269" cy="355599"/>
           </a:xfrm>
           <a:prstGeom prst="rect">
             <a:avLst/>
@@ -7244,7 +7244,7 @@
               <a:buNone/>
             </a:pPr>
             <a:r>
-              <a:rPr lang="en-US" sz="1250" b="1" dirty="0">
+              <a:rPr lang="en-US" sz="1050" b="1" dirty="0">
                 <a:solidFill>
                   <a:srgbClr val="1C2230"/>
                 </a:solidFill>
@@ -7252,9 +7252,9 @@
                 <a:ea typeface="Arial" pitchFamily="34" charset="-122"/>
                 <a:cs typeface="Arial" pitchFamily="34" charset="-120"/>
               </a:rPr>
-              <a:t>Acht beldagen per vier weken</a:t>
-            </a:r>
-            <a:endParaRPr lang="en-US" sz="1250" dirty="0"/>
+              <a:t>Zes beldagen</a:t>
+            </a:r>
+            <a:endParaRPr lang="en-US" sz="1050" dirty="0"/>
           </a:p>
         </p:txBody>
       </p:sp>
@@ -7266,24 +7266,24 @@
         </p:nvSpPr>
         <p:spPr>
           <a:xfrm>
-            <a:off x="8242279" y="3378192"/>
-            <a:ext cx="2578094" cy="350519"/>
-          </a:xfrm>
-          <a:prstGeom prst="rect">
-            <a:avLst/>
-          </a:prstGeom>
-          <a:noFill/>
-          <a:ln/>
-        </p:spPr>
-        <p:txBody>
-          <a:bodyPr wrap="square" lIns="0" tIns="0" rIns="0" bIns="0" rtlCol="0" anchor="ctr"/>
-          <a:lstStyle/>
-          <a:p>
-            <a:pPr indent="0" marL="0">
-              <a:buNone/>
-            </a:pPr>
-            <a:r>
-              <a:rPr lang="en-US" sz="950" dirty="0">
+            <a:off x="6318234" y="3378192"/>
+            <a:ext cx="1730371" cy="350519"/>
+          </a:xfrm>
+          <a:prstGeom prst="rect">
+            <a:avLst/>
+          </a:prstGeom>
+          <a:noFill/>
+          <a:ln/>
+        </p:spPr>
+        <p:txBody>
+          <a:bodyPr wrap="square" lIns="0" tIns="0" rIns="0" bIns="0" rtlCol="0" anchor="ctr"/>
+          <a:lstStyle/>
+          <a:p>
+            <a:pPr indent="0" marL="0">
+              <a:buNone/>
+            </a:pPr>
+            <a:r>
+              <a:rPr lang="en-US" sz="800" dirty="0">
                 <a:solidFill>
                   <a:srgbClr val="6F6A5C"/>
                 </a:solidFill>
@@ -7291,9 +7291,9 @@
                 <a:ea typeface="Arial" pitchFamily="34" charset="-122"/>
                 <a:cs typeface="Arial" pitchFamily="34" charset="-120"/>
               </a:rPr>
-              <a:t>Beldagen per periode</a:t>
-            </a:r>
-            <a:endParaRPr lang="en-US" sz="950" dirty="0"/>
+              <a:t>Beldagen</a:t>
+            </a:r>
+            <a:endParaRPr lang="en-US" sz="800" dirty="0"/>
           </a:p>
         </p:txBody>
       </p:sp>
@@ -7305,7 +7305,7 @@
         </p:nvSpPr>
         <p:spPr>
           <a:xfrm>
-            <a:off x="10540974" y="3378192"/>
+            <a:off x="7820005" y="3378192"/>
             <a:ext cx="825498" cy="350519"/>
           </a:xfrm>
           <a:prstGeom prst="rect">
@@ -7322,7 +7322,7 @@
               <a:buNone/>
             </a:pPr>
             <a:r>
-              <a:rPr lang="en-US" sz="1150" b="1" dirty="0">
+              <a:rPr lang="en-US" sz="1000" b="1" dirty="0">
                 <a:solidFill>
                   <a:srgbClr val="1C2230"/>
                 </a:solidFill>
@@ -7330,9 +7330,9 @@
                 <a:ea typeface="Arial" pitchFamily="34" charset="-122"/>
                 <a:cs typeface="Arial" pitchFamily="34" charset="-120"/>
               </a:rPr>
-              <a:t>8</a:t>
-            </a:r>
-            <a:endParaRPr lang="en-US" sz="1150" dirty="0"/>
+              <a:t>6</a:t>
+            </a:r>
+            <a:endParaRPr lang="en-US" sz="1000" dirty="0"/>
           </a:p>
         </p:txBody>
       </p:sp>
@@ -7344,8 +7344,8 @@
         </p:nvSpPr>
         <p:spPr>
           <a:xfrm>
-            <a:off x="8242279" y="3728711"/>
-            <a:ext cx="3124192" cy="0"/>
+            <a:off x="6318234" y="3728711"/>
+            <a:ext cx="2327269" cy="0"/>
           </a:xfrm>
           <a:prstGeom prst="line">
             <a:avLst/>
@@ -7367,24 +7367,24 @@
         </p:nvSpPr>
         <p:spPr>
           <a:xfrm>
-            <a:off x="8242279" y="3728711"/>
-            <a:ext cx="2578094" cy="350519"/>
-          </a:xfrm>
-          <a:prstGeom prst="rect">
-            <a:avLst/>
-          </a:prstGeom>
-          <a:noFill/>
-          <a:ln/>
-        </p:spPr>
-        <p:txBody>
-          <a:bodyPr wrap="square" lIns="0" tIns="0" rIns="0" bIns="0" rtlCol="0" anchor="ctr"/>
-          <a:lstStyle/>
-          <a:p>
-            <a:pPr indent="0" marL="0">
-              <a:buNone/>
-            </a:pPr>
-            <a:r>
-              <a:rPr lang="en-US" sz="950" dirty="0">
+            <a:off x="6318234" y="3728711"/>
+            <a:ext cx="1730371" cy="350519"/>
+          </a:xfrm>
+          <a:prstGeom prst="rect">
+            <a:avLst/>
+          </a:prstGeom>
+          <a:noFill/>
+          <a:ln/>
+        </p:spPr>
+        <p:txBody>
+          <a:bodyPr wrap="square" lIns="0" tIns="0" rIns="0" bIns="0" rtlCol="0" anchor="ctr"/>
+          <a:lstStyle/>
+          <a:p>
+            <a:pPr indent="0" marL="0">
+              <a:buNone/>
+            </a:pPr>
+            <a:r>
+              <a:rPr lang="en-US" sz="800" dirty="0">
                 <a:solidFill>
                   <a:srgbClr val="6F6A5C"/>
                 </a:solidFill>
@@ -7394,7 +7394,7 @@
               </a:rPr>
               <a:t>Contactpogingen</a:t>
             </a:r>
-            <a:endParaRPr lang="en-US" sz="950" dirty="0"/>
+            <a:endParaRPr lang="en-US" sz="800" dirty="0"/>
           </a:p>
         </p:txBody>
       </p:sp>
@@ -7406,7 +7406,7 @@
         </p:nvSpPr>
         <p:spPr>
           <a:xfrm>
-            <a:off x="10540974" y="3728711"/>
+            <a:off x="7820005" y="3728711"/>
             <a:ext cx="825498" cy="350519"/>
           </a:xfrm>
           <a:prstGeom prst="rect">
@@ -7423,7 +7423,7 @@
               <a:buNone/>
             </a:pPr>
             <a:r>
-              <a:rPr lang="en-US" sz="1150" b="1" dirty="0">
+              <a:rPr lang="en-US" sz="1000" b="1" dirty="0">
                 <a:solidFill>
                   <a:srgbClr val="1C2230"/>
                 </a:solidFill>
@@ -7431,9 +7431,9 @@
                 <a:ea typeface="Arial" pitchFamily="34" charset="-122"/>
                 <a:cs typeface="Arial" pitchFamily="34" charset="-120"/>
               </a:rPr>
-              <a:t>1.200</a:t>
-            </a:r>
-            <a:endParaRPr lang="en-US" sz="1150" dirty="0"/>
+              <a:t>900</a:t>
+            </a:r>
+            <a:endParaRPr lang="en-US" sz="1000" dirty="0"/>
           </a:p>
         </p:txBody>
       </p:sp>
@@ -7445,8 +7445,8 @@
         </p:nvSpPr>
         <p:spPr>
           <a:xfrm>
-            <a:off x="8242279" y="4079230"/>
-            <a:ext cx="3124192" cy="0"/>
+            <a:off x="6318234" y="4079230"/>
+            <a:ext cx="2327269" cy="0"/>
           </a:xfrm>
           <a:prstGeom prst="line">
             <a:avLst/>
@@ -7468,24 +7468,24 @@
         </p:nvSpPr>
         <p:spPr>
           <a:xfrm>
-            <a:off x="8242279" y="4079230"/>
-            <a:ext cx="2578094" cy="350519"/>
-          </a:xfrm>
-          <a:prstGeom prst="rect">
-            <a:avLst/>
-          </a:prstGeom>
-          <a:noFill/>
-          <a:ln/>
-        </p:spPr>
-        <p:txBody>
-          <a:bodyPr wrap="square" lIns="0" tIns="0" rIns="0" bIns="0" rtlCol="0" anchor="ctr"/>
-          <a:lstStyle/>
-          <a:p>
-            <a:pPr indent="0" marL="0">
-              <a:buNone/>
-            </a:pPr>
-            <a:r>
-              <a:rPr lang="en-US" sz="950" dirty="0">
+            <a:off x="6318234" y="4079230"/>
+            <a:ext cx="1730371" cy="350519"/>
+          </a:xfrm>
+          <a:prstGeom prst="rect">
+            <a:avLst/>
+          </a:prstGeom>
+          <a:noFill/>
+          <a:ln/>
+        </p:spPr>
+        <p:txBody>
+          <a:bodyPr wrap="square" lIns="0" tIns="0" rIns="0" bIns="0" rtlCol="0" anchor="ctr"/>
+          <a:lstStyle/>
+          <a:p>
+            <a:pPr indent="0" marL="0">
+              <a:buNone/>
+            </a:pPr>
+            <a:r>
+              <a:rPr lang="en-US" sz="800" dirty="0">
                 <a:solidFill>
                   <a:srgbClr val="6F6A5C"/>
                 </a:solidFill>
@@ -7493,9 +7493,9 @@
                 <a:ea typeface="Arial" pitchFamily="34" charset="-122"/>
                 <a:cs typeface="Arial" pitchFamily="34" charset="-120"/>
               </a:rPr>
-              <a:t>Gekwalificeerde afspraken</a:t>
-            </a:r>
-            <a:endParaRPr lang="en-US" sz="950" dirty="0"/>
+              <a:t>Afspraken</a:t>
+            </a:r>
+            <a:endParaRPr lang="en-US" sz="800" dirty="0"/>
           </a:p>
         </p:txBody>
       </p:sp>
@@ -7507,7 +7507,7 @@
         </p:nvSpPr>
         <p:spPr>
           <a:xfrm>
-            <a:off x="10540974" y="4079230"/>
+            <a:off x="7820005" y="4079230"/>
             <a:ext cx="825498" cy="350519"/>
           </a:xfrm>
           <a:prstGeom prst="rect">
@@ -7524,7 +7524,7 @@
               <a:buNone/>
             </a:pPr>
             <a:r>
-              <a:rPr lang="en-US" sz="1150" b="1" dirty="0">
+              <a:rPr lang="en-US" sz="1000" b="1" dirty="0">
                 <a:solidFill>
                   <a:srgbClr val="1C2230"/>
                 </a:solidFill>
@@ -7532,9 +7532,9 @@
                 <a:ea typeface="Arial" pitchFamily="34" charset="-122"/>
                 <a:cs typeface="Arial" pitchFamily="34" charset="-120"/>
               </a:rPr>
-              <a:t>20</a:t>
-            </a:r>
-            <a:endParaRPr lang="en-US" sz="1150" dirty="0"/>
+              <a:t>15</a:t>
+            </a:r>
+            <a:endParaRPr lang="en-US" sz="1000" dirty="0"/>
           </a:p>
         </p:txBody>
       </p:sp>
@@ -7546,8 +7546,8 @@
         </p:nvSpPr>
         <p:spPr>
           <a:xfrm>
-            <a:off x="8242279" y="4429749"/>
-            <a:ext cx="3124192" cy="0"/>
+            <a:off x="6318234" y="4429749"/>
+            <a:ext cx="2327269" cy="0"/>
           </a:xfrm>
           <a:prstGeom prst="line">
             <a:avLst/>
@@ -7569,24 +7569,24 @@
         </p:nvSpPr>
         <p:spPr>
           <a:xfrm>
-            <a:off x="8242279" y="4429749"/>
-            <a:ext cx="2578094" cy="350519"/>
-          </a:xfrm>
-          <a:prstGeom prst="rect">
-            <a:avLst/>
-          </a:prstGeom>
-          <a:noFill/>
-          <a:ln/>
-        </p:spPr>
-        <p:txBody>
-          <a:bodyPr wrap="square" lIns="0" tIns="0" rIns="0" bIns="0" rtlCol="0" anchor="ctr"/>
-          <a:lstStyle/>
-          <a:p>
-            <a:pPr indent="0" marL="0">
-              <a:buNone/>
-            </a:pPr>
-            <a:r>
-              <a:rPr lang="en-US" sz="950" dirty="0">
+            <a:off x="6318234" y="4429749"/>
+            <a:ext cx="1730371" cy="350519"/>
+          </a:xfrm>
+          <a:prstGeom prst="rect">
+            <a:avLst/>
+          </a:prstGeom>
+          <a:noFill/>
+          <a:ln/>
+        </p:spPr>
+        <p:txBody>
+          <a:bodyPr wrap="square" lIns="0" tIns="0" rIns="0" bIns="0" rtlCol="0" anchor="ctr"/>
+          <a:lstStyle/>
+          <a:p>
+            <a:pPr indent="0" marL="0">
+              <a:buNone/>
+            </a:pPr>
+            <a:r>
+              <a:rPr lang="en-US" sz="800" dirty="0">
                 <a:solidFill>
                   <a:srgbClr val="6F6A5C"/>
                 </a:solidFill>
@@ -7594,9 +7594,9 @@
                 <a:ea typeface="Arial" pitchFamily="34" charset="-122"/>
                 <a:cs typeface="Arial" pitchFamily="34" charset="-120"/>
               </a:rPr>
-              <a:t>Prijs per beldag</a:t>
-            </a:r>
-            <a:endParaRPr lang="en-US" sz="950" dirty="0"/>
+              <a:t>Per beldag</a:t>
+            </a:r>
+            <a:endParaRPr lang="en-US" sz="800" dirty="0"/>
           </a:p>
         </p:txBody>
       </p:sp>
@@ -7608,7 +7608,7 @@
         </p:nvSpPr>
         <p:spPr>
           <a:xfrm>
-            <a:off x="10540974" y="4429749"/>
+            <a:off x="7820005" y="4429749"/>
             <a:ext cx="825498" cy="350519"/>
           </a:xfrm>
           <a:prstGeom prst="rect">
@@ -7625,7 +7625,7 @@
               <a:buNone/>
             </a:pPr>
             <a:r>
-              <a:rPr lang="en-US" sz="1150" b="1" dirty="0">
+              <a:rPr lang="en-US" sz="1000" b="1" dirty="0">
                 <a:solidFill>
                   <a:srgbClr val="1C2230"/>
                 </a:solidFill>
@@ -7633,9 +7633,9 @@
                 <a:ea typeface="Arial" pitchFamily="34" charset="-122"/>
                 <a:cs typeface="Arial" pitchFamily="34" charset="-120"/>
               </a:rPr>
-              <a:t>€ 550</a:t>
-            </a:r>
-            <a:endParaRPr lang="en-US" sz="1150" dirty="0"/>
+              <a:t>€ 575</a:t>
+            </a:r>
+            <a:endParaRPr lang="en-US" sz="1000" dirty="0"/>
           </a:p>
         </p:txBody>
       </p:sp>
@@ -7647,8 +7647,8 @@
         </p:nvSpPr>
         <p:spPr>
           <a:xfrm>
-            <a:off x="8242279" y="4780268"/>
-            <a:ext cx="3124192" cy="0"/>
+            <a:off x="6318234" y="4780268"/>
+            <a:ext cx="2327269" cy="0"/>
           </a:xfrm>
           <a:prstGeom prst="line">
             <a:avLst/>
@@ -7670,24 +7670,24 @@
         </p:nvSpPr>
         <p:spPr>
           <a:xfrm>
-            <a:off x="8242279" y="4780268"/>
-            <a:ext cx="2578094" cy="350519"/>
-          </a:xfrm>
-          <a:prstGeom prst="rect">
-            <a:avLst/>
-          </a:prstGeom>
-          <a:noFill/>
-          <a:ln/>
-        </p:spPr>
-        <p:txBody>
-          <a:bodyPr wrap="square" lIns="0" tIns="0" rIns="0" bIns="0" rtlCol="0" anchor="ctr"/>
-          <a:lstStyle/>
-          <a:p>
-            <a:pPr indent="0" marL="0">
-              <a:buNone/>
-            </a:pPr>
-            <a:r>
-              <a:rPr lang="en-US" sz="950" dirty="0">
+            <a:off x="6318234" y="4780268"/>
+            <a:ext cx="1730371" cy="350519"/>
+          </a:xfrm>
+          <a:prstGeom prst="rect">
+            <a:avLst/>
+          </a:prstGeom>
+          <a:noFill/>
+          <a:ln/>
+        </p:spPr>
+        <p:txBody>
+          <a:bodyPr wrap="square" lIns="0" tIns="0" rIns="0" bIns="0" rtlCol="0" anchor="ctr"/>
+          <a:lstStyle/>
+          <a:p>
+            <a:pPr indent="0" marL="0">
+              <a:buNone/>
+            </a:pPr>
+            <a:r>
+              <a:rPr lang="en-US" sz="800" dirty="0">
                 <a:solidFill>
                   <a:srgbClr val="6F6A5C"/>
                 </a:solidFill>
@@ -7695,9 +7695,9 @@
                 <a:ea typeface="Arial" pitchFamily="34" charset="-122"/>
                 <a:cs typeface="Arial" pitchFamily="34" charset="-120"/>
               </a:rPr>
-              <a:t>Prijs per werkperiode</a:t>
-            </a:r>
-            <a:endParaRPr lang="en-US" sz="950" dirty="0"/>
+              <a:t>Per werkperiode</a:t>
+            </a:r>
+            <a:endParaRPr lang="en-US" sz="800" dirty="0"/>
           </a:p>
         </p:txBody>
       </p:sp>
@@ -7709,7 +7709,7 @@
         </p:nvSpPr>
         <p:spPr>
           <a:xfrm>
-            <a:off x="10540974" y="4780268"/>
+            <a:off x="7820005" y="4780268"/>
             <a:ext cx="825498" cy="350519"/>
           </a:xfrm>
           <a:prstGeom prst="rect">
@@ -7726,7 +7726,7 @@
               <a:buNone/>
             </a:pPr>
             <a:r>
-              <a:rPr lang="en-US" sz="1150" b="1" dirty="0">
+              <a:rPr lang="en-US" sz="1000" b="1" dirty="0">
                 <a:solidFill>
                   <a:srgbClr val="1C2230"/>
                 </a:solidFill>
@@ -7734,15 +7734,600 @@
                 <a:ea typeface="Arial" pitchFamily="34" charset="-122"/>
                 <a:cs typeface="Arial" pitchFamily="34" charset="-120"/>
               </a:rPr>
+              <a:t>€ 3.450</a:t>
+            </a:r>
+            <a:endParaRPr lang="en-US" sz="1000" dirty="0"/>
+          </a:p>
+        </p:txBody>
+      </p:sp>
+      <p:sp>
+        <p:nvSpPr>
+          <p:cNvPr id="58" name="Shape 56"/>
+          <p:cNvSpPr/>
+          <p:nvPr/>
+        </p:nvSpPr>
+        <p:spPr>
+          <a:xfrm>
+            <a:off x="8924903" y="2489194"/>
+            <a:ext cx="2657468" cy="2768593"/>
+          </a:xfrm>
+          <a:prstGeom prst="roundRect">
+            <a:avLst>
+              <a:gd name="adj" fmla="val 3823"/>
+            </a:avLst>
+          </a:prstGeom>
+          <a:solidFill>
+            <a:srgbClr val="F8F4EB"/>
+          </a:solidFill>
+          <a:ln/>
+        </p:spPr>
+      </p:sp>
+      <p:sp>
+        <p:nvSpPr>
+          <p:cNvPr id="59" name="Text 57"/>
+          <p:cNvSpPr txBox="1"/>
+          <p:nvPr/>
+        </p:nvSpPr>
+        <p:spPr>
+          <a:xfrm>
+            <a:off x="9090002" y="2743193"/>
+            <a:ext cx="2327269" cy="190500"/>
+          </a:xfrm>
+          <a:prstGeom prst="rect">
+            <a:avLst/>
+          </a:prstGeom>
+          <a:noFill/>
+          <a:ln/>
+        </p:spPr>
+        <p:txBody>
+          <a:bodyPr wrap="square" lIns="0" tIns="0" rIns="0" bIns="0" rtlCol="0" anchor="ctr"/>
+          <a:lstStyle/>
+          <a:p>
+            <a:pPr indent="0" marL="0">
+              <a:buNone/>
+            </a:pPr>
+            <a:r>
+              <a:rPr lang="en-US" sz="800" b="1" spc="180" kern="0" dirty="0">
+                <a:solidFill>
+                  <a:srgbClr val="6F6A5C"/>
+                </a:solidFill>
+                <a:latin typeface="Arial" pitchFamily="34" charset="0"/>
+                <a:ea typeface="Arial" pitchFamily="34" charset="-122"/>
+                <a:cs typeface="Arial" pitchFamily="34" charset="-120"/>
+              </a:rPr>
+              <a:t>OF</a:t>
+            </a:r>
+            <a:endParaRPr lang="en-US" sz="800" dirty="0"/>
+          </a:p>
+        </p:txBody>
+      </p:sp>
+      <p:sp>
+        <p:nvSpPr>
+          <p:cNvPr id="60" name="Text 58"/>
+          <p:cNvSpPr txBox="1"/>
+          <p:nvPr/>
+        </p:nvSpPr>
+        <p:spPr>
+          <a:xfrm>
+            <a:off x="9090002" y="2959093"/>
+            <a:ext cx="2327269" cy="355599"/>
+          </a:xfrm>
+          <a:prstGeom prst="rect">
+            <a:avLst/>
+          </a:prstGeom>
+          <a:noFill/>
+          <a:ln/>
+        </p:spPr>
+        <p:txBody>
+          <a:bodyPr wrap="square" lIns="0" tIns="0" rIns="0" bIns="0" rtlCol="0" anchor="ctr"/>
+          <a:lstStyle/>
+          <a:p>
+            <a:pPr indent="0" marL="0">
+              <a:lnSpc>
+                <a:spcPct val="115000"/>
+              </a:lnSpc>
+              <a:buNone/>
+            </a:pPr>
+            <a:r>
+              <a:rPr lang="en-US" sz="1050" b="1" dirty="0">
+                <a:solidFill>
+                  <a:srgbClr val="1C2230"/>
+                </a:solidFill>
+                <a:latin typeface="Arial" pitchFamily="34" charset="0"/>
+                <a:ea typeface="Arial" pitchFamily="34" charset="-122"/>
+                <a:cs typeface="Arial" pitchFamily="34" charset="-120"/>
+              </a:rPr>
+              <a:t>Acht beldagen</a:t>
+            </a:r>
+            <a:endParaRPr lang="en-US" sz="1050" dirty="0"/>
+          </a:p>
+        </p:txBody>
+      </p:sp>
+      <p:sp>
+        <p:nvSpPr>
+          <p:cNvPr id="61" name="Text 59"/>
+          <p:cNvSpPr txBox="1"/>
+          <p:nvPr/>
+        </p:nvSpPr>
+        <p:spPr>
+          <a:xfrm>
+            <a:off x="9090002" y="3378192"/>
+            <a:ext cx="1730371" cy="350519"/>
+          </a:xfrm>
+          <a:prstGeom prst="rect">
+            <a:avLst/>
+          </a:prstGeom>
+          <a:noFill/>
+          <a:ln/>
+        </p:spPr>
+        <p:txBody>
+          <a:bodyPr wrap="square" lIns="0" tIns="0" rIns="0" bIns="0" rtlCol="0" anchor="ctr"/>
+          <a:lstStyle/>
+          <a:p>
+            <a:pPr indent="0" marL="0">
+              <a:buNone/>
+            </a:pPr>
+            <a:r>
+              <a:rPr lang="en-US" sz="800" dirty="0">
+                <a:solidFill>
+                  <a:srgbClr val="6F6A5C"/>
+                </a:solidFill>
+                <a:latin typeface="Arial" pitchFamily="34" charset="0"/>
+                <a:ea typeface="Arial" pitchFamily="34" charset="-122"/>
+                <a:cs typeface="Arial" pitchFamily="34" charset="-120"/>
+              </a:rPr>
+              <a:t>Beldagen</a:t>
+            </a:r>
+            <a:endParaRPr lang="en-US" sz="800" dirty="0"/>
+          </a:p>
+        </p:txBody>
+      </p:sp>
+      <p:sp>
+        <p:nvSpPr>
+          <p:cNvPr id="62" name="Text 60"/>
+          <p:cNvSpPr txBox="1"/>
+          <p:nvPr/>
+        </p:nvSpPr>
+        <p:spPr>
+          <a:xfrm>
+            <a:off x="10591774" y="3378192"/>
+            <a:ext cx="825498" cy="350519"/>
+          </a:xfrm>
+          <a:prstGeom prst="rect">
+            <a:avLst/>
+          </a:prstGeom>
+          <a:noFill/>
+          <a:ln/>
+        </p:spPr>
+        <p:txBody>
+          <a:bodyPr wrap="square" lIns="0" tIns="0" rIns="0" bIns="0" rtlCol="0" anchor="ctr"/>
+          <a:lstStyle/>
+          <a:p>
+            <a:pPr algn="r" indent="0" marL="0">
+              <a:buNone/>
+            </a:pPr>
+            <a:r>
+              <a:rPr lang="en-US" sz="1000" b="1" dirty="0">
+                <a:solidFill>
+                  <a:srgbClr val="1C2230"/>
+                </a:solidFill>
+                <a:latin typeface="Arial" pitchFamily="34" charset="0"/>
+                <a:ea typeface="Arial" pitchFamily="34" charset="-122"/>
+                <a:cs typeface="Arial" pitchFamily="34" charset="-120"/>
+              </a:rPr>
+              <a:t>8</a:t>
+            </a:r>
+            <a:endParaRPr lang="en-US" sz="1000" dirty="0"/>
+          </a:p>
+        </p:txBody>
+      </p:sp>
+      <p:sp>
+        <p:nvSpPr>
+          <p:cNvPr id="63" name="Shape 61"/>
+          <p:cNvSpPr/>
+          <p:nvPr/>
+        </p:nvSpPr>
+        <p:spPr>
+          <a:xfrm>
+            <a:off x="9090002" y="3728711"/>
+            <a:ext cx="2327269" cy="0"/>
+          </a:xfrm>
+          <a:prstGeom prst="line">
+            <a:avLst/>
+          </a:prstGeom>
+          <a:noFill/>
+          <a:ln w="9525">
+            <a:solidFill>
+              <a:srgbClr val="D8D2C4"/>
+            </a:solidFill>
+            <a:prstDash val="solid"/>
+          </a:ln>
+        </p:spPr>
+      </p:sp>
+      <p:sp>
+        <p:nvSpPr>
+          <p:cNvPr id="64" name="Text 62"/>
+          <p:cNvSpPr txBox="1"/>
+          <p:nvPr/>
+        </p:nvSpPr>
+        <p:spPr>
+          <a:xfrm>
+            <a:off x="9090002" y="3728711"/>
+            <a:ext cx="1730371" cy="350519"/>
+          </a:xfrm>
+          <a:prstGeom prst="rect">
+            <a:avLst/>
+          </a:prstGeom>
+          <a:noFill/>
+          <a:ln/>
+        </p:spPr>
+        <p:txBody>
+          <a:bodyPr wrap="square" lIns="0" tIns="0" rIns="0" bIns="0" rtlCol="0" anchor="ctr"/>
+          <a:lstStyle/>
+          <a:p>
+            <a:pPr indent="0" marL="0">
+              <a:buNone/>
+            </a:pPr>
+            <a:r>
+              <a:rPr lang="en-US" sz="800" dirty="0">
+                <a:solidFill>
+                  <a:srgbClr val="6F6A5C"/>
+                </a:solidFill>
+                <a:latin typeface="Arial" pitchFamily="34" charset="0"/>
+                <a:ea typeface="Arial" pitchFamily="34" charset="-122"/>
+                <a:cs typeface="Arial" pitchFamily="34" charset="-120"/>
+              </a:rPr>
+              <a:t>Contactpogingen</a:t>
+            </a:r>
+            <a:endParaRPr lang="en-US" sz="800" dirty="0"/>
+          </a:p>
+        </p:txBody>
+      </p:sp>
+      <p:sp>
+        <p:nvSpPr>
+          <p:cNvPr id="65" name="Text 63"/>
+          <p:cNvSpPr txBox="1"/>
+          <p:nvPr/>
+        </p:nvSpPr>
+        <p:spPr>
+          <a:xfrm>
+            <a:off x="10591774" y="3728711"/>
+            <a:ext cx="825498" cy="350519"/>
+          </a:xfrm>
+          <a:prstGeom prst="rect">
+            <a:avLst/>
+          </a:prstGeom>
+          <a:noFill/>
+          <a:ln/>
+        </p:spPr>
+        <p:txBody>
+          <a:bodyPr wrap="square" lIns="0" tIns="0" rIns="0" bIns="0" rtlCol="0" anchor="ctr"/>
+          <a:lstStyle/>
+          <a:p>
+            <a:pPr algn="r" indent="0" marL="0">
+              <a:buNone/>
+            </a:pPr>
+            <a:r>
+              <a:rPr lang="en-US" sz="1000" b="1" dirty="0">
+                <a:solidFill>
+                  <a:srgbClr val="1C2230"/>
+                </a:solidFill>
+                <a:latin typeface="Arial" pitchFamily="34" charset="0"/>
+                <a:ea typeface="Arial" pitchFamily="34" charset="-122"/>
+                <a:cs typeface="Arial" pitchFamily="34" charset="-120"/>
+              </a:rPr>
+              <a:t>1.200</a:t>
+            </a:r>
+            <a:endParaRPr lang="en-US" sz="1000" dirty="0"/>
+          </a:p>
+        </p:txBody>
+      </p:sp>
+      <p:sp>
+        <p:nvSpPr>
+          <p:cNvPr id="66" name="Shape 64"/>
+          <p:cNvSpPr/>
+          <p:nvPr/>
+        </p:nvSpPr>
+        <p:spPr>
+          <a:xfrm>
+            <a:off x="9090002" y="4079230"/>
+            <a:ext cx="2327269" cy="0"/>
+          </a:xfrm>
+          <a:prstGeom prst="line">
+            <a:avLst/>
+          </a:prstGeom>
+          <a:noFill/>
+          <a:ln w="9525">
+            <a:solidFill>
+              <a:srgbClr val="D8D2C4"/>
+            </a:solidFill>
+            <a:prstDash val="solid"/>
+          </a:ln>
+        </p:spPr>
+      </p:sp>
+      <p:sp>
+        <p:nvSpPr>
+          <p:cNvPr id="67" name="Text 65"/>
+          <p:cNvSpPr txBox="1"/>
+          <p:nvPr/>
+        </p:nvSpPr>
+        <p:spPr>
+          <a:xfrm>
+            <a:off x="9090002" y="4079230"/>
+            <a:ext cx="1730371" cy="350519"/>
+          </a:xfrm>
+          <a:prstGeom prst="rect">
+            <a:avLst/>
+          </a:prstGeom>
+          <a:noFill/>
+          <a:ln/>
+        </p:spPr>
+        <p:txBody>
+          <a:bodyPr wrap="square" lIns="0" tIns="0" rIns="0" bIns="0" rtlCol="0" anchor="ctr"/>
+          <a:lstStyle/>
+          <a:p>
+            <a:pPr indent="0" marL="0">
+              <a:buNone/>
+            </a:pPr>
+            <a:r>
+              <a:rPr lang="en-US" sz="800" dirty="0">
+                <a:solidFill>
+                  <a:srgbClr val="6F6A5C"/>
+                </a:solidFill>
+                <a:latin typeface="Arial" pitchFamily="34" charset="0"/>
+                <a:ea typeface="Arial" pitchFamily="34" charset="-122"/>
+                <a:cs typeface="Arial" pitchFamily="34" charset="-120"/>
+              </a:rPr>
+              <a:t>Afspraken</a:t>
+            </a:r>
+            <a:endParaRPr lang="en-US" sz="800" dirty="0"/>
+          </a:p>
+        </p:txBody>
+      </p:sp>
+      <p:sp>
+        <p:nvSpPr>
+          <p:cNvPr id="68" name="Text 66"/>
+          <p:cNvSpPr txBox="1"/>
+          <p:nvPr/>
+        </p:nvSpPr>
+        <p:spPr>
+          <a:xfrm>
+            <a:off x="10591774" y="4079230"/>
+            <a:ext cx="825498" cy="350519"/>
+          </a:xfrm>
+          <a:prstGeom prst="rect">
+            <a:avLst/>
+          </a:prstGeom>
+          <a:noFill/>
+          <a:ln/>
+        </p:spPr>
+        <p:txBody>
+          <a:bodyPr wrap="square" lIns="0" tIns="0" rIns="0" bIns="0" rtlCol="0" anchor="ctr"/>
+          <a:lstStyle/>
+          <a:p>
+            <a:pPr algn="r" indent="0" marL="0">
+              <a:buNone/>
+            </a:pPr>
+            <a:r>
+              <a:rPr lang="en-US" sz="1000" b="1" dirty="0">
+                <a:solidFill>
+                  <a:srgbClr val="1C2230"/>
+                </a:solidFill>
+                <a:latin typeface="Arial" pitchFamily="34" charset="0"/>
+                <a:ea typeface="Arial" pitchFamily="34" charset="-122"/>
+                <a:cs typeface="Arial" pitchFamily="34" charset="-120"/>
+              </a:rPr>
+              <a:t>20</a:t>
+            </a:r>
+            <a:endParaRPr lang="en-US" sz="1000" dirty="0"/>
+          </a:p>
+        </p:txBody>
+      </p:sp>
+      <p:sp>
+        <p:nvSpPr>
+          <p:cNvPr id="69" name="Shape 67"/>
+          <p:cNvSpPr/>
+          <p:nvPr/>
+        </p:nvSpPr>
+        <p:spPr>
+          <a:xfrm>
+            <a:off x="9090002" y="4429749"/>
+            <a:ext cx="2327269" cy="0"/>
+          </a:xfrm>
+          <a:prstGeom prst="line">
+            <a:avLst/>
+          </a:prstGeom>
+          <a:noFill/>
+          <a:ln w="9525">
+            <a:solidFill>
+              <a:srgbClr val="D8D2C4"/>
+            </a:solidFill>
+            <a:prstDash val="solid"/>
+          </a:ln>
+        </p:spPr>
+      </p:sp>
+      <p:sp>
+        <p:nvSpPr>
+          <p:cNvPr id="70" name="Text 68"/>
+          <p:cNvSpPr txBox="1"/>
+          <p:nvPr/>
+        </p:nvSpPr>
+        <p:spPr>
+          <a:xfrm>
+            <a:off x="9090002" y="4429749"/>
+            <a:ext cx="1730371" cy="350519"/>
+          </a:xfrm>
+          <a:prstGeom prst="rect">
+            <a:avLst/>
+          </a:prstGeom>
+          <a:noFill/>
+          <a:ln/>
+        </p:spPr>
+        <p:txBody>
+          <a:bodyPr wrap="square" lIns="0" tIns="0" rIns="0" bIns="0" rtlCol="0" anchor="ctr"/>
+          <a:lstStyle/>
+          <a:p>
+            <a:pPr indent="0" marL="0">
+              <a:buNone/>
+            </a:pPr>
+            <a:r>
+              <a:rPr lang="en-US" sz="800" dirty="0">
+                <a:solidFill>
+                  <a:srgbClr val="6F6A5C"/>
+                </a:solidFill>
+                <a:latin typeface="Arial" pitchFamily="34" charset="0"/>
+                <a:ea typeface="Arial" pitchFamily="34" charset="-122"/>
+                <a:cs typeface="Arial" pitchFamily="34" charset="-120"/>
+              </a:rPr>
+              <a:t>Per beldag</a:t>
+            </a:r>
+            <a:endParaRPr lang="en-US" sz="800" dirty="0"/>
+          </a:p>
+        </p:txBody>
+      </p:sp>
+      <p:sp>
+        <p:nvSpPr>
+          <p:cNvPr id="71" name="Text 69"/>
+          <p:cNvSpPr txBox="1"/>
+          <p:nvPr/>
+        </p:nvSpPr>
+        <p:spPr>
+          <a:xfrm>
+            <a:off x="10591774" y="4429749"/>
+            <a:ext cx="825498" cy="350519"/>
+          </a:xfrm>
+          <a:prstGeom prst="rect">
+            <a:avLst/>
+          </a:prstGeom>
+          <a:noFill/>
+          <a:ln/>
+        </p:spPr>
+        <p:txBody>
+          <a:bodyPr wrap="square" lIns="0" tIns="0" rIns="0" bIns="0" rtlCol="0" anchor="ctr"/>
+          <a:lstStyle/>
+          <a:p>
+            <a:pPr algn="r" indent="0" marL="0">
+              <a:buNone/>
+            </a:pPr>
+            <a:r>
+              <a:rPr lang="en-US" sz="1000" b="1" dirty="0">
+                <a:solidFill>
+                  <a:srgbClr val="1C2230"/>
+                </a:solidFill>
+                <a:latin typeface="Arial" pitchFamily="34" charset="0"/>
+                <a:ea typeface="Arial" pitchFamily="34" charset="-122"/>
+                <a:cs typeface="Arial" pitchFamily="34" charset="-120"/>
+              </a:rPr>
+              <a:t>€ 550</a:t>
+            </a:r>
+            <a:endParaRPr lang="en-US" sz="1000" dirty="0"/>
+          </a:p>
+        </p:txBody>
+      </p:sp>
+      <p:sp>
+        <p:nvSpPr>
+          <p:cNvPr id="72" name="Shape 70"/>
+          <p:cNvSpPr/>
+          <p:nvPr/>
+        </p:nvSpPr>
+        <p:spPr>
+          <a:xfrm>
+            <a:off x="9090002" y="4780268"/>
+            <a:ext cx="2327269" cy="0"/>
+          </a:xfrm>
+          <a:prstGeom prst="line">
+            <a:avLst/>
+          </a:prstGeom>
+          <a:noFill/>
+          <a:ln w="9525">
+            <a:solidFill>
+              <a:srgbClr val="D8D2C4"/>
+            </a:solidFill>
+            <a:prstDash val="solid"/>
+          </a:ln>
+        </p:spPr>
+      </p:sp>
+      <p:sp>
+        <p:nvSpPr>
+          <p:cNvPr id="73" name="Text 71"/>
+          <p:cNvSpPr txBox="1"/>
+          <p:nvPr/>
+        </p:nvSpPr>
+        <p:spPr>
+          <a:xfrm>
+            <a:off x="9090002" y="4780268"/>
+            <a:ext cx="1730371" cy="350519"/>
+          </a:xfrm>
+          <a:prstGeom prst="rect">
+            <a:avLst/>
+          </a:prstGeom>
+          <a:noFill/>
+          <a:ln/>
+        </p:spPr>
+        <p:txBody>
+          <a:bodyPr wrap="square" lIns="0" tIns="0" rIns="0" bIns="0" rtlCol="0" anchor="ctr"/>
+          <a:lstStyle/>
+          <a:p>
+            <a:pPr indent="0" marL="0">
+              <a:buNone/>
+            </a:pPr>
+            <a:r>
+              <a:rPr lang="en-US" sz="800" dirty="0">
+                <a:solidFill>
+                  <a:srgbClr val="6F6A5C"/>
+                </a:solidFill>
+                <a:latin typeface="Arial" pitchFamily="34" charset="0"/>
+                <a:ea typeface="Arial" pitchFamily="34" charset="-122"/>
+                <a:cs typeface="Arial" pitchFamily="34" charset="-120"/>
+              </a:rPr>
+              <a:t>Per werkperiode</a:t>
+            </a:r>
+            <a:endParaRPr lang="en-US" sz="800" dirty="0"/>
+          </a:p>
+        </p:txBody>
+      </p:sp>
+      <p:sp>
+        <p:nvSpPr>
+          <p:cNvPr id="74" name="Text 72"/>
+          <p:cNvSpPr txBox="1"/>
+          <p:nvPr/>
+        </p:nvSpPr>
+        <p:spPr>
+          <a:xfrm>
+            <a:off x="10591774" y="4780268"/>
+            <a:ext cx="825498" cy="350519"/>
+          </a:xfrm>
+          <a:prstGeom prst="rect">
+            <a:avLst/>
+          </a:prstGeom>
+          <a:noFill/>
+          <a:ln/>
+        </p:spPr>
+        <p:txBody>
+          <a:bodyPr wrap="square" lIns="0" tIns="0" rIns="0" bIns="0" rtlCol="0" anchor="ctr"/>
+          <a:lstStyle/>
+          <a:p>
+            <a:pPr algn="r" indent="0" marL="0">
+              <a:buNone/>
+            </a:pPr>
+            <a:r>
+              <a:rPr lang="en-US" sz="1000" b="1" dirty="0">
+                <a:solidFill>
+                  <a:srgbClr val="1C2230"/>
+                </a:solidFill>
+                <a:latin typeface="Arial" pitchFamily="34" charset="0"/>
+                <a:ea typeface="Arial" pitchFamily="34" charset="-122"/>
+                <a:cs typeface="Arial" pitchFamily="34" charset="-120"/>
+              </a:rPr>
               <a:t>€ 4.400</a:t>
             </a:r>
-            <a:endParaRPr lang="en-US" sz="1150" dirty="0"/>
-          </a:p>
-        </p:txBody>
-      </p:sp>
-      <p:sp>
-        <p:nvSpPr>
-          <p:cNvPr id="58" name="Shape 56"/>
+            <a:endParaRPr lang="en-US" sz="1000" dirty="0"/>
+          </a:p>
+        </p:txBody>
+      </p:sp>
+      <p:sp>
+        <p:nvSpPr>
+          <p:cNvPr id="75" name="Shape 73"/>
           <p:cNvSpPr/>
           <p:nvPr/>
         </p:nvSpPr>
@@ -7762,7 +8347,7 @@
       </p:sp>
       <p:sp>
         <p:nvSpPr>
-          <p:cNvPr id="59" name="Text 57"/>
+          <p:cNvPr id="76" name="Text 74"/>
           <p:cNvSpPr txBox="1"/>
           <p:nvPr/>
         </p:nvSpPr>
@@ -7793,7 +8378,7 @@
                 <a:ea typeface="Arial" pitchFamily="34" charset="-122"/>
                 <a:cs typeface="Arial" pitchFamily="34" charset="-120"/>
               </a:rPr>
-              <a:t>De dagprijs blijft gelijk aan wat je nu per beldag betaalt. Neem je het dubbele af, dan zakt die naar 550 euro per beldag en betaal je 220 euro per afspraak in plaats van 240.</a:t>
+              <a:t>De dagprijs blijft gelijk aan wat je nu per beldag betaalt. Neem je er meer af, dan zakt die naar 575 of 550 euro per beldag.</a:t>
             </a:r>
             <a:endParaRPr lang="en-US" sz="1200" dirty="0"/>
           </a:p>
@@ -17933,7 +18518,7 @@
                 <a:ea typeface="Arial" pitchFamily="34" charset="-122"/>
                 <a:cs typeface="Arial" pitchFamily="34" charset="-120"/>
               </a:rPr>
-              <a:t>PER 8 BELDAGEN</a:t>
+              <a:t>PER 6 BELDAGEN</a:t>
             </a:r>
             <a:endParaRPr lang="en-US" sz="800" dirty="0"/>
           </a:p>
@@ -18126,7 +18711,7 @@
                 <a:ea typeface="Arial" pitchFamily="34" charset="-122"/>
                 <a:cs typeface="Arial" pitchFamily="34" charset="-120"/>
               </a:rPr>
-              <a:t>1.200</a:t>
+              <a:t>900</a:t>
             </a:r>
             <a:endParaRPr lang="en-US" sz="1250" dirty="0"/>
           </a:p>
@@ -18319,7 +18904,7 @@
                 <a:ea typeface="Arial" pitchFamily="34" charset="-122"/>
                 <a:cs typeface="Arial" pitchFamily="34" charset="-120"/>
               </a:rPr>
-              <a:t>± 720</a:t>
+              <a:t>± 540</a:t>
             </a:r>
             <a:endParaRPr lang="en-US" sz="1250" dirty="0"/>
           </a:p>
@@ -18534,7 +19119,7 @@
                 <a:ea typeface="Arial" pitchFamily="34" charset="-122"/>
                 <a:cs typeface="Arial" pitchFamily="34" charset="-120"/>
               </a:rPr>
-              <a:t>20</a:t>
+              <a:t>15</a:t>
             </a:r>
             <a:endParaRPr lang="en-US" sz="1250" dirty="0"/>
           </a:p>
@@ -18593,7 +19178,7 @@
                 <a:ea typeface="Arial" pitchFamily="34" charset="-122"/>
                 <a:cs typeface="Arial" pitchFamily="34" charset="-120"/>
               </a:rPr>
-              <a:t>De zes uur bellen maken we altijd vol, dus die honderdvijftig pogingen staan. Garanderen doen we alleen de tien afspraken, en halen we die niet, dan krijgen jullie een beldag cadeau.</a:t>
+              <a:t>De honderdvijftig pogingen per beldag staan vast. Hoeveel bedrijven we spreken hangt af van de bereikbaarheid. Garanderen doen we alleen de tien afspraken, en halen we die niet, dan krijgen jullie een beldag cadeau.</a:t>
             </a:r>
             <a:endParaRPr lang="en-US" sz="1200" dirty="0"/>
           </a:p>

</xml_diff>

<commit_message>
GrowOn: succesfee van 5 procent terug in het voorstel
Co-Authored-By: Claude Opus 5 <noreply@anthropic.com>
Claude-Session: https://claude.ai/code/session_0141FN3f3hHkYQHTyvTJJGrw
</commit_message>
<xml_diff>
--- a/output/LINK. voorstel GrowOn Agency.pptx
+++ b/output/LINK. voorstel GrowOn Agency.pptx
@@ -4643,7 +4643,7 @@
                 <a:ea typeface="Arial" pitchFamily="34" charset="-122"/>
                 <a:cs typeface="Arial" pitchFamily="34" charset="-120"/>
               </a:rPr>
-              <a:t>Je betaalt per beldag, vooraf gefactureerd per werkperiode. Geen nacalculatie, geen kosten per afspraak en geen succesfee meer.</a:t>
+              <a:t>Je betaalt per beldag, vooraf gefactureerd per werkperiode. Geen nacalculatie en geen kosten per afspraak.</a:t>
             </a:r>
             <a:endParaRPr lang="en-US" sz="875" dirty="0"/>
           </a:p>
@@ -5117,7 +5117,7 @@
                 <a:ea typeface="Arial" pitchFamily="34" charset="-122"/>
                 <a:cs typeface="Arial" pitchFamily="34" charset="-120"/>
               </a:rPr>
-              <a:t>Elke periode opnieuw kiezen</a:t>
+              <a:t>Succesfee van 5 procent</a:t>
             </a:r>
             <a:endParaRPr lang="en-US" sz="1150" dirty="0"/>
           </a:p>
@@ -5159,7 +5159,7 @@
                 <a:ea typeface="Arial" pitchFamily="34" charset="-122"/>
                 <a:cs typeface="Arial" pitchFamily="34" charset="-120"/>
               </a:rPr>
-              <a:t>Jullie bepalen per werkperiode het aantal beldagen, vanaf vier. Een maand opzegtermijn, geen jaarcontract en geen opstartkosten meer.</a:t>
+              <a:t>Over de omzet die een klant uit onze afspraken jullie in het eerste jaar oplevert. Zo blijven wij sturen op afspraken die ook echt klant worden, niet op aantallen.</a:t>
             </a:r>
             <a:endParaRPr lang="en-US" sz="875" dirty="0"/>
           </a:p>
@@ -5701,7 +5701,7 @@
                 <a:ea typeface="Arial" pitchFamily="34" charset="-122"/>
                 <a:cs typeface="Arial" pitchFamily="34" charset="-120"/>
               </a:rPr>
-              <a:t>Prijs staat vast tot en met 2027</a:t>
+              <a:t>Succesfee van 5% blijft ongewijzigd</a:t>
             </a:r>
             <a:endParaRPr lang="en-US" sz="900" dirty="0"/>
           </a:p>
@@ -10342,7 +10342,7 @@
                 <a:ea typeface="Arial" pitchFamily="34" charset="-122"/>
                 <a:cs typeface="Arial" pitchFamily="34" charset="-120"/>
               </a:rPr>
-              <a:t>Prijs vast tot en met 2027</a:t>
+              <a:t>Succesfee van 5 procent</a:t>
             </a:r>
             <a:endParaRPr lang="en-US" sz="1200" dirty="0"/>
           </a:p>
@@ -10384,7 +10384,7 @@
                 <a:ea typeface="Arial" pitchFamily="34" charset="-122"/>
                 <a:cs typeface="Arial" pitchFamily="34" charset="-120"/>
               </a:rPr>
-              <a:t>De dagprijs en de staffel blijven ongewijzigd. Geen jaarlijkse indexatie.</a:t>
+              <a:t>Ongewijzigd ten opzichte van nu. Over het eerste jaar omzet uit een klant die uit onze afspraken komt.</a:t>
             </a:r>
             <a:endParaRPr lang="en-US" sz="950" dirty="0"/>
           </a:p>

</xml_diff>

<commit_message>
GrowOn: tien afspraken is de belofte, zeshonderd pogingen de ondergrens
Maximaal een gratis inhaaldag per werkperiode. Komen de afspraken eerder
binnen, dan gaat de resterende tijd naar lijst en terugbelafspraken.

Co-Authored-By: Claude Opus 5 <noreply@anthropic.com>
Claude-Session: https://claude.ai/code/session_0141FN3f3hHkYQHTyvTJJGrw
</commit_message>
<xml_diff>
--- a/output/LINK. voorstel GrowOn Agency.pptx
+++ b/output/LINK. voorstel GrowOn Agency.pptx
@@ -4987,7 +4987,7 @@
                 <a:ea typeface="Arial" pitchFamily="34" charset="-122"/>
                 <a:cs typeface="Arial" pitchFamily="34" charset="-120"/>
               </a:rPr>
-              <a:t>Komt een werkperiode onder de tien afspraken, dan bellen we de volgende periode een dag extra die niet op de rekening komt.</a:t>
+              <a:t>Staan de tien afspraken er na zeshonderd pogingen niet, dan bellen we een dag extra die niet op de rekening komt. Maximaal een per werkperiode.</a:t>
             </a:r>
             <a:endParaRPr lang="en-US" sz="875" dirty="0"/>
           </a:p>
@@ -5638,7 +5638,7 @@
                 <a:ea typeface="Arial" pitchFamily="34" charset="-122"/>
                 <a:cs typeface="Arial" pitchFamily="34" charset="-120"/>
               </a:rPr>
-              <a:t>Niet gehaald is een gratis beldag</a:t>
+              <a:t>Maximaal één gratis inhaaldag</a:t>
             </a:r>
             <a:endParaRPr lang="en-US" sz="900" dirty="0"/>
           </a:p>
@@ -9934,7 +9934,7 @@
                 <a:ea typeface="Arial" pitchFamily="34" charset="-122"/>
                 <a:cs typeface="Arial" pitchFamily="34" charset="-120"/>
               </a:rPr>
-              <a:t>Onder de tien afspraken in een werkperiode, dan bellen we de volgende periode een dag extra zonder factuur.</a:t>
+              <a:t>Maximaal een per werkperiode. Halen we het dan nog niet, dan gaan we om tafel over lijst, script of kwalificatie.</a:t>
             </a:r>
             <a:endParaRPr lang="en-US" sz="950" dirty="0"/>
           </a:p>
@@ -18304,7 +18304,7 @@
                 <a:ea typeface="Arial" pitchFamily="34" charset="-122"/>
                 <a:cs typeface="Arial" pitchFamily="34" charset="-120"/>
               </a:rPr>
-              <a:t>Eén belofte: </a:t>
+              <a:t>Tien afspraken per werkperiode, </a:t>
             </a:r>
             <a:pPr algn="l" indent="0" marL="0">
               <a:lnSpc>
@@ -18321,7 +18321,7 @@
                 <a:ea typeface="Georgia" pitchFamily="34" charset="-122"/>
                 <a:cs typeface="Georgia" pitchFamily="34" charset="-120"/>
               </a:rPr>
-              <a:t>tien afspraken</a:t>
+              <a:t>hoe dan ook</a:t>
             </a:r>
             <a:pPr algn="l" indent="0" marL="0">
               <a:lnSpc>
@@ -18338,7 +18338,7 @@
                 <a:ea typeface="Arial" pitchFamily="34" charset="-122"/>
                 <a:cs typeface="Arial" pitchFamily="34" charset="-120"/>
               </a:rPr>
-              <a:t> per werkperiode.</a:t>
+              <a:t>.</a:t>
             </a:r>
             <a:endParaRPr lang="en-US" sz="3200" dirty="0"/>
           </a:p>
@@ -18594,7 +18594,7 @@
                 <a:ea typeface="Georgia" pitchFamily="34" charset="-122"/>
                 <a:cs typeface="Georgia" pitchFamily="34" charset="-120"/>
               </a:rPr>
-              <a:t>   vast</a:t>
+              <a:t>   ondergrens</a:t>
             </a:r>
             <a:endParaRPr lang="en-US" sz="1250" dirty="0"/>
           </a:p>
@@ -19178,7 +19178,7 @@
                 <a:ea typeface="Arial" pitchFamily="34" charset="-122"/>
                 <a:cs typeface="Arial" pitchFamily="34" charset="-120"/>
               </a:rPr>
-              <a:t>De honderdvijftig pogingen per beldag staan vast. Hoeveel bedrijven we spreken hangt af van de bereikbaarheid. Garanderen doen we alleen de tien afspraken, en halen we die niet, dan krijgen jullie een beldag cadeau.</a:t>
+              <a:t>Staan de tien afspraken er eerder, dan gebruiken we de resterende tijd voor de bellijst en de terugbelafspraken van de volgende periode. Staan ze er na zeshonderd pogingen niet, dan bellen we een extra dag die niet op de rekening komt.</a:t>
             </a:r>
             <a:endParaRPr lang="en-US" sz="1200" dirty="0"/>
           </a:p>

</xml_diff>

<commit_message>
GrowOn: alles vanuit het voordeel van de klant geschreven
Cover, model, vergelijking en spelregels herschreven zodat elk punt leest als
wat GrowOn erbij krijgt: twee afspraken meer, dezelfde dagprijs, een gratis
beldag bij achterstand, prijs vast tot en met 2027.

Co-Authored-By: Claude Opus 5 <noreply@anthropic.com>
Claude-Session: https://claude.ai/code/session_0141FN3f3hHkYQHTyvTJJGrw
</commit_message>
<xml_diff>
--- a/output/LINK. voorstel GrowOn Agency.pptx
+++ b/output/LINK. voorstel GrowOn Agency.pptx
@@ -2786,7 +2786,7 @@
                 <a:ea typeface="Arial" pitchFamily="34" charset="-122"/>
                 <a:cs typeface="Arial" pitchFamily="34" charset="-120"/>
               </a:rPr>
-              <a:t>Er verandert weinig. Zelfde team, zelfde bellijst en dezelfde wekelijkse rapportage. Vanaf werkperiode 4 rekenen we in beldagen, met harde aantallen en een scherpere afspraak over wat een afspraak is.</a:t>
+              <a:t>Er verandert weinig. Zelfde team, zelfde bellijst en dezelfde prijs per beldag. Wat erbij komt: twee afspraken meer per periode, vaste aantallen op papier en een gratis beldag als we die niet halen.</a:t>
             </a:r>
             <a:endParaRPr lang="en-US" sz="1400" dirty="0"/>
           </a:p>
@@ -3141,7 +3141,7 @@
                 <a:ea typeface="Arial" pitchFamily="34" charset="-122"/>
                 <a:cs typeface="Arial" pitchFamily="34" charset="-120"/>
               </a:rPr>
-              <a:t>WAT ER VERANDERT</a:t>
+              <a:t>WAT HET JE OPLEVERT</a:t>
             </a:r>
             <a:endParaRPr lang="en-US" sz="950" dirty="0"/>
           </a:p>
@@ -3183,7 +3183,7 @@
                 <a:ea typeface="Arial" pitchFamily="34" charset="-122"/>
                 <a:cs typeface="Arial" pitchFamily="34" charset="-120"/>
               </a:rPr>
-              <a:t>Hetzelfde werk, nu met </a:t>
+              <a:t>Meer afspraken, </a:t>
             </a:r>
             <a:pPr algn="l" indent="0" marL="0">
               <a:lnSpc>
@@ -3200,7 +3200,7 @@
                 <a:ea typeface="Georgia" pitchFamily="34" charset="-122"/>
                 <a:cs typeface="Georgia" pitchFamily="34" charset="-120"/>
               </a:rPr>
-              <a:t>harde aantallen</a:t>
+              <a:t>dezelfde dagprijs</a:t>
             </a:r>
             <a:pPr algn="l" indent="0" marL="0">
               <a:lnSpc>
@@ -5616,7 +5616,7 @@
                 <a:ea typeface="Arial" pitchFamily="34" charset="-122"/>
                 <a:cs typeface="Arial" pitchFamily="34" charset="-120"/>
               </a:rPr>
-              <a:t>De dagprijs blijft gelijk aan wat je nu per beldag betaalt. Neem je er meer af, dan zakt die naar 575 of 550 euro per beldag.</a:t>
+              <a:t>Je betaalt per beldag wat je nu al betaalt. Wat erbij komt: twee afspraken meer, vaste aantallen op papier en een gratis beldag als we ze niet halen.</a:t>
             </a:r>
             <a:endParaRPr lang="en-US" sz="1200" dirty="0"/>
           </a:p>
@@ -6853,7 +6853,7 @@
                 <a:ea typeface="Arial" pitchFamily="34" charset="-122"/>
                 <a:cs typeface="Arial" pitchFamily="34" charset="-120"/>
               </a:rPr>
-              <a:t>Werkperiodes van 4 weken</a:t>
+              <a:t>Tien afspraken per werkperiode</a:t>
             </a:r>
             <a:endParaRPr lang="en-US" sz="1200" dirty="0"/>
           </a:p>
@@ -6895,7 +6895,7 @@
                 <a:ea typeface="Arial" pitchFamily="34" charset="-122"/>
                 <a:cs typeface="Arial" pitchFamily="34" charset="-120"/>
               </a:rPr>
-              <a:t>Vooraf gefactureerd, per werkperiode. Geen nacalculatie achteraf.</a:t>
+              <a:t>Vastgelegd. Halen we ze niet, dan krijg je een extra beldag van ons.</a:t>
             </a:r>
             <a:endParaRPr lang="en-US" sz="950" dirty="0"/>
           </a:p>
@@ -6980,7 +6980,7 @@
                 <a:ea typeface="Arial" pitchFamily="34" charset="-122"/>
                 <a:cs typeface="Arial" pitchFamily="34" charset="-120"/>
               </a:rPr>
-              <a:t>Tien afspraken per werkperiode</a:t>
+              <a:t>Prijs vast tot en met 2027</a:t>
             </a:r>
             <a:endParaRPr lang="en-US" sz="1200" dirty="0"/>
           </a:p>
@@ -7022,7 +7022,7 @@
                 <a:ea typeface="Arial" pitchFamily="34" charset="-122"/>
                 <a:cs typeface="Arial" pitchFamily="34" charset="-120"/>
               </a:rPr>
-              <a:t>Dat is wat we garanderen bij vier beldagen. Alles eromheen laten we zien in de wekelijkse rapportage.</a:t>
+              <a:t>De dagprijs en de staffel blijven ongewijzigd. Geen jaarlijkse indexatie.</a:t>
             </a:r>
             <a:endParaRPr lang="en-US" sz="950" dirty="0"/>
           </a:p>
@@ -7130,7 +7130,7 @@
                 <a:ea typeface="Arial" pitchFamily="34" charset="-122"/>
                 <a:cs typeface="Arial" pitchFamily="34" charset="-120"/>
               </a:rPr>
-              <a:t>Niet gehaald is een gratis beldag</a:t>
+              <a:t>Geen opstartkosten meer</a:t>
             </a:r>
             <a:endParaRPr lang="en-US" sz="1200" dirty="0"/>
           </a:p>
@@ -7172,7 +7172,7 @@
                 <a:ea typeface="Arial" pitchFamily="34" charset="-122"/>
                 <a:cs typeface="Arial" pitchFamily="34" charset="-120"/>
               </a:rPr>
-              <a:t>Maximaal een per werkperiode. Halen we het dan nog niet, dan gaan we om tafel over lijst, script of kwalificatie.</a:t>
+              <a:t>De inrichting staat. Die fee is eenmalig geweest.</a:t>
             </a:r>
             <a:endParaRPr lang="en-US" sz="950" dirty="0"/>
           </a:p>
@@ -7280,7 +7280,7 @@
                 <a:ea typeface="Arial" pitchFamily="34" charset="-122"/>
                 <a:cs typeface="Arial" pitchFamily="34" charset="-120"/>
               </a:rPr>
-              <a:t>Kwalificatie-eisen samen vastgesteld</a:t>
+              <a:t>Maand opzegtermijn</a:t>
             </a:r>
             <a:endParaRPr lang="en-US" sz="1200" dirty="0"/>
           </a:p>
@@ -7322,7 +7322,7 @@
                 <a:ea typeface="Arial" pitchFamily="34" charset="-122"/>
                 <a:cs typeface="Arial" pitchFamily="34" charset="-120"/>
               </a:rPr>
-              <a:t>Bij de start van werkperiode 4 leggen we samen vast wanneer een afspraak meetelt.</a:t>
+              <a:t>Geen jaarcontract. Jullie zitten nergens aan vast.</a:t>
             </a:r>
             <a:endParaRPr lang="en-US" sz="950" dirty="0"/>
           </a:p>
@@ -7430,7 +7430,7 @@
                 <a:ea typeface="Arial" pitchFamily="34" charset="-122"/>
                 <a:cs typeface="Arial" pitchFamily="34" charset="-120"/>
               </a:rPr>
-              <a:t>Op- en afschalen</a:t>
+              <a:t>Op- en afschalen per periode</a:t>
             </a:r>
             <a:endParaRPr lang="en-US" sz="1200" dirty="0"/>
           </a:p>
@@ -7472,7 +7472,7 @@
                 <a:ea typeface="Arial" pitchFamily="34" charset="-122"/>
                 <a:cs typeface="Arial" pitchFamily="34" charset="-120"/>
               </a:rPr>
-              <a:t>Per werkperiode bepalen jullie het aantal beldagen, vanaf vier.</a:t>
+              <a:t>Jullie bepalen het aantal beldagen, vanaf vier.</a:t>
             </a:r>
             <a:endParaRPr lang="en-US" sz="950" dirty="0"/>
           </a:p>
@@ -7580,7 +7580,7 @@
                 <a:ea typeface="Arial" pitchFamily="34" charset="-122"/>
                 <a:cs typeface="Arial" pitchFamily="34" charset="-120"/>
               </a:rPr>
-              <a:t>Succesfee van 5 procent</a:t>
+              <a:t>Kwalificatie samen vastgesteld</a:t>
             </a:r>
             <a:endParaRPr lang="en-US" sz="1200" dirty="0"/>
           </a:p>
@@ -7622,7 +7622,7 @@
                 <a:ea typeface="Arial" pitchFamily="34" charset="-122"/>
                 <a:cs typeface="Arial" pitchFamily="34" charset="-120"/>
               </a:rPr>
-              <a:t>Ongewijzigd ten opzichte van nu. Over het eerste jaar omzet uit een klant die uit onze afspraken komt.</a:t>
+              <a:t>Bij de start van werkperiode 4 leggen we samen vast wanneer een afspraak meetelt.</a:t>
             </a:r>
             <a:endParaRPr lang="en-US" sz="950" dirty="0"/>
           </a:p>
@@ -7730,7 +7730,7 @@
                 <a:ea typeface="Arial" pitchFamily="34" charset="-122"/>
                 <a:cs typeface="Arial" pitchFamily="34" charset="-120"/>
               </a:rPr>
-              <a:t>Maand opzegtermijn</a:t>
+              <a:t>Succesfee van 5 procent</a:t>
             </a:r>
             <a:endParaRPr lang="en-US" sz="1200" dirty="0"/>
           </a:p>
@@ -7772,7 +7772,7 @@
                 <a:ea typeface="Arial" pitchFamily="34" charset="-122"/>
                 <a:cs typeface="Arial" pitchFamily="34" charset="-120"/>
               </a:rPr>
-              <a:t>Geen jaarcontract en geen opstartkosten meer.</a:t>
+              <a:t>Ongewijzigd. Wij verdienen pas echt als een afspraak klant wordt.</a:t>
             </a:r>
             <a:endParaRPr lang="en-US" sz="950" dirty="0"/>
           </a:p>
@@ -15298,7 +15298,7 @@
                 <a:ea typeface="Arial" pitchFamily="34" charset="-122"/>
                 <a:cs typeface="Arial" pitchFamily="34" charset="-120"/>
               </a:rPr>
-              <a:t>Komt een werkperiode onder de tien afspraken uit, dan bellen we een extra dag die niet op de rekening komt. Maximaal een per periode.</a:t>
+              <a:t>Halen we de tien afspraken in een werkperiode niet, dan bellen we een extra dag die niet op de rekening komt. Een mindere periode kost jullie dus niets extra.</a:t>
             </a:r>
             <a:endParaRPr lang="en-US" sz="1200" dirty="0"/>
           </a:p>
@@ -15500,7 +15500,7 @@
                 <a:ea typeface="Arial" pitchFamily="34" charset="-122"/>
                 <a:cs typeface="Arial" pitchFamily="34" charset="-120"/>
               </a:rPr>
-              <a:t>HOE WE AFREKENEN</a:t>
+              <a:t>WAT JE ERVOOR TERUGKRIJGT</a:t>
             </a:r>
             <a:endParaRPr lang="en-US" sz="950" dirty="0"/>
           </a:p>
@@ -15748,7 +15748,7 @@
                 <a:ea typeface="Arial" pitchFamily="34" charset="-122"/>
                 <a:cs typeface="Arial" pitchFamily="34" charset="-120"/>
               </a:rPr>
-              <a:t>Je betaalt per beldag, vooraf gefactureerd per werkperiode. Geen nacalculatie en geen kosten per afspraak.</a:t>
+              <a:t>Je weet vooraf precies wat een werkperiode kost. Geen nacalculatie, geen kosten per afspraak en geen rekening achteraf.</a:t>
             </a:r>
             <a:endParaRPr lang="en-US" sz="875" dirty="0"/>
           </a:p>
@@ -15920,7 +15920,7 @@
                 <a:ea typeface="Arial" pitchFamily="34" charset="-122"/>
                 <a:cs typeface="Arial" pitchFamily="34" charset="-120"/>
               </a:rPr>
-              <a:t>Dat is de afspraak waar je ons aan mag houden. Het aantal pogingen en gesprekken laten we zien in de rapportage, maar de tien afspraken zijn wat we garanderen.</a:t>
+              <a:t>Twee meer dan je nu krijgt, voor dezelfde prijs per beldag. Dat is het getal waar je ons aan mag houden.</a:t>
             </a:r>
             <a:endParaRPr lang="en-US" sz="875" dirty="0"/>
           </a:p>
@@ -16092,7 +16092,7 @@
                 <a:ea typeface="Arial" pitchFamily="34" charset="-122"/>
                 <a:cs typeface="Arial" pitchFamily="34" charset="-120"/>
               </a:rPr>
-              <a:t>Staan de tien afspraken er na zeshonderd pogingen niet, dan bellen we een dag extra die niet op de rekening komt. Maximaal een per werkperiode.</a:t>
+              <a:t>Halen we de tien niet, dan bellen we een dag extra op onze kosten. Het risico van een mindere periode ligt bij ons.</a:t>
             </a:r>
             <a:endParaRPr lang="en-US" sz="875" dirty="0"/>
           </a:p>
@@ -16264,7 +16264,7 @@
                 <a:ea typeface="Arial" pitchFamily="34" charset="-122"/>
                 <a:cs typeface="Arial" pitchFamily="34" charset="-120"/>
               </a:rPr>
-              <a:t>Over de omzet die een klant uit onze afspraken jullie in het eerste jaar oplevert. Zo blijven wij sturen op afspraken die ook echt klant worden, niet op aantallen.</a:t>
+              <a:t>Ongewijzigd ten opzichte van nu. Wij verdienen pas echt als een afspraak klant wordt, dus sturen we op kwaliteit en niet op aantallen.</a:t>
             </a:r>
             <a:endParaRPr lang="en-US" sz="875" dirty="0"/>
           </a:p>

</xml_diff>